<commit_message>
Add NUG Weedmaps management pitch deck
Prospect file and generated deck for NUG (7 California listings + brand page),
scoped to Weedmaps management with $995/mo base or 10% of ad spend above
$9,995/mo. Generator now adapts cover and solution copy to the platforms in
scope, supports a free-text business type label, shows location count when
competitor count is unknown, and fixes pricing-column overlap.

Co-Authored-By: Claude Fable 5.1 <noreply@anthropic.com>
Claude-Session: https://claude.ai/code/session_01RhvxWoxVegp3rGjZ4khBZo
</commit_message>
<xml_diff>
--- a/decks/Sparks-x-example-green-valley.pptx
+++ b/decks/Sparks-x-example-green-valley.pptx
@@ -8142,7 +8142,7 @@
         <p:spPr>
           <a:xfrm>
             <a:off x="7909560" y="2697480"/>
-            <a:ext cx="1858975" cy="329184"/>
+            <a:ext cx="1036015" cy="329184"/>
           </a:xfrm>
           <a:prstGeom prst="rect">
             <a:avLst/>
@@ -8180,8 +8180,8 @@
         </p:nvSpPr>
         <p:spPr>
           <a:xfrm>
-            <a:off x="9768535" y="2697480"/>
-            <a:ext cx="1554480" cy="329184"/>
+            <a:off x="8854135" y="2697480"/>
+            <a:ext cx="2468880" cy="329184"/>
           </a:xfrm>
           <a:prstGeom prst="rect">
             <a:avLst/>
@@ -8259,7 +8259,7 @@
         <p:spPr>
           <a:xfrm>
             <a:off x="7909560" y="3429000"/>
-            <a:ext cx="1858975" cy="329184"/>
+            <a:ext cx="1036015" cy="329184"/>
           </a:xfrm>
           <a:prstGeom prst="rect">
             <a:avLst/>
@@ -8297,8 +8297,8 @@
         </p:nvSpPr>
         <p:spPr>
           <a:xfrm>
-            <a:off x="9768535" y="3429000"/>
-            <a:ext cx="1554480" cy="329184"/>
+            <a:off x="8854135" y="3429000"/>
+            <a:ext cx="2468880" cy="329184"/>
           </a:xfrm>
           <a:prstGeom prst="rect">
             <a:avLst/>
@@ -8376,7 +8376,7 @@
         <p:spPr>
           <a:xfrm>
             <a:off x="7909560" y="4160520"/>
-            <a:ext cx="1858975" cy="329184"/>
+            <a:ext cx="1036015" cy="329184"/>
           </a:xfrm>
           <a:prstGeom prst="rect">
             <a:avLst/>
@@ -8414,8 +8414,8 @@
         </p:nvSpPr>
         <p:spPr>
           <a:xfrm>
-            <a:off x="9768535" y="4160520"/>
-            <a:ext cx="1554480" cy="329184"/>
+            <a:off x="8854135" y="4160520"/>
+            <a:ext cx="2468880" cy="329184"/>
           </a:xfrm>
           <a:prstGeom prst="rect">
             <a:avLst/>
@@ -9653,7 +9653,7 @@
         <p:spPr>
           <a:xfrm>
             <a:off x="4556455" y="5486400"/>
-            <a:ext cx="1600200" cy="457200"/>
+            <a:ext cx="1600200" cy="274320"/>
           </a:xfrm>
           <a:prstGeom prst="rect">
             <a:avLst/>
@@ -9743,7 +9743,7 @@
         <p:spPr>
           <a:xfrm>
             <a:off x="6385255" y="5486400"/>
-            <a:ext cx="1600200" cy="457200"/>
+            <a:ext cx="1600200" cy="274320"/>
           </a:xfrm>
           <a:prstGeom prst="rect">
             <a:avLst/>
@@ -9833,7 +9833,7 @@
         <p:spPr>
           <a:xfrm>
             <a:off x="8214055" y="5486400"/>
-            <a:ext cx="1600200" cy="457200"/>
+            <a:ext cx="1600200" cy="274320"/>
           </a:xfrm>
           <a:prstGeom prst="rect">
             <a:avLst/>
@@ -9923,7 +9923,7 @@
         <p:spPr>
           <a:xfrm>
             <a:off x="10042855" y="5486400"/>
-            <a:ext cx="1600200" cy="457200"/>
+            <a:ext cx="1600200" cy="274320"/>
           </a:xfrm>
           <a:prstGeom prst="rect">
             <a:avLst/>
@@ -11151,9 +11151,9 @@
             <a:tbl>
               <a:tblPr/>
               <a:tblGrid>
-                <a:gridCol w="1828800"/>
-                <a:gridCol w="4846320"/>
-                <a:gridCol w="4416552"/>
+                <a:gridCol w="2286000"/>
+                <a:gridCol w="4572000"/>
+                <a:gridCol w="4233672"/>
               </a:tblGrid>
               <a:tr h="548640">
                 <a:tc>

</xml_diff>

<commit_message>
Bundle add-on pricing, package total, and free 30-day trial
- investment.addon prices Leafly + Yelp + Google as one $495/mo bundle
  (10% of ad spend above $4,950/mo on any platform); investment.total shows
  the $1,490/mo package on the investment and next-steps slides
- investment.trial adds a free 30-day trial line to the cover, investment
  and next-steps slides; NUG deck uses it (no invoice until day 31)
- Investment card prices scale to fit; summary labels no longer wrap

Co-Authored-By: Claude Fable 5.1 <noreply@anthropic.com>
Claude-Session: https://claude.ai/code/session_01RhvxWoxVegp3rGjZ4khBZo
</commit_message>
<xml_diff>
--- a/decks/Sparks-x-example-green-valley.pptx
+++ b/decks/Sparks-x-example-green-valley.pptx
@@ -1044,7 +1044,7 @@
           <a:p>
             <a:r>
               <a:rPr lang="en-US" dirty="0"/>
-              <a:t>Close: restate the guarantee, propose a start date, and ask for Weedmaps admin access to begin the audit. Add-ons are $495/mo each and can be switched on at any time.</a:t>
+              <a:t>Close: restate the guarantee, propose a start date, and ask for Weedmaps admin access to begin the audit. Add-ons are $495/mo each. Can be switched on at any time.</a:t>
             </a:r>
             <a:endParaRPr lang="en-US" dirty="0"/>
           </a:p>
@@ -1748,7 +1748,7 @@
           <a:p>
             <a:r>
               <a:rPr lang="en-US" dirty="0"/>
-              <a:t>Pricing for Weedmaps Management. Results in 30 days or your money back. Ad spend is billed by the platform; the fee covers management. Then transition: each add-on is $495/mo.</a:t>
+              <a:t>Pricing for Weedmaps Management. Results in 30 days or your money back. Ad spend is billed by the platform; the fee covers management. Each add-on is $495/mo.</a:t>
             </a:r>
             <a:endParaRPr lang="en-US" dirty="0"/>
           </a:p>
@@ -2367,7 +2367,7 @@
         <p:spPr>
           <a:xfrm>
             <a:off x="548640" y="3931920"/>
-            <a:ext cx="6949440" cy="365760"/>
+            <a:ext cx="7498080" cy="365760"/>
           </a:xfrm>
           <a:prstGeom prst="rect">
             <a:avLst/>
@@ -8235,8 +8235,8 @@
         </p:blipFill>
         <p:spPr>
           <a:xfrm>
-            <a:off x="548640" y="5532120"/>
-            <a:ext cx="1005840" cy="672406"/>
+            <a:off x="548640" y="5623560"/>
+            <a:ext cx="914400" cy="611278"/>
           </a:xfrm>
           <a:prstGeom prst="rect">
             <a:avLst/>
@@ -8318,7 +8318,7 @@
         <p:spPr>
           <a:xfrm>
             <a:off x="7909560" y="2743200"/>
-            <a:ext cx="1676095" cy="335280"/>
+            <a:ext cx="2133295" cy="350520"/>
           </a:xfrm>
           <a:prstGeom prst="rect">
             <a:avLst/>
@@ -8334,7 +8334,7 @@
               <a:buNone/>
             </a:pPr>
             <a:r>
-              <a:rPr lang="en-US" sz="1250" dirty="0">
+              <a:rPr lang="en-US" sz="1200" dirty="0">
                 <a:solidFill>
                   <a:srgbClr val="FFFFFF"/>
                 </a:solidFill>
@@ -8344,7 +8344,7 @@
               </a:rPr>
               <a:t>Weedmaps · Launch</a:t>
             </a:r>
-            <a:endParaRPr lang="en-US" sz="1250" dirty="0"/>
+            <a:endParaRPr lang="en-US" sz="1200" dirty="0"/>
           </a:p>
         </p:txBody>
       </p:sp>
@@ -8356,8 +8356,8 @@
         </p:nvSpPr>
         <p:spPr>
           <a:xfrm>
-            <a:off x="9494215" y="2743200"/>
-            <a:ext cx="1828800" cy="335280"/>
+            <a:off x="9859975" y="2743200"/>
+            <a:ext cx="1463040" cy="350520"/>
           </a:xfrm>
           <a:prstGeom prst="rect">
             <a:avLst/>
@@ -8373,7 +8373,7 @@
               <a:buNone/>
             </a:pPr>
             <a:r>
-              <a:rPr lang="en-US" sz="1250" b="1" dirty="0">
+              <a:rPr lang="en-US" sz="1200" b="1" dirty="0">
                 <a:solidFill>
                   <a:srgbClr val="FFFFFF"/>
                 </a:solidFill>
@@ -8383,7 +8383,7 @@
               </a:rPr>
               <a:t>Custom</a:t>
             </a:r>
-            <a:endParaRPr lang="en-US" sz="1250" dirty="0"/>
+            <a:endParaRPr lang="en-US" sz="1200" dirty="0"/>
           </a:p>
         </p:txBody>
       </p:sp>
@@ -8395,8 +8395,8 @@
         </p:nvSpPr>
         <p:spPr>
           <a:xfrm>
-            <a:off x="7909560" y="3078480"/>
-            <a:ext cx="1676095" cy="335280"/>
+            <a:off x="7909560" y="3093720"/>
+            <a:ext cx="2133295" cy="350520"/>
           </a:xfrm>
           <a:prstGeom prst="rect">
             <a:avLst/>
@@ -8412,7 +8412,7 @@
               <a:buNone/>
             </a:pPr>
             <a:r>
-              <a:rPr lang="en-US" sz="1250" dirty="0">
+              <a:rPr lang="en-US" sz="1200" dirty="0">
                 <a:solidFill>
                   <a:srgbClr val="FFFFFF"/>
                 </a:solidFill>
@@ -8422,7 +8422,7 @@
               </a:rPr>
               <a:t>Weedmaps · Growth</a:t>
             </a:r>
-            <a:endParaRPr lang="en-US" sz="1250" dirty="0"/>
+            <a:endParaRPr lang="en-US" sz="1200" dirty="0"/>
           </a:p>
         </p:txBody>
       </p:sp>
@@ -8434,8 +8434,8 @@
         </p:nvSpPr>
         <p:spPr>
           <a:xfrm>
-            <a:off x="9494215" y="3078480"/>
-            <a:ext cx="1828800" cy="335280"/>
+            <a:off x="9859975" y="3093720"/>
+            <a:ext cx="1463040" cy="350520"/>
           </a:xfrm>
           <a:prstGeom prst="rect">
             <a:avLst/>
@@ -8451,7 +8451,7 @@
               <a:buNone/>
             </a:pPr>
             <a:r>
-              <a:rPr lang="en-US" sz="1250" b="1" dirty="0">
+              <a:rPr lang="en-US" sz="1200" b="1" dirty="0">
                 <a:solidFill>
                   <a:srgbClr val="FFFFFF"/>
                 </a:solidFill>
@@ -8461,7 +8461,7 @@
               </a:rPr>
               <a:t>Custom</a:t>
             </a:r>
-            <a:endParaRPr lang="en-US" sz="1250" dirty="0"/>
+            <a:endParaRPr lang="en-US" sz="1200" dirty="0"/>
           </a:p>
         </p:txBody>
       </p:sp>
@@ -8473,8 +8473,8 @@
         </p:nvSpPr>
         <p:spPr>
           <a:xfrm>
-            <a:off x="7909560" y="3413760"/>
-            <a:ext cx="1676095" cy="335280"/>
+            <a:off x="7909560" y="3444240"/>
+            <a:ext cx="2133295" cy="350520"/>
           </a:xfrm>
           <a:prstGeom prst="rect">
             <a:avLst/>
@@ -8490,7 +8490,7 @@
               <a:buNone/>
             </a:pPr>
             <a:r>
-              <a:rPr lang="en-US" sz="1250" dirty="0">
+              <a:rPr lang="en-US" sz="1200" dirty="0">
                 <a:solidFill>
                   <a:srgbClr val="FFFFFF"/>
                 </a:solidFill>
@@ -8500,7 +8500,7 @@
               </a:rPr>
               <a:t>Weedmaps · Dominate</a:t>
             </a:r>
-            <a:endParaRPr lang="en-US" sz="1250" dirty="0"/>
+            <a:endParaRPr lang="en-US" sz="1200" dirty="0"/>
           </a:p>
         </p:txBody>
       </p:sp>
@@ -8512,8 +8512,8 @@
         </p:nvSpPr>
         <p:spPr>
           <a:xfrm>
-            <a:off x="9494215" y="3413760"/>
-            <a:ext cx="1828800" cy="335280"/>
+            <a:off x="9859975" y="3444240"/>
+            <a:ext cx="1463040" cy="350520"/>
           </a:xfrm>
           <a:prstGeom prst="rect">
             <a:avLst/>
@@ -8529,7 +8529,7 @@
               <a:buNone/>
             </a:pPr>
             <a:r>
-              <a:rPr lang="en-US" sz="1250" b="1" dirty="0">
+              <a:rPr lang="en-US" sz="1200" b="1" dirty="0">
                 <a:solidFill>
                   <a:srgbClr val="FFFFFF"/>
                 </a:solidFill>
@@ -8539,7 +8539,7 @@
               </a:rPr>
               <a:t>Custom</a:t>
             </a:r>
-            <a:endParaRPr lang="en-US" sz="1250" dirty="0"/>
+            <a:endParaRPr lang="en-US" sz="1200" dirty="0"/>
           </a:p>
         </p:txBody>
       </p:sp>
@@ -8551,8 +8551,8 @@
         </p:nvSpPr>
         <p:spPr>
           <a:xfrm>
-            <a:off x="7909560" y="3749040"/>
-            <a:ext cx="1676095" cy="335280"/>
+            <a:off x="7909560" y="3794760"/>
+            <a:ext cx="2133295" cy="350520"/>
           </a:xfrm>
           <a:prstGeom prst="rect">
             <a:avLst/>
@@ -8568,7 +8568,7 @@
               <a:buNone/>
             </a:pPr>
             <a:r>
-              <a:rPr lang="en-US" sz="1250" dirty="0">
+              <a:rPr lang="en-US" sz="1200" dirty="0">
                 <a:solidFill>
                   <a:srgbClr val="FFFFFF"/>
                 </a:solidFill>
@@ -8578,7 +8578,7 @@
               </a:rPr>
               <a:t>Leafly Management</a:t>
             </a:r>
-            <a:endParaRPr lang="en-US" sz="1250" dirty="0"/>
+            <a:endParaRPr lang="en-US" sz="1200" dirty="0"/>
           </a:p>
         </p:txBody>
       </p:sp>
@@ -8590,8 +8590,8 @@
         </p:nvSpPr>
         <p:spPr>
           <a:xfrm>
-            <a:off x="9494215" y="3749040"/>
-            <a:ext cx="1828800" cy="335280"/>
+            <a:off x="9859975" y="3794760"/>
+            <a:ext cx="1463040" cy="350520"/>
           </a:xfrm>
           <a:prstGeom prst="rect">
             <a:avLst/>
@@ -8607,7 +8607,7 @@
               <a:buNone/>
             </a:pPr>
             <a:r>
-              <a:rPr lang="en-US" sz="1250" b="1" dirty="0">
+              <a:rPr lang="en-US" sz="1200" b="1" dirty="0">
                 <a:solidFill>
                   <a:srgbClr val="FFFFFF"/>
                 </a:solidFill>
@@ -8617,7 +8617,7 @@
               </a:rPr>
               <a:t>Included</a:t>
             </a:r>
-            <a:endParaRPr lang="en-US" sz="1250" dirty="0"/>
+            <a:endParaRPr lang="en-US" sz="1200" dirty="0"/>
           </a:p>
         </p:txBody>
       </p:sp>
@@ -8629,8 +8629,8 @@
         </p:nvSpPr>
         <p:spPr>
           <a:xfrm>
-            <a:off x="7909560" y="4084320"/>
-            <a:ext cx="1676095" cy="335280"/>
+            <a:off x="7909560" y="4145280"/>
+            <a:ext cx="2133295" cy="350520"/>
           </a:xfrm>
           <a:prstGeom prst="rect">
             <a:avLst/>
@@ -8646,7 +8646,7 @@
               <a:buNone/>
             </a:pPr>
             <a:r>
-              <a:rPr lang="en-US" sz="1250" dirty="0">
+              <a:rPr lang="en-US" sz="1200" dirty="0">
                 <a:solidFill>
                   <a:srgbClr val="FFFFFF"/>
                 </a:solidFill>
@@ -8656,7 +8656,7 @@
               </a:rPr>
               <a:t>Yelp Management</a:t>
             </a:r>
-            <a:endParaRPr lang="en-US" sz="1250" dirty="0"/>
+            <a:endParaRPr lang="en-US" sz="1200" dirty="0"/>
           </a:p>
         </p:txBody>
       </p:sp>
@@ -8668,8 +8668,8 @@
         </p:nvSpPr>
         <p:spPr>
           <a:xfrm>
-            <a:off x="9494215" y="4084320"/>
-            <a:ext cx="1828800" cy="335280"/>
+            <a:off x="9859975" y="4145280"/>
+            <a:ext cx="1463040" cy="350520"/>
           </a:xfrm>
           <a:prstGeom prst="rect">
             <a:avLst/>
@@ -8685,7 +8685,7 @@
               <a:buNone/>
             </a:pPr>
             <a:r>
-              <a:rPr lang="en-US" sz="1250" b="1" dirty="0">
+              <a:rPr lang="en-US" sz="1200" b="1" dirty="0">
                 <a:solidFill>
                   <a:srgbClr val="FFFFFF"/>
                 </a:solidFill>
@@ -8695,7 +8695,7 @@
               </a:rPr>
               <a:t>Included</a:t>
             </a:r>
-            <a:endParaRPr lang="en-US" sz="1250" dirty="0"/>
+            <a:endParaRPr lang="en-US" sz="1200" dirty="0"/>
           </a:p>
         </p:txBody>
       </p:sp>
@@ -8707,8 +8707,8 @@
         </p:nvSpPr>
         <p:spPr>
           <a:xfrm>
-            <a:off x="7909560" y="4419600"/>
-            <a:ext cx="1676095" cy="335280"/>
+            <a:off x="7909560" y="4495800"/>
+            <a:ext cx="2133295" cy="350520"/>
           </a:xfrm>
           <a:prstGeom prst="rect">
             <a:avLst/>
@@ -8724,7 +8724,7 @@
               <a:buNone/>
             </a:pPr>
             <a:r>
-              <a:rPr lang="en-US" sz="1250" dirty="0">
+              <a:rPr lang="en-US" sz="1200" dirty="0">
                 <a:solidFill>
                   <a:srgbClr val="FFFFFF"/>
                 </a:solidFill>
@@ -8734,7 +8734,7 @@
               </a:rPr>
               <a:t>Google Management</a:t>
             </a:r>
-            <a:endParaRPr lang="en-US" sz="1250" dirty="0"/>
+            <a:endParaRPr lang="en-US" sz="1200" dirty="0"/>
           </a:p>
         </p:txBody>
       </p:sp>
@@ -8746,8 +8746,8 @@
         </p:nvSpPr>
         <p:spPr>
           <a:xfrm>
-            <a:off x="9494215" y="4419600"/>
-            <a:ext cx="1828800" cy="335280"/>
+            <a:off x="9859975" y="4495800"/>
+            <a:ext cx="1463040" cy="350520"/>
           </a:xfrm>
           <a:prstGeom prst="rect">
             <a:avLst/>
@@ -8763,7 +8763,7 @@
               <a:buNone/>
             </a:pPr>
             <a:r>
-              <a:rPr lang="en-US" sz="1250" b="1" dirty="0">
+              <a:rPr lang="en-US" sz="1200" b="1" dirty="0">
                 <a:solidFill>
                   <a:srgbClr val="FFFFFF"/>
                 </a:solidFill>
@@ -8773,7 +8773,7 @@
               </a:rPr>
               <a:t>Included</a:t>
             </a:r>
-            <a:endParaRPr lang="en-US" sz="1250" dirty="0"/>
+            <a:endParaRPr lang="en-US" sz="1200" dirty="0"/>
           </a:p>
         </p:txBody>
       </p:sp>
@@ -15751,16 +15751,16 @@
         <p:spPr>
           <a:xfrm>
             <a:off x="868680" y="2926080"/>
-            <a:ext cx="2875178" cy="868680"/>
-          </a:xfrm>
-          <a:prstGeom prst="rect">
-            <a:avLst/>
-          </a:prstGeom>
-          <a:noFill/>
-          <a:ln/>
-        </p:spPr>
-        <p:txBody>
-          <a:bodyPr wrap="square" lIns="0" tIns="0" rIns="0" bIns="0" rtlCol="0" anchor="t"/>
+            <a:ext cx="2875178" cy="822960"/>
+          </a:xfrm>
+          <a:prstGeom prst="rect">
+            <a:avLst/>
+          </a:prstGeom>
+          <a:noFill/>
+          <a:ln/>
+        </p:spPr>
+        <p:txBody>
+          <a:bodyPr wrap="square" lIns="0" tIns="0" rIns="0" bIns="0" rtlCol="0" anchor="ctr"/>
           <a:lstStyle/>
           <a:p>
             <a:pPr indent="0" marL="0">
@@ -15790,7 +15790,7 @@
         <p:spPr>
           <a:xfrm>
             <a:off x="868680" y="3840480"/>
-            <a:ext cx="2875178" cy="1005840"/>
+            <a:ext cx="2875178" cy="1051560"/>
           </a:xfrm>
           <a:prstGeom prst="rect">
             <a:avLst/>
@@ -15806,7 +15806,7 @@
               <a:buNone/>
             </a:pPr>
             <a:r>
-              <a:rPr lang="en-US" sz="1250" dirty="0">
+              <a:rPr lang="en-US" sz="1200" dirty="0">
                 <a:solidFill>
                   <a:srgbClr val="222222"/>
                 </a:solidFill>
@@ -15816,7 +15816,7 @@
               </a:rPr>
               <a:t>Weedmaps + Google</a:t>
             </a:r>
-            <a:endParaRPr lang="en-US" sz="1250" dirty="0"/>
+            <a:endParaRPr lang="en-US" sz="1200" dirty="0"/>
           </a:p>
         </p:txBody>
       </p:sp>
@@ -15895,16 +15895,16 @@
         <p:spPr>
           <a:xfrm>
             <a:off x="4658258" y="2926080"/>
-            <a:ext cx="2875178" cy="868680"/>
-          </a:xfrm>
-          <a:prstGeom prst="rect">
-            <a:avLst/>
-          </a:prstGeom>
-          <a:noFill/>
-          <a:ln/>
-        </p:spPr>
-        <p:txBody>
-          <a:bodyPr wrap="square" lIns="0" tIns="0" rIns="0" bIns="0" rtlCol="0" anchor="t"/>
+            <a:ext cx="2875178" cy="822960"/>
+          </a:xfrm>
+          <a:prstGeom prst="rect">
+            <a:avLst/>
+          </a:prstGeom>
+          <a:noFill/>
+          <a:ln/>
+        </p:spPr>
+        <p:txBody>
+          <a:bodyPr wrap="square" lIns="0" tIns="0" rIns="0" bIns="0" rtlCol="0" anchor="ctr"/>
           <a:lstStyle/>
           <a:p>
             <a:pPr indent="0" marL="0">
@@ -15934,7 +15934,7 @@
         <p:spPr>
           <a:xfrm>
             <a:off x="4658258" y="3840480"/>
-            <a:ext cx="2875178" cy="1005840"/>
+            <a:ext cx="2875178" cy="1051560"/>
           </a:xfrm>
           <a:prstGeom prst="rect">
             <a:avLst/>
@@ -15950,7 +15950,7 @@
               <a:buNone/>
             </a:pPr>
             <a:r>
-              <a:rPr lang="en-US" sz="1250" dirty="0">
+              <a:rPr lang="en-US" sz="1200" dirty="0">
                 <a:solidFill>
                   <a:srgbClr val="222222"/>
                 </a:solidFill>
@@ -15960,7 +15960,7 @@
               </a:rPr>
               <a:t>Weedmaps + Leafly + Yelp + Google</a:t>
             </a:r>
-            <a:endParaRPr lang="en-US" sz="1250" dirty="0"/>
+            <a:endParaRPr lang="en-US" sz="1200" dirty="0"/>
           </a:p>
         </p:txBody>
       </p:sp>
@@ -16039,16 +16039,16 @@
         <p:spPr>
           <a:xfrm>
             <a:off x="8447837" y="2926080"/>
-            <a:ext cx="2875178" cy="868680"/>
-          </a:xfrm>
-          <a:prstGeom prst="rect">
-            <a:avLst/>
-          </a:prstGeom>
-          <a:noFill/>
-          <a:ln/>
-        </p:spPr>
-        <p:txBody>
-          <a:bodyPr wrap="square" lIns="0" tIns="0" rIns="0" bIns="0" rtlCol="0" anchor="t"/>
+            <a:ext cx="2875178" cy="822960"/>
+          </a:xfrm>
+          <a:prstGeom prst="rect">
+            <a:avLst/>
+          </a:prstGeom>
+          <a:noFill/>
+          <a:ln/>
+        </p:spPr>
+        <p:txBody>
+          <a:bodyPr wrap="square" lIns="0" tIns="0" rIns="0" bIns="0" rtlCol="0" anchor="ctr"/>
           <a:lstStyle/>
           <a:p>
             <a:pPr indent="0" marL="0">
@@ -16078,7 +16078,7 @@
         <p:spPr>
           <a:xfrm>
             <a:off x="8447837" y="3840480"/>
-            <a:ext cx="2875178" cy="1005840"/>
+            <a:ext cx="2875178" cy="1051560"/>
           </a:xfrm>
           <a:prstGeom prst="rect">
             <a:avLst/>
@@ -16094,7 +16094,7 @@
               <a:buNone/>
             </a:pPr>
             <a:r>
-              <a:rPr lang="en-US" sz="1250" dirty="0">
+              <a:rPr lang="en-US" sz="1200" dirty="0">
                 <a:solidFill>
                   <a:srgbClr val="222222"/>
                 </a:solidFill>
@@ -16104,7 +16104,7 @@
               </a:rPr>
               <a:t>All platforms + Local SEO + Programmatic</a:t>
             </a:r>
-            <a:endParaRPr lang="en-US" sz="1250" dirty="0"/>
+            <a:endParaRPr lang="en-US" sz="1200" dirty="0"/>
           </a:p>
         </p:txBody>
       </p:sp>

</xml_diff>

<commit_message>
Give scope items titles with descriptions
Each "what we manage" line in src/platforms.yml is now a title + body for all
four platforms. The focus scope slide shows a bold title over the description;
add-on preview cards show "Title — description" bullets.

Co-Authored-By: Claude Fable 5.1 <noreply@anthropic.com>
Claude-Session: https://claude.ai/code/session_01RhvxWoxVegp3rGjZ4khBZo
</commit_message>
<xml_diff>
--- a/decks/Sparks-x-example-green-valley.pptx
+++ b/decks/Sparks-x-example-green-valley.pptx
@@ -3367,8 +3367,8 @@
         </p:nvSpPr>
         <p:spPr>
           <a:xfrm>
-            <a:off x="7772400" y="2743454"/>
-            <a:ext cx="3596335" cy="1892554"/>
+            <a:off x="7772400" y="2725166"/>
+            <a:ext cx="3596335" cy="2121154"/>
           </a:xfrm>
           <a:prstGeom prst="rect">
             <a:avLst/>
@@ -3382,13 +3382,13 @@
           <a:p>
             <a:pPr marL="152400" indent="-152400">
               <a:spcAft>
-                <a:spcPts val="300"/>
+                <a:spcPts val="200"/>
               </a:spcAft>
               <a:buSzPct val="100000"/>
               <a:buChar char="•"/>
             </a:pPr>
             <a:r>
-              <a:rPr lang="en-US" sz="1050" dirty="0">
+              <a:rPr lang="en-US" sz="1000" b="1" dirty="0">
                 <a:solidFill>
                   <a:srgbClr val="FFFFFF"/>
                 </a:solidFill>
@@ -3396,20 +3396,34 @@
                 <a:ea typeface="Calibri" pitchFamily="34" charset="-122"/>
                 <a:cs typeface="Calibri" pitchFamily="34" charset="-120"/>
               </a:rPr>
-              <a:t>Menu sync and product tagging across strains, brands, and categories</a:t>
-            </a:r>
-            <a:endParaRPr lang="en-US" sz="1050" dirty="0"/>
+              <a:t>Menu sync &amp; tagging</a:t>
+            </a:r>
+            <a:pPr indent="0" marL="0">
+              <a:buNone/>
+            </a:pPr>
+            <a:r>
+              <a:rPr lang="en-US" sz="1000" dirty="0">
+                <a:solidFill>
+                  <a:srgbClr val="FFE3D0"/>
+                </a:solidFill>
+                <a:latin typeface="Calibri" pitchFamily="34" charset="0"/>
+                <a:ea typeface="Calibri" pitchFamily="34" charset="-122"/>
+                <a:cs typeface="Calibri" pitchFamily="34" charset="-120"/>
+              </a:rPr>
+              <a:t> — Product tagging across strains, brands, and categories, synced with your POS</a:t>
+            </a:r>
+            <a:endParaRPr lang="en-US" sz="1000" dirty="0"/>
           </a:p>
           <a:p>
             <a:pPr marL="152400" indent="-152400">
               <a:spcAft>
-                <a:spcPts val="300"/>
+                <a:spcPts val="200"/>
               </a:spcAft>
               <a:buSzPct val="100000"/>
               <a:buChar char="•"/>
             </a:pPr>
             <a:r>
-              <a:rPr lang="en-US" sz="1050" dirty="0">
+              <a:rPr lang="en-US" sz="1000" b="1" dirty="0">
                 <a:solidFill>
                   <a:srgbClr val="FFFFFF"/>
                 </a:solidFill>
@@ -3417,20 +3431,34 @@
                 <a:ea typeface="Calibri" pitchFamily="34" charset="-122"/>
                 <a:cs typeface="Calibri" pitchFamily="34" charset="-120"/>
               </a:rPr>
-              <a:t>Leafly Ads strategy, budget, and creative</a:t>
-            </a:r>
-            <a:endParaRPr lang="en-US" sz="1050" dirty="0"/>
+              <a:t>Leafly Ads</a:t>
+            </a:r>
+            <a:pPr indent="0" marL="0">
+              <a:buNone/>
+            </a:pPr>
+            <a:r>
+              <a:rPr lang="en-US" sz="1000" dirty="0">
+                <a:solidFill>
+                  <a:srgbClr val="FFE3D0"/>
+                </a:solidFill>
+                <a:latin typeface="Calibri" pitchFamily="34" charset="0"/>
+                <a:ea typeface="Calibri" pitchFamily="34" charset="-122"/>
+                <a:cs typeface="Calibri" pitchFamily="34" charset="-120"/>
+              </a:rPr>
+              <a:t> — Ad strategy, budget, and creative built around ROAS</a:t>
+            </a:r>
+            <a:endParaRPr lang="en-US" sz="1000" dirty="0"/>
           </a:p>
           <a:p>
             <a:pPr marL="152400" indent="-152400">
               <a:spcAft>
-                <a:spcPts val="300"/>
+                <a:spcPts val="200"/>
               </a:spcAft>
               <a:buSzPct val="100000"/>
               <a:buChar char="•"/>
             </a:pPr>
             <a:r>
-              <a:rPr lang="en-US" sz="1050" dirty="0">
+              <a:rPr lang="en-US" sz="1000" b="1" dirty="0">
                 <a:solidFill>
                   <a:srgbClr val="FFFFFF"/>
                 </a:solidFill>
@@ -3438,20 +3466,34 @@
                 <a:ea typeface="Calibri" pitchFamily="34" charset="-122"/>
                 <a:cs typeface="Calibri" pitchFamily="34" charset="-120"/>
               </a:rPr>
-              <a:t>Deal and featured-product activations</a:t>
-            </a:r>
-            <a:endParaRPr lang="en-US" sz="1050" dirty="0"/>
+              <a:t>Deals &amp; featured products</a:t>
+            </a:r>
+            <a:pPr indent="0" marL="0">
+              <a:buNone/>
+            </a:pPr>
+            <a:r>
+              <a:rPr lang="en-US" sz="1000" dirty="0">
+                <a:solidFill>
+                  <a:srgbClr val="FFE3D0"/>
+                </a:solidFill>
+                <a:latin typeface="Calibri" pitchFamily="34" charset="0"/>
+                <a:ea typeface="Calibri" pitchFamily="34" charset="-122"/>
+                <a:cs typeface="Calibri" pitchFamily="34" charset="-120"/>
+              </a:rPr>
+              <a:t> — Deal and featured-product activations kept current</a:t>
+            </a:r>
+            <a:endParaRPr lang="en-US" sz="1000" dirty="0"/>
           </a:p>
           <a:p>
             <a:pPr marL="152400" indent="-152400">
               <a:spcAft>
-                <a:spcPts val="300"/>
+                <a:spcPts val="200"/>
               </a:spcAft>
               <a:buSzPct val="100000"/>
               <a:buChar char="•"/>
             </a:pPr>
             <a:r>
-              <a:rPr lang="en-US" sz="1050" dirty="0">
+              <a:rPr lang="en-US" sz="1000" b="1" dirty="0">
                 <a:solidFill>
                   <a:srgbClr val="FFFFFF"/>
                 </a:solidFill>
@@ -3459,20 +3501,34 @@
                 <a:ea typeface="Calibri" pitchFamily="34" charset="-122"/>
                 <a:cs typeface="Calibri" pitchFamily="34" charset="-120"/>
               </a:rPr>
-              <a:t>Listing optimization and photo refresh</a:t>
-            </a:r>
-            <a:endParaRPr lang="en-US" sz="1050" dirty="0"/>
+              <a:t>Listing optimization</a:t>
+            </a:r>
+            <a:pPr indent="0" marL="0">
+              <a:buNone/>
+            </a:pPr>
+            <a:r>
+              <a:rPr lang="en-US" sz="1000" dirty="0">
+                <a:solidFill>
+                  <a:srgbClr val="FFE3D0"/>
+                </a:solidFill>
+                <a:latin typeface="Calibri" pitchFamily="34" charset="0"/>
+                <a:ea typeface="Calibri" pitchFamily="34" charset="-122"/>
+                <a:cs typeface="Calibri" pitchFamily="34" charset="-120"/>
+              </a:rPr>
+              <a:t> — Profile details and photo refresh</a:t>
+            </a:r>
+            <a:endParaRPr lang="en-US" sz="1000" dirty="0"/>
           </a:p>
           <a:p>
             <a:pPr marL="152400" indent="-152400">
               <a:spcAft>
-                <a:spcPts val="300"/>
+                <a:spcPts val="200"/>
               </a:spcAft>
               <a:buSzPct val="100000"/>
               <a:buChar char="•"/>
             </a:pPr>
             <a:r>
-              <a:rPr lang="en-US" sz="1050" dirty="0">
+              <a:rPr lang="en-US" sz="1000" b="1" dirty="0">
                 <a:solidFill>
                   <a:srgbClr val="FFFFFF"/>
                 </a:solidFill>
@@ -3480,9 +3536,23 @@
                 <a:ea typeface="Calibri" pitchFamily="34" charset="-122"/>
                 <a:cs typeface="Calibri" pitchFamily="34" charset="-120"/>
               </a:rPr>
-              <a:t>Review responses and reporting</a:t>
-            </a:r>
-            <a:endParaRPr lang="en-US" sz="1050" dirty="0"/>
+              <a:t>Reviews &amp; reporting</a:t>
+            </a:r>
+            <a:pPr indent="0" marL="0">
+              <a:buNone/>
+            </a:pPr>
+            <a:r>
+              <a:rPr lang="en-US" sz="1000" dirty="0">
+                <a:solidFill>
+                  <a:srgbClr val="FFE3D0"/>
+                </a:solidFill>
+                <a:latin typeface="Calibri" pitchFamily="34" charset="0"/>
+                <a:ea typeface="Calibri" pitchFamily="34" charset="-122"/>
+                <a:cs typeface="Calibri" pitchFamily="34" charset="-120"/>
+              </a:rPr>
+              <a:t> — Review responses and monthly performance reporting</a:t>
+            </a:r>
+            <a:endParaRPr lang="en-US" sz="1000" dirty="0"/>
           </a:p>
         </p:txBody>
       </p:sp>
@@ -3494,7 +3564,7 @@
         </p:nvSpPr>
         <p:spPr>
           <a:xfrm>
-            <a:off x="7909560" y="4754880"/>
+            <a:off x="7909560" y="4919472"/>
             <a:ext cx="3413455" cy="0"/>
           </a:xfrm>
           <a:prstGeom prst="line">
@@ -3517,8 +3587,8 @@
         </p:nvSpPr>
         <p:spPr>
           <a:xfrm>
-            <a:off x="7909560" y="4864608"/>
-            <a:ext cx="1828800" cy="502920"/>
+            <a:off x="7909560" y="4983480"/>
+            <a:ext cx="1828800" cy="457200"/>
           </a:xfrm>
           <a:prstGeom prst="rect">
             <a:avLst/>
@@ -3534,7 +3604,7 @@
               <a:buNone/>
             </a:pPr>
             <a:r>
-              <a:rPr lang="en-US" sz="2400" b="1" dirty="0">
+              <a:rPr lang="en-US" sz="2200" b="1" dirty="0">
                 <a:solidFill>
                   <a:srgbClr val="FFFFFF"/>
                 </a:solidFill>
@@ -3544,7 +3614,7 @@
               </a:rPr>
               <a:t>+44%</a:t>
             </a:r>
-            <a:endParaRPr lang="en-US" sz="2400" dirty="0"/>
+            <a:endParaRPr lang="en-US" sz="2200" dirty="0"/>
           </a:p>
         </p:txBody>
       </p:sp>
@@ -3556,8 +3626,8 @@
         </p:nvSpPr>
         <p:spPr>
           <a:xfrm>
-            <a:off x="9784080" y="4864608"/>
-            <a:ext cx="1538935" cy="502920"/>
+            <a:off x="9784080" y="4983480"/>
+            <a:ext cx="1538935" cy="457200"/>
           </a:xfrm>
           <a:prstGeom prst="rect">
             <a:avLst/>
@@ -3573,7 +3643,7 @@
               <a:buNone/>
             </a:pPr>
             <a:r>
-              <a:rPr lang="en-US" sz="1050" dirty="0">
+              <a:rPr lang="en-US" sz="1000" dirty="0">
                 <a:solidFill>
                   <a:srgbClr val="FFE3D0"/>
                 </a:solidFill>
@@ -3583,7 +3653,7 @@
               </a:rPr>
               <a:t>Leafly ROAS for Nuna Harvest in six months</a:t>
             </a:r>
-            <a:endParaRPr lang="en-US" sz="1050" dirty="0"/>
+            <a:endParaRPr lang="en-US" sz="1000" dirty="0"/>
           </a:p>
         </p:txBody>
       </p:sp>
@@ -4545,8 +4615,8 @@
         </p:nvSpPr>
         <p:spPr>
           <a:xfrm>
-            <a:off x="7772400" y="2743454"/>
-            <a:ext cx="3596335" cy="1892554"/>
+            <a:off x="7772400" y="2725166"/>
+            <a:ext cx="3596335" cy="2121154"/>
           </a:xfrm>
           <a:prstGeom prst="rect">
             <a:avLst/>
@@ -4560,13 +4630,13 @@
           <a:p>
             <a:pPr marL="152400" indent="-152400">
               <a:spcAft>
-                <a:spcPts val="300"/>
+                <a:spcPts val="200"/>
               </a:spcAft>
               <a:buSzPct val="100000"/>
               <a:buChar char="•"/>
             </a:pPr>
             <a:r>
-              <a:rPr lang="en-US" sz="1050" dirty="0">
+              <a:rPr lang="en-US" sz="1000" b="1" dirty="0">
                 <a:solidFill>
                   <a:srgbClr val="FFFFFF"/>
                 </a:solidFill>
@@ -4574,20 +4644,34 @@
                 <a:ea typeface="Calibri" pitchFamily="34" charset="-122"/>
                 <a:cs typeface="Calibri" pitchFamily="34" charset="-120"/>
               </a:rPr>
-              <a:t>Yelp Ads campaigns through Sparks' Certified Partner access</a:t>
-            </a:r>
-            <a:endParaRPr lang="en-US" sz="1050" dirty="0"/>
+              <a:t>Yelp Ads</a:t>
+            </a:r>
+            <a:pPr indent="0" marL="0">
+              <a:buNone/>
+            </a:pPr>
+            <a:r>
+              <a:rPr lang="en-US" sz="1000" dirty="0">
+                <a:solidFill>
+                  <a:srgbClr val="FFE3D0"/>
+                </a:solidFill>
+                <a:latin typeface="Calibri" pitchFamily="34" charset="0"/>
+                <a:ea typeface="Calibri" pitchFamily="34" charset="-122"/>
+                <a:cs typeface="Calibri" pitchFamily="34" charset="-120"/>
+              </a:rPr>
+              <a:t> — Campaigns run through Sparks' Yelp Ads Certified Partner access</a:t>
+            </a:r>
+            <a:endParaRPr lang="en-US" sz="1000" dirty="0"/>
           </a:p>
           <a:p>
             <a:pPr marL="152400" indent="-152400">
               <a:spcAft>
-                <a:spcPts val="300"/>
+                <a:spcPts val="200"/>
               </a:spcAft>
               <a:buSzPct val="100000"/>
               <a:buChar char="•"/>
             </a:pPr>
             <a:r>
-              <a:rPr lang="en-US" sz="1050" dirty="0">
+              <a:rPr lang="en-US" sz="1000" b="1" dirty="0">
                 <a:solidFill>
                   <a:srgbClr val="FFFFFF"/>
                 </a:solidFill>
@@ -4595,20 +4679,34 @@
                 <a:ea typeface="Calibri" pitchFamily="34" charset="-122"/>
                 <a:cs typeface="Calibri" pitchFamily="34" charset="-120"/>
               </a:rPr>
-              <a:t>Profile optimization: photos, categories, hours, and highlights</a:t>
-            </a:r>
-            <a:endParaRPr lang="en-US" sz="1050" dirty="0"/>
+              <a:t>Profile optimization</a:t>
+            </a:r>
+            <a:pPr indent="0" marL="0">
+              <a:buNone/>
+            </a:pPr>
+            <a:r>
+              <a:rPr lang="en-US" sz="1000" dirty="0">
+                <a:solidFill>
+                  <a:srgbClr val="FFE3D0"/>
+                </a:solidFill>
+                <a:latin typeface="Calibri" pitchFamily="34" charset="0"/>
+                <a:ea typeface="Calibri" pitchFamily="34" charset="-122"/>
+                <a:cs typeface="Calibri" pitchFamily="34" charset="-120"/>
+              </a:rPr>
+              <a:t> — Photos, categories, hours, and highlights</a:t>
+            </a:r>
+            <a:endParaRPr lang="en-US" sz="1000" dirty="0"/>
           </a:p>
           <a:p>
             <a:pPr marL="152400" indent="-152400">
               <a:spcAft>
-                <a:spcPts val="300"/>
+                <a:spcPts val="200"/>
               </a:spcAft>
               <a:buSzPct val="100000"/>
               <a:buChar char="•"/>
             </a:pPr>
             <a:r>
-              <a:rPr lang="en-US" sz="1050" dirty="0">
+              <a:rPr lang="en-US" sz="1000" b="1" dirty="0">
                 <a:solidFill>
                   <a:srgbClr val="FFFFFF"/>
                 </a:solidFill>
@@ -4616,20 +4714,34 @@
                 <a:ea typeface="Calibri" pitchFamily="34" charset="-122"/>
                 <a:cs typeface="Calibri" pitchFamily="34" charset="-120"/>
               </a:rPr>
-              <a:t>Review responses and removal requests for guideline-breaking reviews</a:t>
-            </a:r>
-            <a:endParaRPr lang="en-US" sz="1050" dirty="0"/>
+              <a:t>Review management</a:t>
+            </a:r>
+            <a:pPr indent="0" marL="0">
+              <a:buNone/>
+            </a:pPr>
+            <a:r>
+              <a:rPr lang="en-US" sz="1000" dirty="0">
+                <a:solidFill>
+                  <a:srgbClr val="FFE3D0"/>
+                </a:solidFill>
+                <a:latin typeface="Calibri" pitchFamily="34" charset="0"/>
+                <a:ea typeface="Calibri" pitchFamily="34" charset="-122"/>
+                <a:cs typeface="Calibri" pitchFamily="34" charset="-120"/>
+              </a:rPr>
+              <a:t> — Responses and removal requests for guideline-breaking reviews</a:t>
+            </a:r>
+            <a:endParaRPr lang="en-US" sz="1000" dirty="0"/>
           </a:p>
           <a:p>
             <a:pPr marL="152400" indent="-152400">
               <a:spcAft>
-                <a:spcPts val="300"/>
+                <a:spcPts val="200"/>
               </a:spcAft>
               <a:buSzPct val="100000"/>
               <a:buChar char="•"/>
             </a:pPr>
             <a:r>
-              <a:rPr lang="en-US" sz="1050" dirty="0">
+              <a:rPr lang="en-US" sz="1000" b="1" dirty="0">
                 <a:solidFill>
                   <a:srgbClr val="FFFFFF"/>
                 </a:solidFill>
@@ -4637,20 +4749,34 @@
                 <a:ea typeface="Calibri" pitchFamily="34" charset="-122"/>
                 <a:cs typeface="Calibri" pitchFamily="34" charset="-120"/>
               </a:rPr>
-              <a:t>Lead tracking for calls, directions, and site visits</a:t>
-            </a:r>
-            <a:endParaRPr lang="en-US" sz="1050" dirty="0"/>
+              <a:t>Lead tracking</a:t>
+            </a:r>
+            <a:pPr indent="0" marL="0">
+              <a:buNone/>
+            </a:pPr>
+            <a:r>
+              <a:rPr lang="en-US" sz="1000" dirty="0">
+                <a:solidFill>
+                  <a:srgbClr val="FFE3D0"/>
+                </a:solidFill>
+                <a:latin typeface="Calibri" pitchFamily="34" charset="0"/>
+                <a:ea typeface="Calibri" pitchFamily="34" charset="-122"/>
+                <a:cs typeface="Calibri" pitchFamily="34" charset="-120"/>
+              </a:rPr>
+              <a:t> — Calls, direction requests, and site visits attributed to Yelp</a:t>
+            </a:r>
+            <a:endParaRPr lang="en-US" sz="1000" dirty="0"/>
           </a:p>
           <a:p>
             <a:pPr marL="152400" indent="-152400">
               <a:spcAft>
-                <a:spcPts val="300"/>
+                <a:spcPts val="200"/>
               </a:spcAft>
               <a:buSzPct val="100000"/>
               <a:buChar char="•"/>
             </a:pPr>
             <a:r>
-              <a:rPr lang="en-US" sz="1050" dirty="0">
+              <a:rPr lang="en-US" sz="1000" b="1" dirty="0">
                 <a:solidFill>
                   <a:srgbClr val="FFFFFF"/>
                 </a:solidFill>
@@ -4658,9 +4784,23 @@
                 <a:ea typeface="Calibri" pitchFamily="34" charset="-122"/>
                 <a:cs typeface="Calibri" pitchFamily="34" charset="-120"/>
               </a:rPr>
-              <a:t>Monthly reporting alongside your marketplace results</a:t>
-            </a:r>
-            <a:endParaRPr lang="en-US" sz="1050" dirty="0"/>
+              <a:t>Reporting</a:t>
+            </a:r>
+            <a:pPr indent="0" marL="0">
+              <a:buNone/>
+            </a:pPr>
+            <a:r>
+              <a:rPr lang="en-US" sz="1000" dirty="0">
+                <a:solidFill>
+                  <a:srgbClr val="FFE3D0"/>
+                </a:solidFill>
+                <a:latin typeface="Calibri" pitchFamily="34" charset="0"/>
+                <a:ea typeface="Calibri" pitchFamily="34" charset="-122"/>
+                <a:cs typeface="Calibri" pitchFamily="34" charset="-120"/>
+              </a:rPr>
+              <a:t> — Monthly reporting alongside your marketplace results</a:t>
+            </a:r>
+            <a:endParaRPr lang="en-US" sz="1000" dirty="0"/>
           </a:p>
         </p:txBody>
       </p:sp>
@@ -4672,7 +4812,7 @@
         </p:nvSpPr>
         <p:spPr>
           <a:xfrm>
-            <a:off x="7909560" y="4754880"/>
+            <a:off x="7909560" y="4919472"/>
             <a:ext cx="3413455" cy="0"/>
           </a:xfrm>
           <a:prstGeom prst="line">
@@ -4695,8 +4835,8 @@
         </p:nvSpPr>
         <p:spPr>
           <a:xfrm>
-            <a:off x="7909560" y="4864608"/>
-            <a:ext cx="1828800" cy="502920"/>
+            <a:off x="7909560" y="4983480"/>
+            <a:ext cx="1828800" cy="457200"/>
           </a:xfrm>
           <a:prstGeom prst="rect">
             <a:avLst/>
@@ -4712,7 +4852,7 @@
               <a:buNone/>
             </a:pPr>
             <a:r>
-              <a:rPr lang="en-US" sz="2400" b="1" dirty="0">
+              <a:rPr lang="en-US" sz="2200" b="1" dirty="0">
                 <a:solidFill>
                   <a:srgbClr val="FFFFFF"/>
                 </a:solidFill>
@@ -4722,7 +4862,7 @@
               </a:rPr>
               <a:t>+109%</a:t>
             </a:r>
-            <a:endParaRPr lang="en-US" sz="2400" dirty="0"/>
+            <a:endParaRPr lang="en-US" sz="2200" dirty="0"/>
           </a:p>
         </p:txBody>
       </p:sp>
@@ -4734,8 +4874,8 @@
         </p:nvSpPr>
         <p:spPr>
           <a:xfrm>
-            <a:off x="9784080" y="4864608"/>
-            <a:ext cx="1538935" cy="502920"/>
+            <a:off x="9784080" y="4983480"/>
+            <a:ext cx="1538935" cy="457200"/>
           </a:xfrm>
           <a:prstGeom prst="rect">
             <a:avLst/>
@@ -4751,7 +4891,7 @@
               <a:buNone/>
             </a:pPr>
             <a:r>
-              <a:rPr lang="en-US" sz="1050" dirty="0">
+              <a:rPr lang="en-US" sz="1000" dirty="0">
                 <a:solidFill>
                   <a:srgbClr val="FFE3D0"/>
                 </a:solidFill>
@@ -4761,7 +4901,7 @@
               </a:rPr>
               <a:t>Yelp leads for Nuna Harvest in six months</a:t>
             </a:r>
-            <a:endParaRPr lang="en-US" sz="1050" dirty="0"/>
+            <a:endParaRPr lang="en-US" sz="1000" dirty="0"/>
           </a:p>
         </p:txBody>
       </p:sp>
@@ -5723,8 +5863,8 @@
         </p:nvSpPr>
         <p:spPr>
           <a:xfrm>
-            <a:off x="7772400" y="2743454"/>
-            <a:ext cx="3596335" cy="1892554"/>
+            <a:off x="7772400" y="2725166"/>
+            <a:ext cx="3596335" cy="2121154"/>
           </a:xfrm>
           <a:prstGeom prst="rect">
             <a:avLst/>
@@ -5738,13 +5878,13 @@
           <a:p>
             <a:pPr marL="152400" indent="-152400">
               <a:spcAft>
-                <a:spcPts val="300"/>
+                <a:spcPts val="200"/>
               </a:spcAft>
               <a:buSzPct val="100000"/>
               <a:buChar char="•"/>
             </a:pPr>
             <a:r>
-              <a:rPr lang="en-US" sz="1050" dirty="0">
+              <a:rPr lang="en-US" sz="1000" b="1" dirty="0">
                 <a:solidFill>
                   <a:srgbClr val="FFFFFF"/>
                 </a:solidFill>
@@ -5752,20 +5892,34 @@
                 <a:ea typeface="Calibri" pitchFamily="34" charset="-122"/>
                 <a:cs typeface="Calibri" pitchFamily="34" charset="-120"/>
               </a:rPr>
-              <a:t>Google Business Profile claim, cleanup, and optimization</a:t>
-            </a:r>
-            <a:endParaRPr lang="en-US" sz="1050" dirty="0"/>
+              <a:t>Business Profile</a:t>
+            </a:r>
+            <a:pPr indent="0" marL="0">
+              <a:buNone/>
+            </a:pPr>
+            <a:r>
+              <a:rPr lang="en-US" sz="1000" dirty="0">
+                <a:solidFill>
+                  <a:srgbClr val="FFE3D0"/>
+                </a:solidFill>
+                <a:latin typeface="Calibri" pitchFamily="34" charset="0"/>
+                <a:ea typeface="Calibri" pitchFamily="34" charset="-122"/>
+                <a:cs typeface="Calibri" pitchFamily="34" charset="-120"/>
+              </a:rPr>
+              <a:t> — Claim, cleanup, and optimization of your Google Business Profile</a:t>
+            </a:r>
+            <a:endParaRPr lang="en-US" sz="1000" dirty="0"/>
           </a:p>
           <a:p>
             <a:pPr marL="152400" indent="-152400">
               <a:spcAft>
-                <a:spcPts val="300"/>
+                <a:spcPts val="200"/>
               </a:spcAft>
               <a:buSzPct val="100000"/>
               <a:buChar char="•"/>
             </a:pPr>
             <a:r>
-              <a:rPr lang="en-US" sz="1050" dirty="0">
+              <a:rPr lang="en-US" sz="1000" b="1" dirty="0">
                 <a:solidFill>
                   <a:srgbClr val="FFFFFF"/>
                 </a:solidFill>
@@ -5773,20 +5927,34 @@
                 <a:ea typeface="Calibri" pitchFamily="34" charset="-122"/>
                 <a:cs typeface="Calibri" pitchFamily="34" charset="-120"/>
               </a:rPr>
-              <a:t>Weekly Google Posts, photo refresh, Q&amp;A, and review responses</a:t>
-            </a:r>
-            <a:endParaRPr lang="en-US" sz="1050" dirty="0"/>
+              <a:t>Posts, photos &amp; reviews</a:t>
+            </a:r>
+            <a:pPr indent="0" marL="0">
+              <a:buNone/>
+            </a:pPr>
+            <a:r>
+              <a:rPr lang="en-US" sz="1000" dirty="0">
+                <a:solidFill>
+                  <a:srgbClr val="FFE3D0"/>
+                </a:solidFill>
+                <a:latin typeface="Calibri" pitchFamily="34" charset="0"/>
+                <a:ea typeface="Calibri" pitchFamily="34" charset="-122"/>
+                <a:cs typeface="Calibri" pitchFamily="34" charset="-120"/>
+              </a:rPr>
+              <a:t> — Weekly Google Posts, photo refresh, Q&amp;A, and review responses</a:t>
+            </a:r>
+            <a:endParaRPr lang="en-US" sz="1000" dirty="0"/>
           </a:p>
           <a:p>
             <a:pPr marL="152400" indent="-152400">
               <a:spcAft>
-                <a:spcPts val="300"/>
+                <a:spcPts val="200"/>
               </a:spcAft>
               <a:buSzPct val="100000"/>
               <a:buChar char="•"/>
             </a:pPr>
             <a:r>
-              <a:rPr lang="en-US" sz="1050" dirty="0">
+              <a:rPr lang="en-US" sz="1000" b="1" dirty="0">
                 <a:solidFill>
                   <a:srgbClr val="FFFFFF"/>
                 </a:solidFill>
@@ -5794,20 +5962,34 @@
                 <a:ea typeface="Calibri" pitchFamily="34" charset="-122"/>
                 <a:cs typeface="Calibri" pitchFamily="34" charset="-120"/>
               </a:rPr>
-              <a:t>Compliant Google Ads where the market allows</a:t>
-            </a:r>
-            <a:endParaRPr lang="en-US" sz="1050" dirty="0"/>
+              <a:t>Google Ads</a:t>
+            </a:r>
+            <a:pPr indent="0" marL="0">
+              <a:buNone/>
+            </a:pPr>
+            <a:r>
+              <a:rPr lang="en-US" sz="1000" dirty="0">
+                <a:solidFill>
+                  <a:srgbClr val="FFE3D0"/>
+                </a:solidFill>
+                <a:latin typeface="Calibri" pitchFamily="34" charset="0"/>
+                <a:ea typeface="Calibri" pitchFamily="34" charset="-122"/>
+                <a:cs typeface="Calibri" pitchFamily="34" charset="-120"/>
+              </a:rPr>
+              <a:t> — Compliant campaigns where the market allows</a:t>
+            </a:r>
+            <a:endParaRPr lang="en-US" sz="1000" dirty="0"/>
           </a:p>
           <a:p>
             <a:pPr marL="152400" indent="-152400">
               <a:spcAft>
-                <a:spcPts val="300"/>
+                <a:spcPts val="200"/>
               </a:spcAft>
               <a:buSzPct val="100000"/>
               <a:buChar char="•"/>
             </a:pPr>
             <a:r>
-              <a:rPr lang="en-US" sz="1050" dirty="0">
+              <a:rPr lang="en-US" sz="1000" b="1" dirty="0">
                 <a:solidFill>
                   <a:srgbClr val="FFFFFF"/>
                 </a:solidFill>
@@ -5815,20 +5997,34 @@
                 <a:ea typeface="Calibri" pitchFamily="34" charset="-122"/>
                 <a:cs typeface="Calibri" pitchFamily="34" charset="-120"/>
               </a:rPr>
-              <a:t>Local SEO: NAP consistency and citations across 50+ directories</a:t>
-            </a:r>
-            <a:endParaRPr lang="en-US" sz="1050" dirty="0"/>
+              <a:t>Local SEO &amp; citations</a:t>
+            </a:r>
+            <a:pPr indent="0" marL="0">
+              <a:buNone/>
+            </a:pPr>
+            <a:r>
+              <a:rPr lang="en-US" sz="1000" dirty="0">
+                <a:solidFill>
+                  <a:srgbClr val="FFE3D0"/>
+                </a:solidFill>
+                <a:latin typeface="Calibri" pitchFamily="34" charset="0"/>
+                <a:ea typeface="Calibri" pitchFamily="34" charset="-122"/>
+                <a:cs typeface="Calibri" pitchFamily="34" charset="-120"/>
+              </a:rPr>
+              <a:t> — NAP consistency across 50+ directories</a:t>
+            </a:r>
+            <a:endParaRPr lang="en-US" sz="1000" dirty="0"/>
           </a:p>
           <a:p>
             <a:pPr marL="152400" indent="-152400">
               <a:spcAft>
-                <a:spcPts val="300"/>
+                <a:spcPts val="200"/>
               </a:spcAft>
               <a:buSzPct val="100000"/>
               <a:buChar char="•"/>
             </a:pPr>
             <a:r>
-              <a:rPr lang="en-US" sz="1050" dirty="0">
+              <a:rPr lang="en-US" sz="1000" b="1" dirty="0">
                 <a:solidFill>
                   <a:srgbClr val="FFFFFF"/>
                 </a:solidFill>
@@ -5836,9 +6032,23 @@
                 <a:ea typeface="Calibri" pitchFamily="34" charset="-122"/>
                 <a:cs typeface="Calibri" pitchFamily="34" charset="-120"/>
               </a:rPr>
-              <a:t>Map-pack ranking tracking with a Top 3 goal in 90 days</a:t>
-            </a:r>
-            <a:endParaRPr lang="en-US" sz="1050" dirty="0"/>
+              <a:t>Map-pack tracking</a:t>
+            </a:r>
+            <a:pPr indent="0" marL="0">
+              <a:buNone/>
+            </a:pPr>
+            <a:r>
+              <a:rPr lang="en-US" sz="1000" dirty="0">
+                <a:solidFill>
+                  <a:srgbClr val="FFE3D0"/>
+                </a:solidFill>
+                <a:latin typeface="Calibri" pitchFamily="34" charset="0"/>
+                <a:ea typeface="Calibri" pitchFamily="34" charset="-122"/>
+                <a:cs typeface="Calibri" pitchFamily="34" charset="-120"/>
+              </a:rPr>
+              <a:t> — Ranking tracking with a Top 3 goal in 90 days</a:t>
+            </a:r>
+            <a:endParaRPr lang="en-US" sz="1000" dirty="0"/>
           </a:p>
         </p:txBody>
       </p:sp>
@@ -5850,7 +6060,7 @@
         </p:nvSpPr>
         <p:spPr>
           <a:xfrm>
-            <a:off x="7909560" y="4754880"/>
+            <a:off x="7909560" y="4919472"/>
             <a:ext cx="3413455" cy="0"/>
           </a:xfrm>
           <a:prstGeom prst="line">
@@ -5873,8 +6083,8 @@
         </p:nvSpPr>
         <p:spPr>
           <a:xfrm>
-            <a:off x="7909560" y="4864608"/>
-            <a:ext cx="1828800" cy="502920"/>
+            <a:off x="7909560" y="4983480"/>
+            <a:ext cx="1828800" cy="457200"/>
           </a:xfrm>
           <a:prstGeom prst="rect">
             <a:avLst/>
@@ -5890,7 +6100,7 @@
               <a:buNone/>
             </a:pPr>
             <a:r>
-              <a:rPr lang="en-US" sz="2400" b="1" dirty="0">
+              <a:rPr lang="en-US" sz="2200" b="1" dirty="0">
                 <a:solidFill>
                   <a:srgbClr val="FFFFFF"/>
                 </a:solidFill>
@@ -5900,7 +6110,7 @@
               </a:rPr>
               <a:t>Top 3</a:t>
             </a:r>
-            <a:endParaRPr lang="en-US" sz="2400" dirty="0"/>
+            <a:endParaRPr lang="en-US" sz="2200" dirty="0"/>
           </a:p>
         </p:txBody>
       </p:sp>
@@ -5912,8 +6122,8 @@
         </p:nvSpPr>
         <p:spPr>
           <a:xfrm>
-            <a:off x="9784080" y="4864608"/>
-            <a:ext cx="1538935" cy="502920"/>
+            <a:off x="9784080" y="4983480"/>
+            <a:ext cx="1538935" cy="457200"/>
           </a:xfrm>
           <a:prstGeom prst="rect">
             <a:avLst/>
@@ -5929,7 +6139,7 @@
               <a:buNone/>
             </a:pPr>
             <a:r>
-              <a:rPr lang="en-US" sz="1050" dirty="0">
+              <a:rPr lang="en-US" sz="1000" dirty="0">
                 <a:solidFill>
                   <a:srgbClr val="FFE3D0"/>
                 </a:solidFill>
@@ -5939,7 +6149,7 @@
               </a:rPr>
               <a:t>Google Maps ranking goal within 90 days</a:t>
             </a:r>
-            <a:endParaRPr lang="en-US" sz="1050" dirty="0"/>
+            <a:endParaRPr lang="en-US" sz="1000" dirty="0"/>
           </a:p>
         </p:txBody>
       </p:sp>
@@ -12542,23 +12752,62 @@
         <p:spPr>
           <a:xfrm>
             <a:off x="1325880" y="2746248"/>
-            <a:ext cx="4404208" cy="582168"/>
-          </a:xfrm>
-          <a:prstGeom prst="rect">
-            <a:avLst/>
-          </a:prstGeom>
-          <a:noFill/>
-          <a:ln/>
-        </p:spPr>
-        <p:txBody>
-          <a:bodyPr wrap="square" lIns="0" tIns="0" rIns="0" bIns="0" rtlCol="0" anchor="ctr"/>
-          <a:lstStyle/>
-          <a:p>
-            <a:pPr indent="0" marL="0">
-              <a:buNone/>
-            </a:pPr>
-            <a:r>
-              <a:rPr lang="en-US" sz="1300" dirty="0">
+            <a:ext cx="4404208" cy="274320"/>
+          </a:xfrm>
+          <a:prstGeom prst="rect">
+            <a:avLst/>
+          </a:prstGeom>
+          <a:noFill/>
+          <a:ln/>
+        </p:spPr>
+        <p:txBody>
+          <a:bodyPr wrap="square" lIns="0" tIns="0" rIns="0" bIns="0" rtlCol="0" anchor="t"/>
+          <a:lstStyle/>
+          <a:p>
+            <a:pPr indent="0" marL="0">
+              <a:buNone/>
+            </a:pPr>
+            <a:r>
+              <a:rPr lang="en-US" sz="1350" b="1" dirty="0">
+                <a:solidFill>
+                  <a:srgbClr val="DD5F13"/>
+                </a:solidFill>
+                <a:latin typeface="Calibri" pitchFamily="34" charset="0"/>
+                <a:ea typeface="Calibri" pitchFamily="34" charset="-122"/>
+                <a:cs typeface="Calibri" pitchFamily="34" charset="-120"/>
+              </a:rPr>
+              <a:t>Bid &amp; budget strategy</a:t>
+            </a:r>
+            <a:endParaRPr lang="en-US" sz="1350" dirty="0"/>
+          </a:p>
+        </p:txBody>
+      </p:sp>
+      <p:sp>
+        <p:nvSpPr>
+          <p:cNvPr id="12" name="Text 9"/>
+          <p:cNvSpPr txBox="1"/>
+          <p:nvPr/>
+        </p:nvSpPr>
+        <p:spPr>
+          <a:xfrm>
+            <a:off x="1325880" y="3020568"/>
+            <a:ext cx="4404208" cy="353568"/>
+          </a:xfrm>
+          <a:prstGeom prst="rect">
+            <a:avLst/>
+          </a:prstGeom>
+          <a:noFill/>
+          <a:ln/>
+        </p:spPr>
+        <p:txBody>
+          <a:bodyPr wrap="square" lIns="0" tIns="0" rIns="0" bIns="0" rtlCol="0" anchor="t"/>
+          <a:lstStyle/>
+          <a:p>
+            <a:pPr indent="0" marL="0">
+              <a:buNone/>
+            </a:pPr>
+            <a:r>
+              <a:rPr lang="en-US" sz="1150" dirty="0">
                 <a:solidFill>
                   <a:srgbClr val="222222"/>
                 </a:solidFill>
@@ -12566,15 +12815,15 @@
                 <a:ea typeface="Calibri" pitchFamily="34" charset="-122"/>
                 <a:cs typeface="Calibri" pitchFamily="34" charset="-120"/>
               </a:rPr>
-              <a:t>Bid strategy and daily budget pacing for top placement in every service zone</a:t>
-            </a:r>
-            <a:endParaRPr lang="en-US" sz="1300" dirty="0"/>
-          </a:p>
-        </p:txBody>
-      </p:sp>
-      <p:sp>
-        <p:nvSpPr>
-          <p:cNvPr id="12" name="Shape 9"/>
+              <a:t>Daily budget pacing and bid management for top placement in every service zone</a:t>
+            </a:r>
+            <a:endParaRPr lang="en-US" sz="1150" dirty="0"/>
+          </a:p>
+        </p:txBody>
+      </p:sp>
+      <p:sp>
+        <p:nvSpPr>
+          <p:cNvPr id="13" name="Shape 10"/>
           <p:cNvSpPr/>
           <p:nvPr/>
         </p:nvSpPr>
@@ -12601,7 +12850,7 @@
       </p:sp>
       <p:sp>
         <p:nvSpPr>
-          <p:cNvPr id="13" name="Shape 10"/>
+          <p:cNvPr id="14" name="Shape 11"/>
           <p:cNvSpPr/>
           <p:nvPr/>
         </p:nvSpPr>
@@ -12626,7 +12875,7 @@
       </p:sp>
       <p:sp>
         <p:nvSpPr>
-          <p:cNvPr id="14" name="Text 11"/>
+          <p:cNvPr id="15" name="Text 12"/>
           <p:cNvSpPr txBox="1"/>
           <p:nvPr/>
         </p:nvSpPr>
@@ -12665,30 +12914,69 @@
       </p:sp>
       <p:sp>
         <p:nvSpPr>
-          <p:cNvPr id="15" name="Text 12"/>
+          <p:cNvPr id="16" name="Text 13"/>
           <p:cNvSpPr txBox="1"/>
           <p:nvPr/>
         </p:nvSpPr>
         <p:spPr>
           <a:xfrm>
             <a:off x="7010248" y="2746248"/>
-            <a:ext cx="4404208" cy="582168"/>
-          </a:xfrm>
-          <a:prstGeom prst="rect">
-            <a:avLst/>
-          </a:prstGeom>
-          <a:noFill/>
-          <a:ln/>
-        </p:spPr>
-        <p:txBody>
-          <a:bodyPr wrap="square" lIns="0" tIns="0" rIns="0" bIns="0" rtlCol="0" anchor="ctr"/>
-          <a:lstStyle/>
-          <a:p>
-            <a:pPr indent="0" marL="0">
-              <a:buNone/>
-            </a:pPr>
-            <a:r>
-              <a:rPr lang="en-US" sz="1300" dirty="0">
+            <a:ext cx="4404208" cy="274320"/>
+          </a:xfrm>
+          <a:prstGeom prst="rect">
+            <a:avLst/>
+          </a:prstGeom>
+          <a:noFill/>
+          <a:ln/>
+        </p:spPr>
+        <p:txBody>
+          <a:bodyPr wrap="square" lIns="0" tIns="0" rIns="0" bIns="0" rtlCol="0" anchor="t"/>
+          <a:lstStyle/>
+          <a:p>
+            <a:pPr indent="0" marL="0">
+              <a:buNone/>
+            </a:pPr>
+            <a:r>
+              <a:rPr lang="en-US" sz="1350" b="1" dirty="0">
+                <a:solidFill>
+                  <a:srgbClr val="DD5F13"/>
+                </a:solidFill>
+                <a:latin typeface="Calibri" pitchFamily="34" charset="0"/>
+                <a:ea typeface="Calibri" pitchFamily="34" charset="-122"/>
+                <a:cs typeface="Calibri" pitchFamily="34" charset="-120"/>
+              </a:rPr>
+              <a:t>Listing optimization</a:t>
+            </a:r>
+            <a:endParaRPr lang="en-US" sz="1350" dirty="0"/>
+          </a:p>
+        </p:txBody>
+      </p:sp>
+      <p:sp>
+        <p:nvSpPr>
+          <p:cNvPr id="17" name="Text 14"/>
+          <p:cNvSpPr txBox="1"/>
+          <p:nvPr/>
+        </p:nvSpPr>
+        <p:spPr>
+          <a:xfrm>
+            <a:off x="7010248" y="3020568"/>
+            <a:ext cx="4404208" cy="353568"/>
+          </a:xfrm>
+          <a:prstGeom prst="rect">
+            <a:avLst/>
+          </a:prstGeom>
+          <a:noFill/>
+          <a:ln/>
+        </p:spPr>
+        <p:txBody>
+          <a:bodyPr wrap="square" lIns="0" tIns="0" rIns="0" bIns="0" rtlCol="0" anchor="t"/>
+          <a:lstStyle/>
+          <a:p>
+            <a:pPr indent="0" marL="0">
+              <a:buNone/>
+            </a:pPr>
+            <a:r>
+              <a:rPr lang="en-US" sz="1150" dirty="0">
                 <a:solidFill>
                   <a:srgbClr val="222222"/>
                 </a:solidFill>
@@ -12696,15 +12984,15 @@
                 <a:ea typeface="Calibri" pitchFamily="34" charset="-122"/>
                 <a:cs typeface="Calibri" pitchFamily="34" charset="-120"/>
               </a:rPr>
-              <a:t>Listing optimization: hours, photos, attributes, description, and Q&amp;A</a:t>
-            </a:r>
-            <a:endParaRPr lang="en-US" sz="1300" dirty="0"/>
-          </a:p>
-        </p:txBody>
-      </p:sp>
-      <p:sp>
-        <p:nvSpPr>
-          <p:cNvPr id="16" name="Shape 13"/>
+              <a:t>Hours, photos, attributes, description, and Q&amp;A kept accurate and conversion-ready</a:t>
+            </a:r>
+            <a:endParaRPr lang="en-US" sz="1150" dirty="0"/>
+          </a:p>
+        </p:txBody>
+      </p:sp>
+      <p:sp>
+        <p:nvSpPr>
+          <p:cNvPr id="18" name="Shape 15"/>
           <p:cNvSpPr/>
           <p:nvPr/>
         </p:nvSpPr>
@@ -12731,7 +13019,7 @@
       </p:sp>
       <p:sp>
         <p:nvSpPr>
-          <p:cNvPr id="17" name="Shape 14"/>
+          <p:cNvPr id="19" name="Shape 16"/>
           <p:cNvSpPr/>
           <p:nvPr/>
         </p:nvSpPr>
@@ -12756,7 +13044,7 @@
       </p:sp>
       <p:sp>
         <p:nvSpPr>
-          <p:cNvPr id="18" name="Text 15"/>
+          <p:cNvPr id="20" name="Text 17"/>
           <p:cNvSpPr txBox="1"/>
           <p:nvPr/>
         </p:nvSpPr>
@@ -12795,30 +13083,69 @@
       </p:sp>
       <p:sp>
         <p:nvSpPr>
-          <p:cNvPr id="19" name="Text 16"/>
+          <p:cNvPr id="21" name="Text 18"/>
           <p:cNvSpPr txBox="1"/>
           <p:nvPr/>
         </p:nvSpPr>
         <p:spPr>
           <a:xfrm>
             <a:off x="1325880" y="3648456"/>
-            <a:ext cx="4404208" cy="582168"/>
-          </a:xfrm>
-          <a:prstGeom prst="rect">
-            <a:avLst/>
-          </a:prstGeom>
-          <a:noFill/>
-          <a:ln/>
-        </p:spPr>
-        <p:txBody>
-          <a:bodyPr wrap="square" lIns="0" tIns="0" rIns="0" bIns="0" rtlCol="0" anchor="ctr"/>
-          <a:lstStyle/>
-          <a:p>
-            <a:pPr indent="0" marL="0">
-              <a:buNone/>
-            </a:pPr>
-            <a:r>
-              <a:rPr lang="en-US" sz="1300" dirty="0">
+            <a:ext cx="4404208" cy="274320"/>
+          </a:xfrm>
+          <a:prstGeom prst="rect">
+            <a:avLst/>
+          </a:prstGeom>
+          <a:noFill/>
+          <a:ln/>
+        </p:spPr>
+        <p:txBody>
+          <a:bodyPr wrap="square" lIns="0" tIns="0" rIns="0" bIns="0" rtlCol="0" anchor="t"/>
+          <a:lstStyle/>
+          <a:p>
+            <a:pPr indent="0" marL="0">
+              <a:buNone/>
+            </a:pPr>
+            <a:r>
+              <a:rPr lang="en-US" sz="1350" b="1" dirty="0">
+                <a:solidFill>
+                  <a:srgbClr val="DD5F13"/>
+                </a:solidFill>
+                <a:latin typeface="Calibri" pitchFamily="34" charset="0"/>
+                <a:ea typeface="Calibri" pitchFamily="34" charset="-122"/>
+                <a:cs typeface="Calibri" pitchFamily="34" charset="-120"/>
+              </a:rPr>
+              <a:t>Menu &amp; product verification</a:t>
+            </a:r>
+            <a:endParaRPr lang="en-US" sz="1350" dirty="0"/>
+          </a:p>
+        </p:txBody>
+      </p:sp>
+      <p:sp>
+        <p:nvSpPr>
+          <p:cNvPr id="22" name="Text 19"/>
+          <p:cNvSpPr txBox="1"/>
+          <p:nvPr/>
+        </p:nvSpPr>
+        <p:spPr>
+          <a:xfrm>
+            <a:off x="1325880" y="3922776"/>
+            <a:ext cx="4404208" cy="353568"/>
+          </a:xfrm>
+          <a:prstGeom prst="rect">
+            <a:avLst/>
+          </a:prstGeom>
+          <a:noFill/>
+          <a:ln/>
+        </p:spPr>
+        <p:txBody>
+          <a:bodyPr wrap="square" lIns="0" tIns="0" rIns="0" bIns="0" rtlCol="0" anchor="t"/>
+          <a:lstStyle/>
+          <a:p>
+            <a:pPr indent="0" marL="0">
+              <a:buNone/>
+            </a:pPr>
+            <a:r>
+              <a:rPr lang="en-US" sz="1150" dirty="0">
                 <a:solidFill>
                   <a:srgbClr val="222222"/>
                 </a:solidFill>
@@ -12826,15 +13153,15 @@
                 <a:ea typeface="Calibri" pitchFamily="34" charset="-122"/>
                 <a:cs typeface="Calibri" pitchFamily="34" charset="-120"/>
               </a:rPr>
-              <a:t>Menu management and product verification synced with your POS</a:t>
-            </a:r>
-            <a:endParaRPr lang="en-US" sz="1300" dirty="0"/>
-          </a:p>
-        </p:txBody>
-      </p:sp>
-      <p:sp>
-        <p:nvSpPr>
-          <p:cNvPr id="20" name="Shape 17"/>
+              <a:t>Menu management synced with your POS; every product verified</a:t>
+            </a:r>
+            <a:endParaRPr lang="en-US" sz="1150" dirty="0"/>
+          </a:p>
+        </p:txBody>
+      </p:sp>
+      <p:sp>
+        <p:nvSpPr>
+          <p:cNvPr id="23" name="Shape 20"/>
           <p:cNvSpPr/>
           <p:nvPr/>
         </p:nvSpPr>
@@ -12861,7 +13188,7 @@
       </p:sp>
       <p:sp>
         <p:nvSpPr>
-          <p:cNvPr id="21" name="Shape 18"/>
+          <p:cNvPr id="24" name="Shape 21"/>
           <p:cNvSpPr/>
           <p:nvPr/>
         </p:nvSpPr>
@@ -12886,7 +13213,7 @@
       </p:sp>
       <p:sp>
         <p:nvSpPr>
-          <p:cNvPr id="22" name="Text 19"/>
+          <p:cNvPr id="25" name="Text 22"/>
           <p:cNvSpPr txBox="1"/>
           <p:nvPr/>
         </p:nvSpPr>
@@ -12925,30 +13252,69 @@
       </p:sp>
       <p:sp>
         <p:nvSpPr>
-          <p:cNvPr id="23" name="Text 20"/>
+          <p:cNvPr id="26" name="Text 23"/>
           <p:cNvSpPr txBox="1"/>
           <p:nvPr/>
         </p:nvSpPr>
         <p:spPr>
           <a:xfrm>
             <a:off x="7010248" y="3648456"/>
-            <a:ext cx="4404208" cy="582168"/>
-          </a:xfrm>
-          <a:prstGeom prst="rect">
-            <a:avLst/>
-          </a:prstGeom>
-          <a:noFill/>
-          <a:ln/>
-        </p:spPr>
-        <p:txBody>
-          <a:bodyPr wrap="square" lIns="0" tIns="0" rIns="0" bIns="0" rtlCol="0" anchor="ctr"/>
-          <a:lstStyle/>
-          <a:p>
-            <a:pPr indent="0" marL="0">
-              <a:buNone/>
-            </a:pPr>
-            <a:r>
-              <a:rPr lang="en-US" sz="1300" dirty="0">
+            <a:ext cx="4404208" cy="274320"/>
+          </a:xfrm>
+          <a:prstGeom prst="rect">
+            <a:avLst/>
+          </a:prstGeom>
+          <a:noFill/>
+          <a:ln/>
+        </p:spPr>
+        <p:txBody>
+          <a:bodyPr wrap="square" lIns="0" tIns="0" rIns="0" bIns="0" rtlCol="0" anchor="t"/>
+          <a:lstStyle/>
+          <a:p>
+            <a:pPr indent="0" marL="0">
+              <a:buNone/>
+            </a:pPr>
+            <a:r>
+              <a:rPr lang="en-US" sz="1350" b="1" dirty="0">
+                <a:solidFill>
+                  <a:srgbClr val="DD5F13"/>
+                </a:solidFill>
+                <a:latin typeface="Calibri" pitchFamily="34" charset="0"/>
+                <a:ea typeface="Calibri" pitchFamily="34" charset="-122"/>
+                <a:cs typeface="Calibri" pitchFamily="34" charset="-120"/>
+              </a:rPr>
+              <a:t>Deals &amp; promotions</a:t>
+            </a:r>
+            <a:endParaRPr lang="en-US" sz="1350" dirty="0"/>
+          </a:p>
+        </p:txBody>
+      </p:sp>
+      <p:sp>
+        <p:nvSpPr>
+          <p:cNvPr id="27" name="Text 24"/>
+          <p:cNvSpPr txBox="1"/>
+          <p:nvPr/>
+        </p:nvSpPr>
+        <p:spPr>
+          <a:xfrm>
+            <a:off x="7010248" y="3922776"/>
+            <a:ext cx="4404208" cy="353568"/>
+          </a:xfrm>
+          <a:prstGeom prst="rect">
+            <a:avLst/>
+          </a:prstGeom>
+          <a:noFill/>
+          <a:ln/>
+        </p:spPr>
+        <p:txBody>
+          <a:bodyPr wrap="square" lIns="0" tIns="0" rIns="0" bIns="0" rtlCol="0" anchor="t"/>
+          <a:lstStyle/>
+          <a:p>
+            <a:pPr indent="0" marL="0">
+              <a:buNone/>
+            </a:pPr>
+            <a:r>
+              <a:rPr lang="en-US" sz="1150" dirty="0">
                 <a:solidFill>
                   <a:srgbClr val="222222"/>
                 </a:solidFill>
@@ -12958,13 +13324,13 @@
               </a:rPr>
               <a:t>Daily and monthly deal activations, BOGOs, and featured products</a:t>
             </a:r>
-            <a:endParaRPr lang="en-US" sz="1300" dirty="0"/>
-          </a:p>
-        </p:txBody>
-      </p:sp>
-      <p:sp>
-        <p:nvSpPr>
-          <p:cNvPr id="24" name="Shape 21"/>
+            <a:endParaRPr lang="en-US" sz="1150" dirty="0"/>
+          </a:p>
+        </p:txBody>
+      </p:sp>
+      <p:sp>
+        <p:nvSpPr>
+          <p:cNvPr id="28" name="Shape 25"/>
           <p:cNvSpPr/>
           <p:nvPr/>
         </p:nvSpPr>
@@ -12991,7 +13357,7 @@
       </p:sp>
       <p:sp>
         <p:nvSpPr>
-          <p:cNvPr id="25" name="Shape 22"/>
+          <p:cNvPr id="29" name="Shape 26"/>
           <p:cNvSpPr/>
           <p:nvPr/>
         </p:nvSpPr>
@@ -13016,7 +13382,7 @@
       </p:sp>
       <p:sp>
         <p:nvSpPr>
-          <p:cNvPr id="26" name="Text 23"/>
+          <p:cNvPr id="30" name="Text 27"/>
           <p:cNvSpPr txBox="1"/>
           <p:nvPr/>
         </p:nvSpPr>
@@ -13055,30 +13421,69 @@
       </p:sp>
       <p:sp>
         <p:nvSpPr>
-          <p:cNvPr id="27" name="Text 24"/>
+          <p:cNvPr id="31" name="Text 28"/>
           <p:cNvSpPr txBox="1"/>
           <p:nvPr/>
         </p:nvSpPr>
         <p:spPr>
           <a:xfrm>
             <a:off x="1325880" y="4550664"/>
-            <a:ext cx="4404208" cy="582168"/>
-          </a:xfrm>
-          <a:prstGeom prst="rect">
-            <a:avLst/>
-          </a:prstGeom>
-          <a:noFill/>
-          <a:ln/>
-        </p:spPr>
-        <p:txBody>
-          <a:bodyPr wrap="square" lIns="0" tIns="0" rIns="0" bIns="0" rtlCol="0" anchor="ctr"/>
-          <a:lstStyle/>
-          <a:p>
-            <a:pPr indent="0" marL="0">
-              <a:buNone/>
-            </a:pPr>
-            <a:r>
-              <a:rPr lang="en-US" sz="1300" dirty="0">
+            <a:ext cx="4404208" cy="274320"/>
+          </a:xfrm>
+          <a:prstGeom prst="rect">
+            <a:avLst/>
+          </a:prstGeom>
+          <a:noFill/>
+          <a:ln/>
+        </p:spPr>
+        <p:txBody>
+          <a:bodyPr wrap="square" lIns="0" tIns="0" rIns="0" bIns="0" rtlCol="0" anchor="t"/>
+          <a:lstStyle/>
+          <a:p>
+            <a:pPr indent="0" marL="0">
+              <a:buNone/>
+            </a:pPr>
+            <a:r>
+              <a:rPr lang="en-US" sz="1350" b="1" dirty="0">
+                <a:solidFill>
+                  <a:srgbClr val="DD5F13"/>
+                </a:solidFill>
+                <a:latin typeface="Calibri" pitchFamily="34" charset="0"/>
+                <a:ea typeface="Calibri" pitchFamily="34" charset="-122"/>
+                <a:cs typeface="Calibri" pitchFamily="34" charset="-120"/>
+              </a:rPr>
+              <a:t>In-house graphics</a:t>
+            </a:r>
+            <a:endParaRPr lang="en-US" sz="1350" dirty="0"/>
+          </a:p>
+        </p:txBody>
+      </p:sp>
+      <p:sp>
+        <p:nvSpPr>
+          <p:cNvPr id="32" name="Text 29"/>
+          <p:cNvSpPr txBox="1"/>
+          <p:nvPr/>
+        </p:nvSpPr>
+        <p:spPr>
+          <a:xfrm>
+            <a:off x="1325880" y="4824984"/>
+            <a:ext cx="4404208" cy="353568"/>
+          </a:xfrm>
+          <a:prstGeom prst="rect">
+            <a:avLst/>
+          </a:prstGeom>
+          <a:noFill/>
+          <a:ln/>
+        </p:spPr>
+        <p:txBody>
+          <a:bodyPr wrap="square" lIns="0" tIns="0" rIns="0" bIns="0" rtlCol="0" anchor="t"/>
+          <a:lstStyle/>
+          <a:p>
+            <a:pPr indent="0" marL="0">
+              <a:buNone/>
+            </a:pPr>
+            <a:r>
+              <a:rPr lang="en-US" sz="1150" dirty="0">
                 <a:solidFill>
                   <a:srgbClr val="222222"/>
                 </a:solidFill>
@@ -13086,15 +13491,15 @@
                 <a:ea typeface="Calibri" pitchFamily="34" charset="-122"/>
                 <a:cs typeface="Calibri" pitchFamily="34" charset="-120"/>
               </a:rPr>
-              <a:t>In-house graphics for headers, deal tiles, and product imagery</a:t>
-            </a:r>
-            <a:endParaRPr lang="en-US" sz="1300" dirty="0"/>
-          </a:p>
-        </p:txBody>
-      </p:sp>
-      <p:sp>
-        <p:nvSpPr>
-          <p:cNvPr id="28" name="Shape 25"/>
+              <a:t>Headers, deal tiles, and product imagery designed for every ad format</a:t>
+            </a:r>
+            <a:endParaRPr lang="en-US" sz="1150" dirty="0"/>
+          </a:p>
+        </p:txBody>
+      </p:sp>
+      <p:sp>
+        <p:nvSpPr>
+          <p:cNvPr id="33" name="Shape 30"/>
           <p:cNvSpPr/>
           <p:nvPr/>
         </p:nvSpPr>
@@ -13121,7 +13526,7 @@
       </p:sp>
       <p:sp>
         <p:nvSpPr>
-          <p:cNvPr id="29" name="Shape 26"/>
+          <p:cNvPr id="34" name="Shape 31"/>
           <p:cNvSpPr/>
           <p:nvPr/>
         </p:nvSpPr>
@@ -13146,7 +13551,7 @@
       </p:sp>
       <p:sp>
         <p:nvSpPr>
-          <p:cNvPr id="30" name="Text 27"/>
+          <p:cNvPr id="35" name="Text 32"/>
           <p:cNvSpPr txBox="1"/>
           <p:nvPr/>
         </p:nvSpPr>
@@ -13185,30 +13590,69 @@
       </p:sp>
       <p:sp>
         <p:nvSpPr>
-          <p:cNvPr id="31" name="Text 28"/>
+          <p:cNvPr id="36" name="Text 33"/>
           <p:cNvSpPr txBox="1"/>
           <p:nvPr/>
         </p:nvSpPr>
         <p:spPr>
           <a:xfrm>
             <a:off x="7010248" y="4550664"/>
-            <a:ext cx="4404208" cy="582168"/>
-          </a:xfrm>
-          <a:prstGeom prst="rect">
-            <a:avLst/>
-          </a:prstGeom>
-          <a:noFill/>
-          <a:ln/>
-        </p:spPr>
-        <p:txBody>
-          <a:bodyPr wrap="square" lIns="0" tIns="0" rIns="0" bIns="0" rtlCol="0" anchor="ctr"/>
-          <a:lstStyle/>
-          <a:p>
-            <a:pPr indent="0" marL="0">
-              <a:buNone/>
-            </a:pPr>
-            <a:r>
-              <a:rPr lang="en-US" sz="1300" dirty="0">
+            <a:ext cx="4404208" cy="274320"/>
+          </a:xfrm>
+          <a:prstGeom prst="rect">
+            <a:avLst/>
+          </a:prstGeom>
+          <a:noFill/>
+          <a:ln/>
+        </p:spPr>
+        <p:txBody>
+          <a:bodyPr wrap="square" lIns="0" tIns="0" rIns="0" bIns="0" rtlCol="0" anchor="t"/>
+          <a:lstStyle/>
+          <a:p>
+            <a:pPr indent="0" marL="0">
+              <a:buNone/>
+            </a:pPr>
+            <a:r>
+              <a:rPr lang="en-US" sz="1350" b="1" dirty="0">
+                <a:solidFill>
+                  <a:srgbClr val="DD5F13"/>
+                </a:solidFill>
+                <a:latin typeface="Calibri" pitchFamily="34" charset="0"/>
+                <a:ea typeface="Calibri" pitchFamily="34" charset="-122"/>
+                <a:cs typeface="Calibri" pitchFamily="34" charset="-120"/>
+              </a:rPr>
+              <a:t>Review management</a:t>
+            </a:r>
+            <a:endParaRPr lang="en-US" sz="1350" dirty="0"/>
+          </a:p>
+        </p:txBody>
+      </p:sp>
+      <p:sp>
+        <p:nvSpPr>
+          <p:cNvPr id="37" name="Text 34"/>
+          <p:cNvSpPr txBox="1"/>
+          <p:nvPr/>
+        </p:nvSpPr>
+        <p:spPr>
+          <a:xfrm>
+            <a:off x="7010248" y="4824984"/>
+            <a:ext cx="4404208" cy="353568"/>
+          </a:xfrm>
+          <a:prstGeom prst="rect">
+            <a:avLst/>
+          </a:prstGeom>
+          <a:noFill/>
+          <a:ln/>
+        </p:spPr>
+        <p:txBody>
+          <a:bodyPr wrap="square" lIns="0" tIns="0" rIns="0" bIns="0" rtlCol="0" anchor="t"/>
+          <a:lstStyle/>
+          <a:p>
+            <a:pPr indent="0" marL="0">
+              <a:buNone/>
+            </a:pPr>
+            <a:r>
+              <a:rPr lang="en-US" sz="1150" dirty="0">
                 <a:solidFill>
                   <a:srgbClr val="222222"/>
                 </a:solidFill>
@@ -13216,15 +13660,15 @@
                 <a:ea typeface="Calibri" pitchFamily="34" charset="-122"/>
                 <a:cs typeface="Calibri" pitchFamily="34" charset="-120"/>
               </a:rPr>
-              <a:t>Same-day review responses and removal requests for policy-breaking reviews</a:t>
-            </a:r>
-            <a:endParaRPr lang="en-US" sz="1300" dirty="0"/>
-          </a:p>
-        </p:txBody>
-      </p:sp>
-      <p:sp>
-        <p:nvSpPr>
-          <p:cNvPr id="32" name="Shape 29"/>
+              <a:t>Same-day responses and removal requests for policy-breaking reviews</a:t>
+            </a:r>
+            <a:endParaRPr lang="en-US" sz="1150" dirty="0"/>
+          </a:p>
+        </p:txBody>
+      </p:sp>
+      <p:sp>
+        <p:nvSpPr>
+          <p:cNvPr id="38" name="Shape 35"/>
           <p:cNvSpPr/>
           <p:nvPr/>
         </p:nvSpPr>
@@ -13251,7 +13695,7 @@
       </p:sp>
       <p:sp>
         <p:nvSpPr>
-          <p:cNvPr id="33" name="Shape 30"/>
+          <p:cNvPr id="39" name="Shape 36"/>
           <p:cNvSpPr/>
           <p:nvPr/>
         </p:nvSpPr>
@@ -13276,7 +13720,7 @@
       </p:sp>
       <p:sp>
         <p:nvSpPr>
-          <p:cNvPr id="34" name="Text 31"/>
+          <p:cNvPr id="40" name="Text 37"/>
           <p:cNvSpPr txBox="1"/>
           <p:nvPr/>
         </p:nvSpPr>
@@ -13315,30 +13759,69 @@
       </p:sp>
       <p:sp>
         <p:nvSpPr>
-          <p:cNvPr id="35" name="Text 32"/>
+          <p:cNvPr id="41" name="Text 38"/>
           <p:cNvSpPr txBox="1"/>
           <p:nvPr/>
         </p:nvSpPr>
         <p:spPr>
           <a:xfrm>
             <a:off x="1325880" y="5452872"/>
-            <a:ext cx="4404208" cy="582168"/>
-          </a:xfrm>
-          <a:prstGeom prst="rect">
-            <a:avLst/>
-          </a:prstGeom>
-          <a:noFill/>
-          <a:ln/>
-        </p:spPr>
-        <p:txBody>
-          <a:bodyPr wrap="square" lIns="0" tIns="0" rIns="0" bIns="0" rtlCol="0" anchor="ctr"/>
-          <a:lstStyle/>
-          <a:p>
-            <a:pPr indent="0" marL="0">
-              <a:buNone/>
-            </a:pPr>
-            <a:r>
-              <a:rPr lang="en-US" sz="1300" dirty="0">
+            <a:ext cx="4404208" cy="274320"/>
+          </a:xfrm>
+          <a:prstGeom prst="rect">
+            <a:avLst/>
+          </a:prstGeom>
+          <a:noFill/>
+          <a:ln/>
+        </p:spPr>
+        <p:txBody>
+          <a:bodyPr wrap="square" lIns="0" tIns="0" rIns="0" bIns="0" rtlCol="0" anchor="t"/>
+          <a:lstStyle/>
+          <a:p>
+            <a:pPr indent="0" marL="0">
+              <a:buNone/>
+            </a:pPr>
+            <a:r>
+              <a:rPr lang="en-US" sz="1350" b="1" dirty="0">
+                <a:solidFill>
+                  <a:srgbClr val="DD5F13"/>
+                </a:solidFill>
+                <a:latin typeface="Calibri" pitchFamily="34" charset="0"/>
+                <a:ea typeface="Calibri" pitchFamily="34" charset="-122"/>
+                <a:cs typeface="Calibri" pitchFamily="34" charset="-120"/>
+              </a:rPr>
+              <a:t>Brand page management</a:t>
+            </a:r>
+            <a:endParaRPr lang="en-US" sz="1350" dirty="0"/>
+          </a:p>
+        </p:txBody>
+      </p:sp>
+      <p:sp>
+        <p:nvSpPr>
+          <p:cNvPr id="42" name="Text 39"/>
+          <p:cNvSpPr txBox="1"/>
+          <p:nvPr/>
+        </p:nvSpPr>
+        <p:spPr>
+          <a:xfrm>
+            <a:off x="1325880" y="5727192"/>
+            <a:ext cx="4404208" cy="353568"/>
+          </a:xfrm>
+          <a:prstGeom prst="rect">
+            <a:avLst/>
+          </a:prstGeom>
+          <a:noFill/>
+          <a:ln/>
+        </p:spPr>
+        <p:txBody>
+          <a:bodyPr wrap="square" lIns="0" tIns="0" rIns="0" bIns="0" rtlCol="0" anchor="t"/>
+          <a:lstStyle/>
+          <a:p>
+            <a:pPr indent="0" marL="0">
+              <a:buNone/>
+            </a:pPr>
+            <a:r>
+              <a:rPr lang="en-US" sz="1150" dirty="0">
                 <a:solidFill>
                   <a:srgbClr val="222222"/>
                 </a:solidFill>
@@ -13346,15 +13829,15 @@
                 <a:ea typeface="Calibri" pitchFamily="34" charset="-122"/>
                 <a:cs typeface="Calibri" pitchFamily="34" charset="-120"/>
               </a:rPr>
-              <a:t>Brand page management for retailers who also own a brand</a:t>
-            </a:r>
-            <a:endParaRPr lang="en-US" sz="1300" dirty="0"/>
-          </a:p>
-        </p:txBody>
-      </p:sp>
-      <p:sp>
-        <p:nvSpPr>
-          <p:cNvPr id="36" name="Shape 33"/>
+              <a:t>Brand page, retailer map, and product catalog for retailers who also own a brand</a:t>
+            </a:r>
+            <a:endParaRPr lang="en-US" sz="1150" dirty="0"/>
+          </a:p>
+        </p:txBody>
+      </p:sp>
+      <p:sp>
+        <p:nvSpPr>
+          <p:cNvPr id="43" name="Shape 40"/>
           <p:cNvSpPr/>
           <p:nvPr/>
         </p:nvSpPr>
@@ -13381,7 +13864,7 @@
       </p:sp>
       <p:sp>
         <p:nvSpPr>
-          <p:cNvPr id="37" name="Shape 34"/>
+          <p:cNvPr id="44" name="Shape 41"/>
           <p:cNvSpPr/>
           <p:nvPr/>
         </p:nvSpPr>
@@ -13406,7 +13889,7 @@
       </p:sp>
       <p:sp>
         <p:nvSpPr>
-          <p:cNvPr id="38" name="Text 35"/>
+          <p:cNvPr id="45" name="Text 42"/>
           <p:cNvSpPr txBox="1"/>
           <p:nvPr/>
         </p:nvSpPr>
@@ -13445,30 +13928,69 @@
       </p:sp>
       <p:sp>
         <p:nvSpPr>
-          <p:cNvPr id="39" name="Text 36"/>
+          <p:cNvPr id="46" name="Text 43"/>
           <p:cNvSpPr txBox="1"/>
           <p:nvPr/>
         </p:nvSpPr>
         <p:spPr>
           <a:xfrm>
             <a:off x="7010248" y="5452872"/>
-            <a:ext cx="4404208" cy="582168"/>
-          </a:xfrm>
-          <a:prstGeom prst="rect">
-            <a:avLst/>
-          </a:prstGeom>
-          <a:noFill/>
-          <a:ln/>
-        </p:spPr>
-        <p:txBody>
-          <a:bodyPr wrap="square" lIns="0" tIns="0" rIns="0" bIns="0" rtlCol="0" anchor="ctr"/>
-          <a:lstStyle/>
-          <a:p>
-            <a:pPr indent="0" marL="0">
-              <a:buNone/>
-            </a:pPr>
-            <a:r>
-              <a:rPr lang="en-US" sz="1300" dirty="0">
+            <a:ext cx="4404208" cy="274320"/>
+          </a:xfrm>
+          <a:prstGeom prst="rect">
+            <a:avLst/>
+          </a:prstGeom>
+          <a:noFill/>
+          <a:ln/>
+        </p:spPr>
+        <p:txBody>
+          <a:bodyPr wrap="square" lIns="0" tIns="0" rIns="0" bIns="0" rtlCol="0" anchor="t"/>
+          <a:lstStyle/>
+          <a:p>
+            <a:pPr indent="0" marL="0">
+              <a:buNone/>
+            </a:pPr>
+            <a:r>
+              <a:rPr lang="en-US" sz="1350" b="1" dirty="0">
+                <a:solidFill>
+                  <a:srgbClr val="DD5F13"/>
+                </a:solidFill>
+                <a:latin typeface="Calibri" pitchFamily="34" charset="0"/>
+                <a:ea typeface="Calibri" pitchFamily="34" charset="-122"/>
+                <a:cs typeface="Calibri" pitchFamily="34" charset="-120"/>
+              </a:rPr>
+              <a:t>Weekly reporting</a:t>
+            </a:r>
+            <a:endParaRPr lang="en-US" sz="1350" dirty="0"/>
+          </a:p>
+        </p:txBody>
+      </p:sp>
+      <p:sp>
+        <p:nvSpPr>
+          <p:cNvPr id="47" name="Text 44"/>
+          <p:cNvSpPr txBox="1"/>
+          <p:nvPr/>
+        </p:nvSpPr>
+        <p:spPr>
+          <a:xfrm>
+            <a:off x="7010248" y="5727192"/>
+            <a:ext cx="4404208" cy="353568"/>
+          </a:xfrm>
+          <a:prstGeom prst="rect">
+            <a:avLst/>
+          </a:prstGeom>
+          <a:noFill/>
+          <a:ln/>
+        </p:spPr>
+        <p:txBody>
+          <a:bodyPr wrap="square" lIns="0" tIns="0" rIns="0" bIns="0" rtlCol="0" anchor="t"/>
+          <a:lstStyle/>
+          <a:p>
+            <a:pPr indent="0" marL="0">
+              <a:buNone/>
+            </a:pPr>
+            <a:r>
+              <a:rPr lang="en-US" sz="1150" dirty="0">
                 <a:solidFill>
                   <a:srgbClr val="222222"/>
                 </a:solidFill>
@@ -13476,9 +13998,9 @@
                 <a:ea typeface="Calibri" pitchFamily="34" charset="-122"/>
                 <a:cs typeface="Calibri" pitchFamily="34" charset="-120"/>
               </a:rPr>
-              <a:t>Weekly performance reporting with POS-attributed revenue</a:t>
-            </a:r>
-            <a:endParaRPr lang="en-US" sz="1300" dirty="0"/>
+              <a:t>Performance reporting with POS-attributed revenue and ROAS</a:t>
+            </a:r>
+            <a:endParaRPr lang="en-US" sz="1150" dirty="0"/>
           </a:p>
         </p:txBody>
       </p:sp>

</xml_diff>

<commit_message>
Rework investment slide into three pricing cards
Weedmaps Management ($995/mo or 10% of ad spend), Listing Bundle ($495/mo
or 10%), and Total Package ($1,490/mo or 10%) highlighted as recommended.
Cards support an "alt" line for the 10% stipulation and a "recommended"
flag; the next-steps summary now mirrors the cards.

Co-Authored-By: Claude Fable 5.1 <noreply@anthropic.com>
Claude-Session: https://claude.ai/code/session_01RhvxWoxVegp3rGjZ4khBZo
</commit_message>
<xml_diff>
--- a/decks/Sparks-x-example-green-valley.pptx
+++ b/decks/Sparks-x-example-green-valley.pptx
@@ -8552,7 +8552,7 @@
                 <a:ea typeface="Calibri" pitchFamily="34" charset="-122"/>
                 <a:cs typeface="Calibri" pitchFamily="34" charset="-120"/>
               </a:rPr>
-              <a:t>Weedmaps · Launch</a:t>
+              <a:t>Launch</a:t>
             </a:r>
             <a:endParaRPr lang="en-US" sz="1200" dirty="0"/>
           </a:p>
@@ -8630,7 +8630,7 @@
                 <a:ea typeface="Calibri" pitchFamily="34" charset="-122"/>
                 <a:cs typeface="Calibri" pitchFamily="34" charset="-120"/>
               </a:rPr>
-              <a:t>Weedmaps · Growth</a:t>
+              <a:t>Growth</a:t>
             </a:r>
             <a:endParaRPr lang="en-US" sz="1200" dirty="0"/>
           </a:p>
@@ -8708,7 +8708,7 @@
                 <a:ea typeface="Calibri" pitchFamily="34" charset="-122"/>
                 <a:cs typeface="Calibri" pitchFamily="34" charset="-120"/>
               </a:rPr>
-              <a:t>Weedmaps · Dominate</a:t>
+              <a:t>Dominate</a:t>
             </a:r>
             <a:endParaRPr lang="en-US" sz="1200" dirty="0"/>
           </a:p>
@@ -16206,12 +16206,12 @@
         </p:nvSpPr>
         <p:spPr>
           <a:xfrm>
-            <a:off x="548640" y="2331720"/>
-            <a:ext cx="3515258" cy="2651760"/>
+            <a:off x="548640" y="2286000"/>
+            <a:ext cx="3515258" cy="2880360"/>
           </a:xfrm>
           <a:prstGeom prst="roundRect">
             <a:avLst>
-              <a:gd name="adj" fmla="val 4138"/>
+              <a:gd name="adj" fmla="val 3810"/>
             </a:avLst>
           </a:prstGeom>
           <a:solidFill>
@@ -16233,7 +16233,7 @@
         </p:nvSpPr>
         <p:spPr>
           <a:xfrm>
-            <a:off x="868680" y="2560320"/>
+            <a:off x="868680" y="2514600"/>
             <a:ext cx="2875178" cy="365760"/>
           </a:xfrm>
           <a:prstGeom prst="rect">
@@ -16243,7 +16243,7 @@
           <a:ln/>
         </p:spPr>
         <p:txBody>
-          <a:bodyPr wrap="square" lIns="0" tIns="0" rIns="0" bIns="0" rtlCol="0" anchor="t"/>
+          <a:bodyPr wrap="square" lIns="0" tIns="0" rIns="0" bIns="0" rtlCol="0" anchor="ctr"/>
           <a:lstStyle/>
           <a:p>
             <a:pPr indent="0" marL="0">
@@ -16273,7 +16273,7 @@
         <p:spPr>
           <a:xfrm>
             <a:off x="868680" y="2926080"/>
-            <a:ext cx="2875178" cy="822960"/>
+            <a:ext cx="2875178" cy="731520"/>
           </a:xfrm>
           <a:prstGeom prst="rect">
             <a:avLst/>
@@ -16289,7 +16289,7 @@
               <a:buNone/>
             </a:pPr>
             <a:r>
-              <a:rPr lang="en-US" sz="3400" b="1" dirty="0">
+              <a:rPr lang="en-US" sz="3600" b="1" dirty="0">
                 <a:solidFill>
                   <a:srgbClr val="222222"/>
                 </a:solidFill>
@@ -16299,7 +16299,7 @@
               </a:rPr>
               <a:t>Custom</a:t>
             </a:r>
-            <a:endParaRPr lang="en-US" sz="3400" dirty="0"/>
+            <a:endParaRPr lang="en-US" sz="3600" dirty="0"/>
           </a:p>
         </p:txBody>
       </p:sp>
@@ -16311,8 +16311,8 @@
         </p:nvSpPr>
         <p:spPr>
           <a:xfrm>
-            <a:off x="868680" y="3840480"/>
-            <a:ext cx="2875178" cy="1051560"/>
+            <a:off x="868680" y="3749040"/>
+            <a:ext cx="2875178" cy="1280160"/>
           </a:xfrm>
           <a:prstGeom prst="rect">
             <a:avLst/>
@@ -16350,12 +16350,12 @@
         </p:nvSpPr>
         <p:spPr>
           <a:xfrm>
-            <a:off x="4338218" y="2331720"/>
-            <a:ext cx="3515258" cy="2651760"/>
+            <a:off x="4338218" y="2286000"/>
+            <a:ext cx="3515258" cy="2880360"/>
           </a:xfrm>
           <a:prstGeom prst="roundRect">
             <a:avLst>
-              <a:gd name="adj" fmla="val 4138"/>
+              <a:gd name="adj" fmla="val 3810"/>
             </a:avLst>
           </a:prstGeom>
           <a:solidFill>
@@ -16377,7 +16377,7 @@
         </p:nvSpPr>
         <p:spPr>
           <a:xfrm>
-            <a:off x="4658258" y="2560320"/>
+            <a:off x="4658258" y="2514600"/>
             <a:ext cx="2875178" cy="365760"/>
           </a:xfrm>
           <a:prstGeom prst="rect">
@@ -16387,7 +16387,7 @@
           <a:ln/>
         </p:spPr>
         <p:txBody>
-          <a:bodyPr wrap="square" lIns="0" tIns="0" rIns="0" bIns="0" rtlCol="0" anchor="t"/>
+          <a:bodyPr wrap="square" lIns="0" tIns="0" rIns="0" bIns="0" rtlCol="0" anchor="ctr"/>
           <a:lstStyle/>
           <a:p>
             <a:pPr indent="0" marL="0">
@@ -16417,7 +16417,7 @@
         <p:spPr>
           <a:xfrm>
             <a:off x="4658258" y="2926080"/>
-            <a:ext cx="2875178" cy="822960"/>
+            <a:ext cx="2875178" cy="731520"/>
           </a:xfrm>
           <a:prstGeom prst="rect">
             <a:avLst/>
@@ -16433,7 +16433,7 @@
               <a:buNone/>
             </a:pPr>
             <a:r>
-              <a:rPr lang="en-US" sz="3400" b="1" dirty="0">
+              <a:rPr lang="en-US" sz="3600" b="1" dirty="0">
                 <a:solidFill>
                   <a:srgbClr val="222222"/>
                 </a:solidFill>
@@ -16443,7 +16443,7 @@
               </a:rPr>
               <a:t>Custom</a:t>
             </a:r>
-            <a:endParaRPr lang="en-US" sz="3400" dirty="0"/>
+            <a:endParaRPr lang="en-US" sz="3600" dirty="0"/>
           </a:p>
         </p:txBody>
       </p:sp>
@@ -16455,8 +16455,8 @@
         </p:nvSpPr>
         <p:spPr>
           <a:xfrm>
-            <a:off x="4658258" y="3840480"/>
-            <a:ext cx="2875178" cy="1051560"/>
+            <a:off x="4658258" y="3749040"/>
+            <a:ext cx="2875178" cy="1280160"/>
           </a:xfrm>
           <a:prstGeom prst="rect">
             <a:avLst/>
@@ -16494,12 +16494,12 @@
         </p:nvSpPr>
         <p:spPr>
           <a:xfrm>
-            <a:off x="8127797" y="2331720"/>
-            <a:ext cx="3515258" cy="2651760"/>
+            <a:off x="8127797" y="2286000"/>
+            <a:ext cx="3515258" cy="2880360"/>
           </a:xfrm>
           <a:prstGeom prst="roundRect">
             <a:avLst>
-              <a:gd name="adj" fmla="val 4138"/>
+              <a:gd name="adj" fmla="val 3810"/>
             </a:avLst>
           </a:prstGeom>
           <a:solidFill>
@@ -16521,7 +16521,7 @@
         </p:nvSpPr>
         <p:spPr>
           <a:xfrm>
-            <a:off x="8447837" y="2560320"/>
+            <a:off x="8447837" y="2514600"/>
             <a:ext cx="2875178" cy="365760"/>
           </a:xfrm>
           <a:prstGeom prst="rect">
@@ -16531,7 +16531,7 @@
           <a:ln/>
         </p:spPr>
         <p:txBody>
-          <a:bodyPr wrap="square" lIns="0" tIns="0" rIns="0" bIns="0" rtlCol="0" anchor="t"/>
+          <a:bodyPr wrap="square" lIns="0" tIns="0" rIns="0" bIns="0" rtlCol="0" anchor="ctr"/>
           <a:lstStyle/>
           <a:p>
             <a:pPr indent="0" marL="0">
@@ -16561,7 +16561,7 @@
         <p:spPr>
           <a:xfrm>
             <a:off x="8447837" y="2926080"/>
-            <a:ext cx="2875178" cy="822960"/>
+            <a:ext cx="2875178" cy="731520"/>
           </a:xfrm>
           <a:prstGeom prst="rect">
             <a:avLst/>
@@ -16577,7 +16577,7 @@
               <a:buNone/>
             </a:pPr>
             <a:r>
-              <a:rPr lang="en-US" sz="3400" b="1" dirty="0">
+              <a:rPr lang="en-US" sz="3600" b="1" dirty="0">
                 <a:solidFill>
                   <a:srgbClr val="222222"/>
                 </a:solidFill>
@@ -16587,7 +16587,7 @@
               </a:rPr>
               <a:t>Custom</a:t>
             </a:r>
-            <a:endParaRPr lang="en-US" sz="3400" dirty="0"/>
+            <a:endParaRPr lang="en-US" sz="3600" dirty="0"/>
           </a:p>
         </p:txBody>
       </p:sp>
@@ -16599,8 +16599,8 @@
         </p:nvSpPr>
         <p:spPr>
           <a:xfrm>
-            <a:off x="8447837" y="3840480"/>
-            <a:ext cx="2875178" cy="1051560"/>
+            <a:off x="8447837" y="3749040"/>
+            <a:ext cx="2875178" cy="1280160"/>
           </a:xfrm>
           <a:prstGeom prst="rect">
             <a:avLst/>
@@ -16638,8 +16638,8 @@
         </p:nvSpPr>
         <p:spPr>
           <a:xfrm>
-            <a:off x="548640" y="5212080"/>
-            <a:ext cx="5943600" cy="365760"/>
+            <a:off x="548640" y="5276088"/>
+            <a:ext cx="6858000" cy="365760"/>
           </a:xfrm>
           <a:prstGeom prst="rect">
             <a:avLst/>
@@ -16655,7 +16655,7 @@
               <a:buNone/>
             </a:pPr>
             <a:r>
-              <a:rPr lang="en-US" sz="1500" b="1" dirty="0">
+              <a:rPr lang="en-US" sz="1400" b="1" dirty="0">
                 <a:solidFill>
                   <a:srgbClr val="FFFFFF"/>
                 </a:solidFill>
@@ -16665,7 +16665,7 @@
               </a:rPr>
               <a:t>Results in 30 days or your money back.</a:t>
             </a:r>
-            <a:endParaRPr lang="en-US" sz="1500" dirty="0"/>
+            <a:endParaRPr lang="en-US" sz="1400" dirty="0"/>
           </a:p>
         </p:txBody>
       </p:sp>
@@ -16677,8 +16677,8 @@
         </p:nvSpPr>
         <p:spPr>
           <a:xfrm>
-            <a:off x="548640" y="5577840"/>
-            <a:ext cx="5943600" cy="457200"/>
+            <a:off x="548640" y="5660136"/>
+            <a:ext cx="6858000" cy="365760"/>
           </a:xfrm>
           <a:prstGeom prst="rect">
             <a:avLst/>
@@ -16694,7 +16694,7 @@
               <a:buNone/>
             </a:pPr>
             <a:r>
-              <a:rPr lang="en-US" sz="1100" i="1" dirty="0">
+              <a:rPr lang="en-US" sz="1050" i="1" dirty="0">
                 <a:solidFill>
                   <a:srgbClr val="FFE3D0"/>
                 </a:solidFill>
@@ -16704,7 +16704,7 @@
               </a:rPr>
               <a:t>Ad spend billed directly by platforms; Sparks manages allocation.</a:t>
             </a:r>
-            <a:endParaRPr lang="en-US" sz="1100" dirty="0"/>
+            <a:endParaRPr lang="en-US" sz="1050" dirty="0"/>
           </a:p>
         </p:txBody>
       </p:sp>

</xml_diff>

<commit_message>
Phone-mockup audit slide, directories tile, Yelp Ads removed, 20 directories
- Audit slide: iPhone mockup of the worst listing with numbered callouts
  (prospect.audit_mock) plus fleet-wide findings; real screenshot supported
- Solution slide: fifth "+20 directories" tile
- Yelp copy no longer pitches Yelp Ads (not available to cannabis); Yelp
  recognition wording updated everywhere
- "All four platforms + 20 directories" (was 50) across deck and docs
- Next-steps summary marks the Listing Bundle as optional

Co-Authored-By: Claude Fable 5.1 <noreply@anthropic.com>
Claude-Session: https://claude.ai/code/session_01RhvxWoxVegp3rGjZ4khBZo
</commit_message>
<xml_diff>
--- a/decks/Sparks-x-example-green-valley.pptx
+++ b/decks/Sparks-x-example-green-valley.pptx
@@ -692,7 +692,7 @@
           <a:p>
             <a:r>
               <a:rPr lang="en-US" dirty="0"/>
-              <a:t>Yelp Management is included in this proposal. Scope notes: Yelp Ads (Certified Partner), profile optimization, review responses and removal requests, lead tracking..</a:t>
+              <a:t>Yelp Management is included in this proposal. Scope notes: Profile optimization, review responses and removal requests, lead tracking..</a:t>
             </a:r>
             <a:endParaRPr lang="en-US" dirty="0"/>
           </a:p>
@@ -3968,7 +3968,7 @@
                 <a:ea typeface="Calibri" pitchFamily="34" charset="-122"/>
                 <a:cs typeface="Calibri" pitchFamily="34" charset="-120"/>
               </a:rPr>
-              <a:t>Where reviews decide, and where Sparks is a Yelp Ads Certified Partner.</a:t>
+              <a:t>Where reviews decide, and where Sparks is one of the few cannabis partners recognized by Yelp.</a:t>
             </a:r>
             <a:endParaRPr lang="en-US" sz="1500" dirty="0"/>
           </a:p>
@@ -4237,7 +4237,7 @@
                 <a:ea typeface="Calibri" pitchFamily="34" charset="-122"/>
                 <a:cs typeface="Calibri" pitchFamily="34" charset="-120"/>
               </a:rPr>
-              <a:t>Yelp Ads reach comparison shoppers</a:t>
+              <a:t>Yelp ranks in Google too</a:t>
             </a:r>
             <a:endParaRPr lang="en-US" sz="1400" dirty="0"/>
           </a:p>
@@ -4276,7 +4276,7 @@
                 <a:ea typeface="Calibri" pitchFamily="34" charset="-122"/>
                 <a:cs typeface="Calibri" pitchFamily="34" charset="-120"/>
               </a:rPr>
-              <a:t>Yelp Ads put your store in front of people actively comparing dispensaries. Sparks is one of the few cannabis partners recognized by Yelp.</a:t>
+              <a:t>Your Yelp page often outranks your own site for your store name. A complete, current profile is what people see before they ever reach your menu.</a:t>
             </a:r>
             <a:endParaRPr lang="en-US" sz="1100" dirty="0"/>
           </a:p>
@@ -4535,7 +4535,7 @@
                 <a:ea typeface="Calibri" pitchFamily="34" charset="-122"/>
                 <a:cs typeface="Calibri" pitchFamily="34" charset="-120"/>
               </a:rPr>
-              <a:t>4 unanswered 1-star reviews; no Yelp Ads</a:t>
+              <a:t>4 unanswered 1-star reviews; profile incomplete</a:t>
             </a:r>
             <a:endParaRPr lang="en-US" sz="1050" dirty="0"/>
           </a:p>
@@ -4644,7 +4644,7 @@
                 <a:ea typeface="Calibri" pitchFamily="34" charset="-122"/>
                 <a:cs typeface="Calibri" pitchFamily="34" charset="-120"/>
               </a:rPr>
-              <a:t>Yelp Ads</a:t>
+              <a:t>Profile optimization</a:t>
             </a:r>
             <a:pPr indent="0" marL="0">
               <a:buNone/>
@@ -4658,7 +4658,7 @@
                 <a:ea typeface="Calibri" pitchFamily="34" charset="-122"/>
                 <a:cs typeface="Calibri" pitchFamily="34" charset="-120"/>
               </a:rPr>
-              <a:t> — Campaigns run through Sparks' Yelp Ads Certified Partner access</a:t>
+              <a:t> — Photos, categories, hours, highlights, and business details kept complete and current</a:t>
             </a:r>
             <a:endParaRPr lang="en-US" sz="1000" dirty="0"/>
           </a:p>
@@ -4679,7 +4679,7 @@
                 <a:ea typeface="Calibri" pitchFamily="34" charset="-122"/>
                 <a:cs typeface="Calibri" pitchFamily="34" charset="-120"/>
               </a:rPr>
-              <a:t>Profile optimization</a:t>
+              <a:t>Review management</a:t>
             </a:r>
             <a:pPr indent="0" marL="0">
               <a:buNone/>
@@ -4693,7 +4693,7 @@
                 <a:ea typeface="Calibri" pitchFamily="34" charset="-122"/>
                 <a:cs typeface="Calibri" pitchFamily="34" charset="-120"/>
               </a:rPr>
-              <a:t> — Photos, categories, hours, and highlights</a:t>
+              <a:t> — Responses and removal requests for guideline-breaking reviews through Sparks' recognized partner access</a:t>
             </a:r>
             <a:endParaRPr lang="en-US" sz="1000" dirty="0"/>
           </a:p>
@@ -4714,7 +4714,7 @@
                 <a:ea typeface="Calibri" pitchFamily="34" charset="-122"/>
                 <a:cs typeface="Calibri" pitchFamily="34" charset="-120"/>
               </a:rPr>
-              <a:t>Review management</a:t>
+              <a:t>Lead tracking</a:t>
             </a:r>
             <a:pPr indent="0" marL="0">
               <a:buNone/>
@@ -4728,7 +4728,7 @@
                 <a:ea typeface="Calibri" pitchFamily="34" charset="-122"/>
                 <a:cs typeface="Calibri" pitchFamily="34" charset="-120"/>
               </a:rPr>
-              <a:t> — Responses and removal requests for guideline-breaking reviews</a:t>
+              <a:t> — Calls, direction requests, and site visits attributed to Yelp</a:t>
             </a:r>
             <a:endParaRPr lang="en-US" sz="1000" dirty="0"/>
           </a:p>
@@ -4749,7 +4749,7 @@
                 <a:ea typeface="Calibri" pitchFamily="34" charset="-122"/>
                 <a:cs typeface="Calibri" pitchFamily="34" charset="-120"/>
               </a:rPr>
-              <a:t>Lead tracking</a:t>
+              <a:t>Content &amp; updates</a:t>
             </a:r>
             <a:pPr indent="0" marL="0">
               <a:buNone/>
@@ -4763,7 +4763,7 @@
                 <a:ea typeface="Calibri" pitchFamily="34" charset="-122"/>
                 <a:cs typeface="Calibri" pitchFamily="34" charset="-120"/>
               </a:rPr>
-              <a:t> — Calls, direction requests, and site visits attributed to Yelp</a:t>
+              <a:t> — Specials, announcements, and photo refreshes to keep the page active</a:t>
             </a:r>
             <a:endParaRPr lang="en-US" sz="1000" dirty="0"/>
           </a:p>
@@ -5678,7 +5678,7 @@
                 <a:ea typeface="Calibri" pitchFamily="34" charset="-122"/>
                 <a:cs typeface="Calibri" pitchFamily="34" charset="-120"/>
               </a:rPr>
-              <a:t>Consistent name, address, and phone across 50+ directories is what tells Google (and Siri and Alexa) that your store is the real one.</a:t>
+              <a:t>Consistent name, address, and phone across 20+ directories is what tells Google (and Siri and Alexa) that your store is the real one.</a:t>
             </a:r>
             <a:endParaRPr lang="en-US" sz="1100" dirty="0"/>
           </a:p>
@@ -6011,7 +6011,7 @@
                 <a:ea typeface="Calibri" pitchFamily="34" charset="-122"/>
                 <a:cs typeface="Calibri" pitchFamily="34" charset="-120"/>
               </a:rPr>
-              <a:t> — NAP consistency across 50+ directories</a:t>
+              <a:t> — NAP consistency across 20+ directories</a:t>
             </a:r>
             <a:endParaRPr lang="en-US" sz="1000" dirty="0"/>
           </a:p>
@@ -6740,7 +6740,7 @@
                 <a:ea typeface="Calibri" pitchFamily="34" charset="-122"/>
                 <a:cs typeface="Calibri" pitchFamily="34" charset="-120"/>
               </a:rPr>
-              <a:t>All four platforms + 50 directories</a:t>
+              <a:t>All four platforms + 20 directories</a:t>
             </a:r>
             <a:endParaRPr lang="en-US" sz="1600" dirty="0"/>
           </a:p>
@@ -6779,7 +6779,7 @@
                 <a:ea typeface="Calibri" pitchFamily="34" charset="-122"/>
                 <a:cs typeface="Calibri" pitchFamily="34" charset="-120"/>
               </a:rPr>
-              <a:t>One team, one strategy, one report across Weedmaps, Leafly, Yelp, Google and every citation that feeds local SEO.</a:t>
+              <a:t>One team, one strategy, one report across Weedmaps, Leafly, Yelp, Google and 20+ directories that feed local SEO.</a:t>
             </a:r>
             <a:endParaRPr lang="en-US" sz="1200" dirty="0"/>
           </a:p>
@@ -7087,7 +7087,7 @@
                 <a:ea typeface="Calibri" pitchFamily="34" charset="-122"/>
                 <a:cs typeface="Calibri" pitchFamily="34" charset="-120"/>
               </a:rPr>
-              <a:t>Top Cannabis Listing Management Agency 2026 (Cannabis Business Insights). Yelp Ads Certified Partner. 100+ businesses managed.</a:t>
+              <a:t>Top Cannabis Listing Management Agency 2026 (Cannabis Business Insights). One of the few cannabis partners recognized by Yelp. 100+ businesses managed.</a:t>
             </a:r>
             <a:endParaRPr lang="en-US" sz="1200" dirty="0"/>
           </a:p>
@@ -10184,7 +10184,7 @@
                 <a:ea typeface="Calibri" pitchFamily="34" charset="-122"/>
                 <a:cs typeface="Calibri" pitchFamily="34" charset="-120"/>
               </a:rPr>
-              <a:t>Full-service listing management: spend, listings, menus, reviews, deals, creative and data — handled by ex-Weedmaps operators. Start with the platform that matters most, add the rest when you're ready.</a:t>
+              <a:t>Full-service listing management: spend, listings, menus, reviews, deals, creative and data — handled by ex-Weedmaps operators. Start with the platform that matters most, add the rest (plus 20+ directories for local SEO) when you're ready.</a:t>
             </a:r>
             <a:endParaRPr lang="en-US" sz="1500" dirty="0"/>
           </a:p>
@@ -10198,7 +10198,7 @@
         </p:nvSpPr>
         <p:spPr>
           <a:xfrm>
-            <a:off x="4556455" y="4526280"/>
+            <a:off x="2727655" y="4526280"/>
             <a:ext cx="1600200" cy="1554480"/>
           </a:xfrm>
           <a:prstGeom prst="roundRect">
@@ -10233,7 +10233,7 @@
         </p:blipFill>
         <p:spPr>
           <a:xfrm>
-            <a:off x="5082235" y="4709160"/>
+            <a:off x="3253435" y="4709160"/>
             <a:ext cx="548640" cy="548640"/>
           </a:xfrm>
           <a:prstGeom prst="rect">
@@ -10249,7 +10249,7 @@
         </p:nvSpPr>
         <p:spPr>
           <a:xfrm>
-            <a:off x="4556455" y="5349240"/>
+            <a:off x="2727655" y="5349240"/>
             <a:ext cx="1600200" cy="274320"/>
           </a:xfrm>
           <a:prstGeom prst="rect">
@@ -10288,7 +10288,7 @@
         </p:nvSpPr>
         <p:spPr>
           <a:xfrm>
-            <a:off x="4556455" y="5623560"/>
+            <a:off x="2727655" y="5623560"/>
             <a:ext cx="1600200" cy="228600"/>
           </a:xfrm>
           <a:prstGeom prst="rect">
@@ -10327,7 +10327,7 @@
         </p:nvSpPr>
         <p:spPr>
           <a:xfrm>
-            <a:off x="6385255" y="4526280"/>
+            <a:off x="4556455" y="4526280"/>
             <a:ext cx="1600200" cy="1554480"/>
           </a:xfrm>
           <a:prstGeom prst="roundRect">
@@ -10362,7 +10362,7 @@
         </p:blipFill>
         <p:spPr>
           <a:xfrm>
-            <a:off x="6911035" y="4709160"/>
+            <a:off x="5082235" y="4709160"/>
             <a:ext cx="548640" cy="548640"/>
           </a:xfrm>
           <a:prstGeom prst="rect">
@@ -10378,7 +10378,7 @@
         </p:nvSpPr>
         <p:spPr>
           <a:xfrm>
-            <a:off x="6385255" y="5349240"/>
+            <a:off x="4556455" y="5349240"/>
             <a:ext cx="1600200" cy="274320"/>
           </a:xfrm>
           <a:prstGeom prst="rect">
@@ -10417,7 +10417,7 @@
         </p:nvSpPr>
         <p:spPr>
           <a:xfrm>
-            <a:off x="6385255" y="5623560"/>
+            <a:off x="4556455" y="5623560"/>
             <a:ext cx="1600200" cy="228600"/>
           </a:xfrm>
           <a:prstGeom prst="rect">
@@ -10456,7 +10456,7 @@
         </p:nvSpPr>
         <p:spPr>
           <a:xfrm>
-            <a:off x="8214055" y="4526280"/>
+            <a:off x="6385255" y="4526280"/>
             <a:ext cx="1600200" cy="1554480"/>
           </a:xfrm>
           <a:prstGeom prst="roundRect">
@@ -10491,7 +10491,7 @@
         </p:blipFill>
         <p:spPr>
           <a:xfrm>
-            <a:off x="8739835" y="4709160"/>
+            <a:off x="6911035" y="4709160"/>
             <a:ext cx="548640" cy="548640"/>
           </a:xfrm>
           <a:prstGeom prst="rect">
@@ -10507,7 +10507,7 @@
         </p:nvSpPr>
         <p:spPr>
           <a:xfrm>
-            <a:off x="8214055" y="5349240"/>
+            <a:off x="6385255" y="5349240"/>
             <a:ext cx="1600200" cy="274320"/>
           </a:xfrm>
           <a:prstGeom prst="rect">
@@ -10546,7 +10546,7 @@
         </p:nvSpPr>
         <p:spPr>
           <a:xfrm>
-            <a:off x="8214055" y="5623560"/>
+            <a:off x="6385255" y="5623560"/>
             <a:ext cx="1600200" cy="228600"/>
           </a:xfrm>
           <a:prstGeom prst="rect">
@@ -10585,7 +10585,7 @@
         </p:nvSpPr>
         <p:spPr>
           <a:xfrm>
-            <a:off x="10042855" y="4526280"/>
+            <a:off x="8214055" y="4526280"/>
             <a:ext cx="1600200" cy="1554480"/>
           </a:xfrm>
           <a:prstGeom prst="roundRect">
@@ -10620,6 +10620,135 @@
         </p:blipFill>
         <p:spPr>
           <a:xfrm>
+            <a:off x="8739835" y="4709160"/>
+            <a:ext cx="548640" cy="548640"/>
+          </a:xfrm>
+          <a:prstGeom prst="rect">
+            <a:avLst/>
+          </a:prstGeom>
+        </p:spPr>
+      </p:pic>
+      <p:sp>
+        <p:nvSpPr>
+          <p:cNvPr id="24" name="Text 17"/>
+          <p:cNvSpPr txBox="1"/>
+          <p:nvPr/>
+        </p:nvSpPr>
+        <p:spPr>
+          <a:xfrm>
+            <a:off x="8214055" y="5349240"/>
+            <a:ext cx="1600200" cy="274320"/>
+          </a:xfrm>
+          <a:prstGeom prst="rect">
+            <a:avLst/>
+          </a:prstGeom>
+          <a:noFill/>
+          <a:ln/>
+        </p:spPr>
+        <p:txBody>
+          <a:bodyPr wrap="square" lIns="0" tIns="0" rIns="0" bIns="0" rtlCol="0" anchor="t"/>
+          <a:lstStyle/>
+          <a:p>
+            <a:pPr algn="ctr" indent="0" marL="0">
+              <a:buNone/>
+            </a:pPr>
+            <a:r>
+              <a:rPr lang="en-US" sz="1400" b="1" dirty="0">
+                <a:solidFill>
+                  <a:srgbClr val="DD5F13"/>
+                </a:solidFill>
+                <a:latin typeface="Calibri" pitchFamily="34" charset="0"/>
+                <a:ea typeface="Calibri" pitchFamily="34" charset="-122"/>
+                <a:cs typeface="Calibri" pitchFamily="34" charset="-120"/>
+              </a:rPr>
+              <a:t>Google</a:t>
+            </a:r>
+            <a:endParaRPr lang="en-US" sz="1400" dirty="0"/>
+          </a:p>
+        </p:txBody>
+      </p:sp>
+      <p:sp>
+        <p:nvSpPr>
+          <p:cNvPr id="25" name="Text 18"/>
+          <p:cNvSpPr txBox="1"/>
+          <p:nvPr/>
+        </p:nvSpPr>
+        <p:spPr>
+          <a:xfrm>
+            <a:off x="8214055" y="5623560"/>
+            <a:ext cx="1600200" cy="228600"/>
+          </a:xfrm>
+          <a:prstGeom prst="rect">
+            <a:avLst/>
+          </a:prstGeom>
+          <a:noFill/>
+          <a:ln/>
+        </p:spPr>
+        <p:txBody>
+          <a:bodyPr wrap="square" lIns="0" tIns="0" rIns="0" bIns="0" rtlCol="0" anchor="t"/>
+          <a:lstStyle/>
+          <a:p>
+            <a:pPr algn="ctr" indent="0" marL="0">
+              <a:buNone/>
+            </a:pPr>
+            <a:r>
+              <a:rPr lang="en-US" sz="800" b="1" spc="100" kern="0" dirty="0">
+                <a:solidFill>
+                  <a:srgbClr val="222222"/>
+                </a:solidFill>
+                <a:latin typeface="Calibri" pitchFamily="34" charset="0"/>
+                <a:ea typeface="Calibri" pitchFamily="34" charset="-122"/>
+                <a:cs typeface="Calibri" pitchFamily="34" charset="-120"/>
+              </a:rPr>
+              <a:t>INCLUDED</a:t>
+            </a:r>
+            <a:endParaRPr lang="en-US" sz="800" dirty="0"/>
+          </a:p>
+        </p:txBody>
+      </p:sp>
+      <p:sp>
+        <p:nvSpPr>
+          <p:cNvPr id="26" name="Shape 19"/>
+          <p:cNvSpPr/>
+          <p:nvPr/>
+        </p:nvSpPr>
+        <p:spPr>
+          <a:xfrm>
+            <a:off x="10042855" y="4526280"/>
+            <a:ext cx="1600200" cy="1554480"/>
+          </a:xfrm>
+          <a:prstGeom prst="roundRect">
+            <a:avLst>
+              <a:gd name="adj" fmla="val 7059"/>
+            </a:avLst>
+          </a:prstGeom>
+          <a:solidFill>
+            <a:srgbClr val="FFFFFF"/>
+          </a:solidFill>
+          <a:ln w="6350">
+            <a:solidFill>
+              <a:srgbClr val="FFFFFF"/>
+            </a:solidFill>
+            <a:prstDash val="solid"/>
+          </a:ln>
+        </p:spPr>
+      </p:sp>
+      <p:pic>
+        <p:nvPicPr>
+          <p:cNvPr id="27" name="Image 5" descr="preencoded.png">    </p:cNvPr>
+          <p:cNvPicPr>
+            <a:picLocks noChangeAspect="1"/>
+          </p:cNvPicPr>
+          <p:nvPr/>
+        </p:nvPicPr>
+        <p:blipFill>
+          <a:blip r:embed="rId6"/>
+          <a:stretch>
+            <a:fillRect/>
+          </a:stretch>
+        </p:blipFill>
+        <p:spPr>
+          <a:xfrm>
             <a:off x="10568635" y="4709160"/>
             <a:ext cx="548640" cy="548640"/>
           </a:xfrm>
@@ -10630,7 +10759,7 @@
       </p:pic>
       <p:sp>
         <p:nvSpPr>
-          <p:cNvPr id="24" name="Text 17"/>
+          <p:cNvPr id="28" name="Text 20"/>
           <p:cNvSpPr txBox="1"/>
           <p:nvPr/>
         </p:nvSpPr>
@@ -10653,7 +10782,7 @@
               <a:buNone/>
             </a:pPr>
             <a:r>
-              <a:rPr lang="en-US" sz="1400" b="1" dirty="0">
+              <a:rPr lang="en-US" sz="1250" b="1" dirty="0">
                 <a:solidFill>
                   <a:srgbClr val="DD5F13"/>
                 </a:solidFill>
@@ -10661,15 +10790,15 @@
                 <a:ea typeface="Calibri" pitchFamily="34" charset="-122"/>
                 <a:cs typeface="Calibri" pitchFamily="34" charset="-120"/>
               </a:rPr>
-              <a:t>Google</a:t>
-            </a:r>
-            <a:endParaRPr lang="en-US" sz="1400" dirty="0"/>
-          </a:p>
-        </p:txBody>
-      </p:sp>
-      <p:sp>
-        <p:nvSpPr>
-          <p:cNvPr id="25" name="Text 18"/>
+              <a:t>+20 directories</a:t>
+            </a:r>
+            <a:endParaRPr lang="en-US" sz="1250" dirty="0"/>
+          </a:p>
+        </p:txBody>
+      </p:sp>
+      <p:sp>
+        <p:nvSpPr>
+          <p:cNvPr id="29" name="Text 21"/>
           <p:cNvSpPr txBox="1"/>
           <p:nvPr/>
         </p:nvSpPr>

</xml_diff>

<commit_message>
Fix founder timeline, generalize restricted-ad copy, verify Caldwell audit
- Founder bio now reads in order: 3 years at Purple Lotus, 4 years at
  Weedmaps, 4+ years running Sparks ("over 10 years in cannabis") in
  config, knowledge base, Why Sparks slide, speaker notes and CLAUDE.md
- Problem slide and Google preview no longer name specific ad networks;
  say most mainstream platforms restrict cannabis
- Caldwell: Leafly row uses live-verified counts, Yelp rating marked to
  confirm on the call
- Rebuild all decks

Co-Authored-By: Claude Fable 5.1 <noreply@anthropic.com>
Claude-Session: https://claude.ai/code/session_01RhvxWoxVegp3rGjZ4khBZo
</commit_message>
<xml_diff>
--- a/decks/Sparks-x-example-green-valley.pptx
+++ b/decks/Sparks-x-example-green-valley.pptx
@@ -1219,7 +1219,7 @@
           <a:p>
             <a:r>
               <a:rPr lang="en-US" dirty="0"/>
-              <a:t>Credibility before the audit. Say 'official partner' only for Yelp, Google and Apple Maps. For Weedmaps and Leafly, say we've worked with them for 10+ years and the founder was a Weedmaps executive — not 'partner'.</a:t>
+              <a:t>Credibility before the audit. Say 'official partner' only for Yelp, Google and Apple Maps. For Weedmaps and Leafly, say we've worked inside and alongside them for 10+ years — not 'partner'. Founder timeline, in order: 3 years at Purple Lotus, then 4 years at Weedmaps as an executive, then 4+ years running Sparks.</a:t>
             </a:r>
             <a:endParaRPr lang="en-US" dirty="0"/>
           </a:p>
@@ -5435,7 +5435,7 @@
                 <a:ea typeface="Calibri" pitchFamily="34" charset="-122"/>
                 <a:cs typeface="Calibri" pitchFamily="34" charset="-120"/>
               </a:rPr>
-              <a:t>With cannabis restricted on most ad platforms, your Google Business Profile is one of the only free places to reach local customers at scale.</a:t>
+              <a:t>With paid reach for cannabis limited on most mainstream platforms, your Google Business Profile is one of the few free places to reach local customers at scale.</a:t>
             </a:r>
             <a:endParaRPr lang="en-US" sz="1100" dirty="0"/>
           </a:p>
@@ -6544,7 +6544,7 @@
                 <a:ea typeface="Calibri" pitchFamily="34" charset="-122"/>
                 <a:cs typeface="Calibri" pitchFamily="34" charset="-120"/>
               </a:rPr>
-              <a:t>4 years at Weedmaps working with the largest dispensaries in the world, then 3 years running listing management for Purple Lotus before founding Sparks in 2022.</a:t>
+              <a:t>Over 10 years in cannabis. 3 years running listing management for Purple Lotus, then 4 years at Weedmaps working with the largest dispensaries in the world, and 4+ years running Sparks for 100+ dispensaries, deliveries and brands.</a:t>
             </a:r>
             <a:endParaRPr lang="en-US" sz="1150" dirty="0"/>
           </a:p>
@@ -8462,7 +8462,7 @@
                 <a:ea typeface="Calibri" pitchFamily="34" charset="-122"/>
                 <a:cs typeface="Calibri" pitchFamily="34" charset="-120"/>
               </a:rPr>
-              <a:t>Google Ads, Meta and most networks block cannabis. Discovery happens on Weedmaps, Leafly, Google Maps, Apple Maps and Yelp.</a:t>
+              <a:t>Most mainstream ad networks and social platforms restrict cannabis. Discovery happens on Weedmaps, Leafly, Google Maps, Apple Maps and Yelp.</a:t>
             </a:r>
             <a:endParaRPr lang="en-US" sz="1300" dirty="0"/>
           </a:p>
@@ -10339,7 +10339,7 @@
         <p:spPr>
           <a:xfrm>
             <a:off x="548640" y="1554734"/>
-            <a:ext cx="11094415" cy="347472"/>
+            <a:ext cx="11094415" cy="603504"/>
           </a:xfrm>
           <a:prstGeom prst="rect">
             <a:avLst/>
@@ -10363,7 +10363,7 @@
                 <a:ea typeface="Calibri" pitchFamily="34" charset="-122"/>
                 <a:cs typeface="Calibri" pitchFamily="34" charset="-120"/>
               </a:rPr>
-              <a:t>The team behind 100+ dispensary listings — recognized, partnered, and built by a Weedmaps executive.</a:t>
+              <a:t>Over 10 years in cannabis, 100+ dispensary listings managed — recognized, partnered, and led by a former Weedmaps executive.</a:t>
             </a:r>
             <a:endParaRPr lang="en-US" sz="1500" dirty="0"/>
           </a:p>
@@ -10377,7 +10377,7 @@
         </p:nvSpPr>
         <p:spPr>
           <a:xfrm>
-            <a:off x="548640" y="2176526"/>
+            <a:off x="548640" y="2432558"/>
             <a:ext cx="3515258" cy="1600200"/>
           </a:xfrm>
           <a:prstGeom prst="roundRect">
@@ -10404,7 +10404,7 @@
         </p:nvSpPr>
         <p:spPr>
           <a:xfrm>
-            <a:off x="822960" y="2359406"/>
+            <a:off x="822960" y="2615438"/>
             <a:ext cx="2966618" cy="685800"/>
           </a:xfrm>
           <a:prstGeom prst="rect">
@@ -10443,7 +10443,7 @@
         </p:nvSpPr>
         <p:spPr>
           <a:xfrm>
-            <a:off x="822960" y="3045206"/>
+            <a:off x="822960" y="3301238"/>
             <a:ext cx="2966618" cy="640080"/>
           </a:xfrm>
           <a:prstGeom prst="rect">
@@ -10482,7 +10482,7 @@
         </p:nvSpPr>
         <p:spPr>
           <a:xfrm>
-            <a:off x="4338218" y="2176526"/>
+            <a:off x="4338218" y="2432558"/>
             <a:ext cx="3515258" cy="1600200"/>
           </a:xfrm>
           <a:prstGeom prst="roundRect">
@@ -10509,7 +10509,7 @@
         </p:nvSpPr>
         <p:spPr>
           <a:xfrm>
-            <a:off x="4612538" y="2359406"/>
+            <a:off x="4612538" y="2615438"/>
             <a:ext cx="2966618" cy="685800"/>
           </a:xfrm>
           <a:prstGeom prst="rect">
@@ -10548,7 +10548,7 @@
         </p:nvSpPr>
         <p:spPr>
           <a:xfrm>
-            <a:off x="4612538" y="3045206"/>
+            <a:off x="4612538" y="3301238"/>
             <a:ext cx="2966618" cy="640080"/>
           </a:xfrm>
           <a:prstGeom prst="rect">
@@ -10587,7 +10587,7 @@
         </p:nvSpPr>
         <p:spPr>
           <a:xfrm>
-            <a:off x="8127797" y="2176526"/>
+            <a:off x="8127797" y="2432558"/>
             <a:ext cx="3515258" cy="1600200"/>
           </a:xfrm>
           <a:prstGeom prst="roundRect">
@@ -10614,7 +10614,7 @@
         </p:nvSpPr>
         <p:spPr>
           <a:xfrm>
-            <a:off x="8402117" y="2359406"/>
+            <a:off x="8402117" y="2615438"/>
             <a:ext cx="2966618" cy="685800"/>
           </a:xfrm>
           <a:prstGeom prst="rect">
@@ -10653,7 +10653,7 @@
         </p:nvSpPr>
         <p:spPr>
           <a:xfrm>
-            <a:off x="8402117" y="3045206"/>
+            <a:off x="8402117" y="3301238"/>
             <a:ext cx="2966618" cy="640080"/>
           </a:xfrm>
           <a:prstGeom prst="rect">
@@ -10678,7 +10678,7 @@
                 <a:ea typeface="Calibri" pitchFamily="34" charset="-122"/>
                 <a:cs typeface="Calibri" pitchFamily="34" charset="-120"/>
               </a:rPr>
-              <a:t>working inside and alongside Weedmaps and Leafly. Our founder ran accounts at Weedmaps as an executive before starting Sparks.</a:t>
+              <a:t>in cannabis: 3 years running listings for Purple Lotus, 4 years as a Weedmaps executive, and 4+ years running Sparks.</a:t>
             </a:r>
             <a:endParaRPr lang="en-US" sz="1100" dirty="0"/>
           </a:p>
@@ -10692,12 +10692,12 @@
         </p:nvSpPr>
         <p:spPr>
           <a:xfrm>
-            <a:off x="548640" y="4051046"/>
-            <a:ext cx="5410048" cy="2075434"/>
+            <a:off x="548640" y="4307078"/>
+            <a:ext cx="5410048" cy="1819402"/>
           </a:xfrm>
           <a:prstGeom prst="roundRect">
             <a:avLst>
-              <a:gd name="adj" fmla="val 5287"/>
+              <a:gd name="adj" fmla="val 6031"/>
             </a:avLst>
           </a:prstGeom>
           <a:solidFill>
@@ -10719,7 +10719,7 @@
         </p:nvSpPr>
         <p:spPr>
           <a:xfrm>
-            <a:off x="868680" y="4279646"/>
+            <a:off x="868680" y="4535678"/>
             <a:ext cx="4769968" cy="274320"/>
           </a:xfrm>
           <a:prstGeom prst="rect">
@@ -10758,7 +10758,7 @@
         </p:nvSpPr>
         <p:spPr>
           <a:xfrm>
-            <a:off x="868680" y="4599686"/>
+            <a:off x="868680" y="4855718"/>
             <a:ext cx="4769968" cy="457200"/>
           </a:xfrm>
           <a:prstGeom prst="rect">
@@ -10797,12 +10797,12 @@
         </p:nvSpPr>
         <p:spPr>
           <a:xfrm>
-            <a:off x="868680" y="5056886"/>
-            <a:ext cx="1468069" cy="795274"/>
+            <a:off x="868680" y="5312918"/>
+            <a:ext cx="1468069" cy="539242"/>
           </a:xfrm>
           <a:prstGeom prst="roundRect">
             <a:avLst>
-              <a:gd name="adj" fmla="val 13798"/>
+              <a:gd name="adj" fmla="val 20349"/>
             </a:avLst>
           </a:prstGeom>
           <a:solidFill>
@@ -10832,7 +10832,7 @@
         </p:blipFill>
         <p:spPr>
           <a:xfrm>
-            <a:off x="1374115" y="5166614"/>
+            <a:off x="1374115" y="5422646"/>
             <a:ext cx="457200" cy="457200"/>
           </a:xfrm>
           <a:prstGeom prst="rect">
@@ -10848,7 +10848,7 @@
         </p:nvSpPr>
         <p:spPr>
           <a:xfrm>
-            <a:off x="868680" y="5642102"/>
+            <a:off x="868680" y="5898134"/>
             <a:ext cx="1468069" cy="237744"/>
           </a:xfrm>
           <a:prstGeom prst="rect">
@@ -10887,7 +10887,7 @@
         </p:nvSpPr>
         <p:spPr>
           <a:xfrm>
-            <a:off x="868680" y="5879846"/>
+            <a:off x="868680" y="6135878"/>
             <a:ext cx="1468069" cy="182880"/>
           </a:xfrm>
           <a:prstGeom prst="rect">
@@ -10926,12 +10926,12 @@
         </p:nvSpPr>
         <p:spPr>
           <a:xfrm>
-            <a:off x="2519629" y="5056886"/>
-            <a:ext cx="1468069" cy="795274"/>
+            <a:off x="2519629" y="5312918"/>
+            <a:ext cx="1468069" cy="539242"/>
           </a:xfrm>
           <a:prstGeom prst="roundRect">
             <a:avLst>
-              <a:gd name="adj" fmla="val 13798"/>
+              <a:gd name="adj" fmla="val 20349"/>
             </a:avLst>
           </a:prstGeom>
           <a:solidFill>
@@ -10961,7 +10961,7 @@
         </p:blipFill>
         <p:spPr>
           <a:xfrm>
-            <a:off x="3025064" y="5166614"/>
+            <a:off x="3025064" y="5422646"/>
             <a:ext cx="457200" cy="457200"/>
           </a:xfrm>
           <a:prstGeom prst="rect">
@@ -10977,7 +10977,7 @@
         </p:nvSpPr>
         <p:spPr>
           <a:xfrm>
-            <a:off x="2519629" y="5642102"/>
+            <a:off x="2519629" y="5898134"/>
             <a:ext cx="1468069" cy="237744"/>
           </a:xfrm>
           <a:prstGeom prst="rect">
@@ -11016,7 +11016,7 @@
         </p:nvSpPr>
         <p:spPr>
           <a:xfrm>
-            <a:off x="2519629" y="5879846"/>
+            <a:off x="2519629" y="6135878"/>
             <a:ext cx="1468069" cy="182880"/>
           </a:xfrm>
           <a:prstGeom prst="rect">
@@ -11055,12 +11055,12 @@
         </p:nvSpPr>
         <p:spPr>
           <a:xfrm>
-            <a:off x="4170578" y="5056886"/>
-            <a:ext cx="1468069" cy="795274"/>
+            <a:off x="4170578" y="5312918"/>
+            <a:ext cx="1468069" cy="539242"/>
           </a:xfrm>
           <a:prstGeom prst="roundRect">
             <a:avLst>
-              <a:gd name="adj" fmla="val 13798"/>
+              <a:gd name="adj" fmla="val 20349"/>
             </a:avLst>
           </a:prstGeom>
           <a:solidFill>
@@ -11090,7 +11090,7 @@
         </p:blipFill>
         <p:spPr>
           <a:xfrm>
-            <a:off x="4676013" y="5166614"/>
+            <a:off x="4676013" y="5422646"/>
             <a:ext cx="457200" cy="457200"/>
           </a:xfrm>
           <a:prstGeom prst="rect">
@@ -11106,7 +11106,7 @@
         </p:nvSpPr>
         <p:spPr>
           <a:xfrm>
-            <a:off x="4170578" y="5642102"/>
+            <a:off x="4170578" y="5898134"/>
             <a:ext cx="1468069" cy="237744"/>
           </a:xfrm>
           <a:prstGeom prst="rect">
@@ -11145,7 +11145,7 @@
         </p:nvSpPr>
         <p:spPr>
           <a:xfrm>
-            <a:off x="4170578" y="5879846"/>
+            <a:off x="4170578" y="6135878"/>
             <a:ext cx="1468069" cy="182880"/>
           </a:xfrm>
           <a:prstGeom prst="rect">
@@ -11184,12 +11184,12 @@
         </p:nvSpPr>
         <p:spPr>
           <a:xfrm>
-            <a:off x="6233008" y="4051046"/>
-            <a:ext cx="5410048" cy="900557"/>
+            <a:off x="6233008" y="4307078"/>
+            <a:ext cx="5410048" cy="772541"/>
           </a:xfrm>
           <a:prstGeom prst="roundRect">
             <a:avLst>
-              <a:gd name="adj" fmla="val 12184"/>
+              <a:gd name="adj" fmla="val 14204"/>
             </a:avLst>
           </a:prstGeom>
           <a:solidFill>
@@ -11211,7 +11211,7 @@
         </p:nvSpPr>
         <p:spPr>
           <a:xfrm>
-            <a:off x="6507328" y="4249865"/>
+            <a:off x="6507328" y="4441889"/>
             <a:ext cx="502920" cy="502920"/>
           </a:xfrm>
           <a:prstGeom prst="ellipse">
@@ -11244,7 +11244,7 @@
         </p:blipFill>
         <p:spPr>
           <a:xfrm>
-            <a:off x="6643116" y="4385653"/>
+            <a:off x="6643116" y="4577677"/>
             <a:ext cx="231343" cy="231343"/>
           </a:xfrm>
           <a:prstGeom prst="rect">
@@ -11260,7 +11260,7 @@
         </p:nvSpPr>
         <p:spPr>
           <a:xfrm>
-            <a:off x="7193128" y="4188206"/>
+            <a:off x="7193128" y="4444238"/>
             <a:ext cx="4221328" cy="274320"/>
           </a:xfrm>
           <a:prstGeom prst="rect">
@@ -11299,8 +11299,8 @@
         </p:nvSpPr>
         <p:spPr>
           <a:xfrm>
-            <a:off x="7193128" y="4462526"/>
-            <a:ext cx="4221328" cy="397637"/>
+            <a:off x="7193128" y="4718558"/>
+            <a:ext cx="4221328" cy="269621"/>
           </a:xfrm>
           <a:prstGeom prst="rect">
             <a:avLst/>
@@ -11338,12 +11338,12 @@
         </p:nvSpPr>
         <p:spPr>
           <a:xfrm>
-            <a:off x="6233008" y="5225923"/>
-            <a:ext cx="5410048" cy="900557"/>
+            <a:off x="6233008" y="5353939"/>
+            <a:ext cx="5410048" cy="772541"/>
           </a:xfrm>
           <a:prstGeom prst="roundRect">
             <a:avLst>
-              <a:gd name="adj" fmla="val 12184"/>
+              <a:gd name="adj" fmla="val 14204"/>
             </a:avLst>
           </a:prstGeom>
           <a:solidFill>
@@ -11365,7 +11365,7 @@
         </p:nvSpPr>
         <p:spPr>
           <a:xfrm>
-            <a:off x="6507328" y="5424742"/>
+            <a:off x="6507328" y="5488750"/>
             <a:ext cx="502920" cy="502920"/>
           </a:xfrm>
           <a:prstGeom prst="ellipse">
@@ -11398,7 +11398,7 @@
         </p:blipFill>
         <p:spPr>
           <a:xfrm>
-            <a:off x="6643116" y="5560530"/>
+            <a:off x="6643116" y="5624538"/>
             <a:ext cx="231343" cy="231343"/>
           </a:xfrm>
           <a:prstGeom prst="rect">
@@ -11414,7 +11414,7 @@
         </p:nvSpPr>
         <p:spPr>
           <a:xfrm>
-            <a:off x="7193128" y="5363083"/>
+            <a:off x="7193128" y="5491099"/>
             <a:ext cx="4221328" cy="274320"/>
           </a:xfrm>
           <a:prstGeom prst="rect">
@@ -11453,8 +11453,8 @@
         </p:nvSpPr>
         <p:spPr>
           <a:xfrm>
-            <a:off x="7193128" y="5637403"/>
-            <a:ext cx="4221328" cy="397637"/>
+            <a:off x="7193128" y="5765419"/>
+            <a:ext cx="4221328" cy="269621"/>
           </a:xfrm>
           <a:prstGeom prst="rect">
             <a:avLst/>

</xml_diff>

<commit_message>
Generalize the scope slide: services cover every listing on the platform
The subtitle no longer repeats the prospect's listing-specific notes
(zones, listing counts), so no listing can be left out. Scope notes
move to the speaker notes. Prospect files updated to match.

Co-Authored-By: Claude Fable 5.1 <noreply@anthropic.com>
Claude-Session: https://claude.ai/code/session_01RhvxWoxVegp3rGjZ4khBZo
</commit_message>
<xml_diff>
--- a/decks/Sparks-x-example-green-valley.pptx
+++ b/decks/Sparks-x-example-green-valley.pptx
@@ -1395,7 +1395,7 @@
           <a:p>
             <a:r>
               <a:rPr lang="en-US" dirty="0"/>
-              <a:t>The seven Sparks pillars (spend, listing, menu, reviews, deals, creative, data) applied to this platform. Tie each line back to an audit finding.</a:t>
+              <a:t>The seven Sparks pillars (spend, listing, menu, reviews, deals, creative, data) applied to every Weedmaps listing. Tie each line back to an audit finding. Scope notes: All listings on the platform: ad spend &amp; bid management, listing optimization, deal &amp; promotion activations, in-house graphics, menu management &amp; product verification, review responses, weekly reporting.</a:t>
             </a:r>
             <a:endParaRPr lang="en-US" dirty="0"/>
           </a:p>
@@ -12528,7 +12528,7 @@
                 <a:ea typeface="Calibri" pitchFamily="34" charset="-122"/>
                 <a:cs typeface="Calibri" pitchFamily="34" charset="-120"/>
               </a:rPr>
-              <a:t>Scoped for this proposal: Bid strategy for top-3 placement in zone, full menu verification, weekly deal rotation, review responses, weekly reporting.</a:t>
+              <a:t>Everything below applies to every Green Valley Dispensary listing on Weedmaps, and to each platform you add to the engagement.</a:t>
             </a:r>
             <a:endParaRPr lang="en-US" sz="1500" dirty="0"/>
           </a:p>

</xml_diff>

<commit_message>
Add optional à-la-carte add-ons row to the investment slide
Review Generation ($100/mo per location + messaging fees) and Product
Image Management ($10/hr) appear under the pricing cards on every deck,
sourced from brand/config.yml → extras and overridable per prospect via
investment.extras. They are never rolled into the Total Package price.
Cards and bottom copy tighten to make room.

Co-Authored-By: Claude Fable 5.1 <noreply@anthropic.com>
Claude-Session: https://claude.ai/code/session_01RhvxWoxVegp3rGjZ4khBZo
</commit_message>
<xml_diff>
--- a/decks/Sparks-x-example-green-valley.pptx
+++ b/decks/Sparks-x-example-green-valley.pptx
@@ -1659,7 +1659,7 @@
           <a:p>
             <a:r>
               <a:rPr lang="en-US" dirty="0"/>
-              <a:t>Pricing for Weedmaps Management. Results in 30 days or your money back. Ad spend is billed by the platform; the fee covers management. Each add-on is $495/mo.</a:t>
+              <a:t>Pricing for Weedmaps Management. Results in 30 days or your money back. Ad spend is billed by the platform; the fee covers management. Each add-on is $495/mo. Optional add-ons, priced separately and not in the package total: Review Generation ($100/mo per location — + messaging fees. We text your customers asking for reviews and gate negative feedback before it goes public.); Product Image Management ($10/hr — Our team finds, edits and uploads product images to your online menus.).</a:t>
             </a:r>
             <a:endParaRPr lang="en-US" dirty="0"/>
           </a:p>
@@ -2380,7 +2380,7 @@
                 <a:ea typeface="Calibri" pitchFamily="34" charset="-122"/>
                 <a:cs typeface="Calibri" pitchFamily="34" charset="-120"/>
               </a:rPr>
-              <a:t>Sacramento, CA   ·   October 15, 2026   ·   Prepared for Jordan Lee, Owner</a:t>
+              <a:t>Sacramento, CA   ·   October 16, 2026   ·   Prepared for Jordan Lee, Owner</a:t>
             </a:r>
             <a:endParaRPr lang="en-US" sz="1200" dirty="0"/>
           </a:p>
@@ -16088,12 +16088,12 @@
         </p:nvSpPr>
         <p:spPr>
           <a:xfrm>
-            <a:off x="548640" y="2286000"/>
-            <a:ext cx="3515258" cy="2880360"/>
+            <a:off x="548640" y="2103120"/>
+            <a:ext cx="3515258" cy="2377440"/>
           </a:xfrm>
           <a:prstGeom prst="roundRect">
             <a:avLst>
-              <a:gd name="adj" fmla="val 3810"/>
+              <a:gd name="adj" fmla="val 4615"/>
             </a:avLst>
           </a:prstGeom>
           <a:solidFill>
@@ -16115,7 +16115,7 @@
         </p:nvSpPr>
         <p:spPr>
           <a:xfrm>
-            <a:off x="868680" y="2514600"/>
+            <a:off x="868680" y="2286000"/>
             <a:ext cx="2875178" cy="365760"/>
           </a:xfrm>
           <a:prstGeom prst="rect">
@@ -16154,8 +16154,8 @@
         </p:nvSpPr>
         <p:spPr>
           <a:xfrm>
-            <a:off x="868680" y="2926080"/>
-            <a:ext cx="2875178" cy="731520"/>
+            <a:off x="868680" y="2633472"/>
+            <a:ext cx="2875178" cy="566928"/>
           </a:xfrm>
           <a:prstGeom prst="rect">
             <a:avLst/>
@@ -16171,7 +16171,7 @@
               <a:buNone/>
             </a:pPr>
             <a:r>
-              <a:rPr lang="en-US" sz="3600" b="1" dirty="0">
+              <a:rPr lang="en-US" sz="3200" b="1" dirty="0">
                 <a:solidFill>
                   <a:srgbClr val="222222"/>
                 </a:solidFill>
@@ -16181,7 +16181,7 @@
               </a:rPr>
               <a:t>Custom</a:t>
             </a:r>
-            <a:endParaRPr lang="en-US" sz="3600" dirty="0"/>
+            <a:endParaRPr lang="en-US" sz="3200" dirty="0"/>
           </a:p>
         </p:txBody>
       </p:sp>
@@ -16193,8 +16193,8 @@
         </p:nvSpPr>
         <p:spPr>
           <a:xfrm>
-            <a:off x="868680" y="3749040"/>
-            <a:ext cx="2875178" cy="1280160"/>
+            <a:off x="868680" y="3218688"/>
+            <a:ext cx="2875178" cy="1152144"/>
           </a:xfrm>
           <a:prstGeom prst="rect">
             <a:avLst/>
@@ -16210,7 +16210,7 @@
               <a:buNone/>
             </a:pPr>
             <a:r>
-              <a:rPr lang="en-US" sz="1200" dirty="0">
+              <a:rPr lang="en-US" sz="1100" dirty="0">
                 <a:solidFill>
                   <a:srgbClr val="222222"/>
                 </a:solidFill>
@@ -16220,7 +16220,7 @@
               </a:rPr>
               <a:t>Weedmaps + Google</a:t>
             </a:r>
-            <a:endParaRPr lang="en-US" sz="1200" dirty="0"/>
+            <a:endParaRPr lang="en-US" sz="1100" dirty="0"/>
           </a:p>
         </p:txBody>
       </p:sp>
@@ -16232,12 +16232,12 @@
         </p:nvSpPr>
         <p:spPr>
           <a:xfrm>
-            <a:off x="4338218" y="2286000"/>
-            <a:ext cx="3515258" cy="2880360"/>
+            <a:off x="4338218" y="2103120"/>
+            <a:ext cx="3515258" cy="2377440"/>
           </a:xfrm>
           <a:prstGeom prst="roundRect">
             <a:avLst>
-              <a:gd name="adj" fmla="val 3810"/>
+              <a:gd name="adj" fmla="val 4615"/>
             </a:avLst>
           </a:prstGeom>
           <a:solidFill>
@@ -16259,7 +16259,7 @@
         </p:nvSpPr>
         <p:spPr>
           <a:xfrm>
-            <a:off x="4658258" y="2514600"/>
+            <a:off x="4658258" y="2286000"/>
             <a:ext cx="2875178" cy="365760"/>
           </a:xfrm>
           <a:prstGeom prst="rect">
@@ -16298,8 +16298,8 @@
         </p:nvSpPr>
         <p:spPr>
           <a:xfrm>
-            <a:off x="4658258" y="2926080"/>
-            <a:ext cx="2875178" cy="731520"/>
+            <a:off x="4658258" y="2633472"/>
+            <a:ext cx="2875178" cy="566928"/>
           </a:xfrm>
           <a:prstGeom prst="rect">
             <a:avLst/>
@@ -16315,7 +16315,7 @@
               <a:buNone/>
             </a:pPr>
             <a:r>
-              <a:rPr lang="en-US" sz="3600" b="1" dirty="0">
+              <a:rPr lang="en-US" sz="3200" b="1" dirty="0">
                 <a:solidFill>
                   <a:srgbClr val="222222"/>
                 </a:solidFill>
@@ -16325,7 +16325,7 @@
               </a:rPr>
               <a:t>Custom</a:t>
             </a:r>
-            <a:endParaRPr lang="en-US" sz="3600" dirty="0"/>
+            <a:endParaRPr lang="en-US" sz="3200" dirty="0"/>
           </a:p>
         </p:txBody>
       </p:sp>
@@ -16337,8 +16337,8 @@
         </p:nvSpPr>
         <p:spPr>
           <a:xfrm>
-            <a:off x="4658258" y="3749040"/>
-            <a:ext cx="2875178" cy="1280160"/>
+            <a:off x="4658258" y="3218688"/>
+            <a:ext cx="2875178" cy="1152144"/>
           </a:xfrm>
           <a:prstGeom prst="rect">
             <a:avLst/>
@@ -16354,7 +16354,7 @@
               <a:buNone/>
             </a:pPr>
             <a:r>
-              <a:rPr lang="en-US" sz="1200" dirty="0">
+              <a:rPr lang="en-US" sz="1100" dirty="0">
                 <a:solidFill>
                   <a:srgbClr val="222222"/>
                 </a:solidFill>
@@ -16364,7 +16364,7 @@
               </a:rPr>
               <a:t>Weedmaps + Leafly + Yelp + Google</a:t>
             </a:r>
-            <a:endParaRPr lang="en-US" sz="1200" dirty="0"/>
+            <a:endParaRPr lang="en-US" sz="1100" dirty="0"/>
           </a:p>
         </p:txBody>
       </p:sp>
@@ -16376,12 +16376,12 @@
         </p:nvSpPr>
         <p:spPr>
           <a:xfrm>
-            <a:off x="8127797" y="2286000"/>
-            <a:ext cx="3515258" cy="2880360"/>
+            <a:off x="8127797" y="2103120"/>
+            <a:ext cx="3515258" cy="2377440"/>
           </a:xfrm>
           <a:prstGeom prst="roundRect">
             <a:avLst>
-              <a:gd name="adj" fmla="val 3810"/>
+              <a:gd name="adj" fmla="val 4615"/>
             </a:avLst>
           </a:prstGeom>
           <a:solidFill>
@@ -16403,7 +16403,7 @@
         </p:nvSpPr>
         <p:spPr>
           <a:xfrm>
-            <a:off x="8447837" y="2514600"/>
+            <a:off x="8447837" y="2286000"/>
             <a:ext cx="2875178" cy="365760"/>
           </a:xfrm>
           <a:prstGeom prst="rect">
@@ -16442,8 +16442,8 @@
         </p:nvSpPr>
         <p:spPr>
           <a:xfrm>
-            <a:off x="8447837" y="2926080"/>
-            <a:ext cx="2875178" cy="731520"/>
+            <a:off x="8447837" y="2633472"/>
+            <a:ext cx="2875178" cy="566928"/>
           </a:xfrm>
           <a:prstGeom prst="rect">
             <a:avLst/>
@@ -16459,7 +16459,7 @@
               <a:buNone/>
             </a:pPr>
             <a:r>
-              <a:rPr lang="en-US" sz="3600" b="1" dirty="0">
+              <a:rPr lang="en-US" sz="3200" b="1" dirty="0">
                 <a:solidFill>
                   <a:srgbClr val="222222"/>
                 </a:solidFill>
@@ -16469,7 +16469,7 @@
               </a:rPr>
               <a:t>Custom</a:t>
             </a:r>
-            <a:endParaRPr lang="en-US" sz="3600" dirty="0"/>
+            <a:endParaRPr lang="en-US" sz="3200" dirty="0"/>
           </a:p>
         </p:txBody>
       </p:sp>
@@ -16481,8 +16481,8 @@
         </p:nvSpPr>
         <p:spPr>
           <a:xfrm>
-            <a:off x="8447837" y="3749040"/>
-            <a:ext cx="2875178" cy="1280160"/>
+            <a:off x="8447837" y="3218688"/>
+            <a:ext cx="2875178" cy="1152144"/>
           </a:xfrm>
           <a:prstGeom prst="rect">
             <a:avLst/>
@@ -16498,7 +16498,7 @@
               <a:buNone/>
             </a:pPr>
             <a:r>
-              <a:rPr lang="en-US" sz="1200" dirty="0">
+              <a:rPr lang="en-US" sz="1100" dirty="0">
                 <a:solidFill>
                   <a:srgbClr val="222222"/>
                 </a:solidFill>
@@ -16508,19 +16508,268 @@
               </a:rPr>
               <a:t>All platforms + Local SEO + Programmatic</a:t>
             </a:r>
+            <a:endParaRPr lang="en-US" sz="1100" dirty="0"/>
+          </a:p>
+        </p:txBody>
+      </p:sp>
+      <p:sp>
+        <p:nvSpPr>
+          <p:cNvPr id="22" name="Text 19"/>
+          <p:cNvSpPr txBox="1"/>
+          <p:nvPr/>
+        </p:nvSpPr>
+        <p:spPr>
+          <a:xfrm>
+            <a:off x="548640" y="4590288"/>
+            <a:ext cx="2011680" cy="731520"/>
+          </a:xfrm>
+          <a:prstGeom prst="rect">
+            <a:avLst/>
+          </a:prstGeom>
+          <a:noFill/>
+          <a:ln/>
+        </p:spPr>
+        <p:txBody>
+          <a:bodyPr wrap="square" lIns="0" tIns="0" rIns="0" bIns="0" rtlCol="0" anchor="ctr"/>
+          <a:lstStyle/>
+          <a:p>
+            <a:pPr indent="0" marL="0">
+              <a:buNone/>
+            </a:pPr>
+            <a:r>
+              <a:rPr lang="en-US" sz="950" b="1" spc="300" kern="0" dirty="0">
+                <a:solidFill>
+                  <a:srgbClr val="FFFFFF"/>
+                </a:solidFill>
+                <a:latin typeface="Calibri" pitchFamily="34" charset="0"/>
+                <a:ea typeface="Calibri" pitchFamily="34" charset="-122"/>
+                <a:cs typeface="Calibri" pitchFamily="34" charset="-120"/>
+              </a:rPr>
+              <a:t>OPTIONAL ADD-ONS</a:t>
+            </a:r>
+            <a:endParaRPr lang="en-US" sz="950" dirty="0"/>
+          </a:p>
+        </p:txBody>
+      </p:sp>
+      <p:sp>
+        <p:nvSpPr>
+          <p:cNvPr id="23" name="Shape 20"/>
+          <p:cNvSpPr/>
+          <p:nvPr/>
+        </p:nvSpPr>
+        <p:spPr>
+          <a:xfrm>
+            <a:off x="2377440" y="4608576"/>
+            <a:ext cx="4518508" cy="731520"/>
+          </a:xfrm>
+          <a:prstGeom prst="roundRect">
+            <a:avLst>
+              <a:gd name="adj" fmla="val 15000"/>
+            </a:avLst>
+          </a:prstGeom>
+          <a:solidFill>
+            <a:srgbClr val="B84C0C"/>
+          </a:solidFill>
+          <a:ln w="6350">
+            <a:solidFill>
+              <a:srgbClr val="F0B48C"/>
+            </a:solidFill>
+            <a:prstDash val="solid"/>
+          </a:ln>
+        </p:spPr>
+      </p:sp>
+      <p:sp>
+        <p:nvSpPr>
+          <p:cNvPr id="24" name="Text 21"/>
+          <p:cNvSpPr txBox="1"/>
+          <p:nvPr/>
+        </p:nvSpPr>
+        <p:spPr>
+          <a:xfrm>
+            <a:off x="2606040" y="4681728"/>
+            <a:ext cx="4061308" cy="256032"/>
+          </a:xfrm>
+          <a:prstGeom prst="rect">
+            <a:avLst/>
+          </a:prstGeom>
+          <a:noFill/>
+          <a:ln/>
+        </p:spPr>
+        <p:txBody>
+          <a:bodyPr wrap="square" lIns="0" tIns="0" rIns="0" bIns="0" rtlCol="0" anchor="t"/>
+          <a:lstStyle/>
+          <a:p>
+            <a:pPr indent="0" marL="0">
+              <a:buNone/>
+            </a:pPr>
+            <a:r>
+              <a:rPr lang="en-US" sz="1200" b="1" dirty="0">
+                <a:solidFill>
+                  <a:srgbClr val="FFFFFF"/>
+                </a:solidFill>
+                <a:latin typeface="Calibri" pitchFamily="34" charset="0"/>
+                <a:ea typeface="Calibri" pitchFamily="34" charset="-122"/>
+                <a:cs typeface="Calibri" pitchFamily="34" charset="-120"/>
+              </a:rPr>
+              <a:t>Review Generation  ·  $100/mo per location</a:t>
+            </a:r>
             <a:endParaRPr lang="en-US" sz="1200" dirty="0"/>
           </a:p>
         </p:txBody>
       </p:sp>
       <p:sp>
         <p:nvSpPr>
-          <p:cNvPr id="22" name="Text 19"/>
-          <p:cNvSpPr txBox="1"/>
-          <p:nvPr/>
-        </p:nvSpPr>
-        <p:spPr>
-          <a:xfrm>
-            <a:off x="548640" y="5276088"/>
+          <p:cNvPr id="25" name="Text 22"/>
+          <p:cNvSpPr txBox="1"/>
+          <p:nvPr/>
+        </p:nvSpPr>
+        <p:spPr>
+          <a:xfrm>
+            <a:off x="2606040" y="4937760"/>
+            <a:ext cx="4061308" cy="365760"/>
+          </a:xfrm>
+          <a:prstGeom prst="rect">
+            <a:avLst/>
+          </a:prstGeom>
+          <a:noFill/>
+          <a:ln/>
+        </p:spPr>
+        <p:txBody>
+          <a:bodyPr wrap="square" lIns="0" tIns="0" rIns="0" bIns="0" rtlCol="0" anchor="t"/>
+          <a:lstStyle/>
+          <a:p>
+            <a:pPr indent="0" marL="0">
+              <a:buNone/>
+            </a:pPr>
+            <a:r>
+              <a:rPr lang="en-US" sz="950" dirty="0">
+                <a:solidFill>
+                  <a:srgbClr val="FFE3D0"/>
+                </a:solidFill>
+                <a:latin typeface="Calibri" pitchFamily="34" charset="0"/>
+                <a:ea typeface="Calibri" pitchFamily="34" charset="-122"/>
+                <a:cs typeface="Calibri" pitchFamily="34" charset="-120"/>
+              </a:rPr>
+              <a:t>+ messaging fees. We text your customers asking for reviews and gate negative feedback before it goes public.</a:t>
+            </a:r>
+            <a:endParaRPr lang="en-US" sz="950" dirty="0"/>
+          </a:p>
+        </p:txBody>
+      </p:sp>
+      <p:sp>
+        <p:nvSpPr>
+          <p:cNvPr id="26" name="Shape 23"/>
+          <p:cNvSpPr/>
+          <p:nvPr/>
+        </p:nvSpPr>
+        <p:spPr>
+          <a:xfrm>
+            <a:off x="7124548" y="4608576"/>
+            <a:ext cx="4518508" cy="731520"/>
+          </a:xfrm>
+          <a:prstGeom prst="roundRect">
+            <a:avLst>
+              <a:gd name="adj" fmla="val 15000"/>
+            </a:avLst>
+          </a:prstGeom>
+          <a:solidFill>
+            <a:srgbClr val="B84C0C"/>
+          </a:solidFill>
+          <a:ln w="6350">
+            <a:solidFill>
+              <a:srgbClr val="F0B48C"/>
+            </a:solidFill>
+            <a:prstDash val="solid"/>
+          </a:ln>
+        </p:spPr>
+      </p:sp>
+      <p:sp>
+        <p:nvSpPr>
+          <p:cNvPr id="27" name="Text 24"/>
+          <p:cNvSpPr txBox="1"/>
+          <p:nvPr/>
+        </p:nvSpPr>
+        <p:spPr>
+          <a:xfrm>
+            <a:off x="7353148" y="4681728"/>
+            <a:ext cx="4061308" cy="256032"/>
+          </a:xfrm>
+          <a:prstGeom prst="rect">
+            <a:avLst/>
+          </a:prstGeom>
+          <a:noFill/>
+          <a:ln/>
+        </p:spPr>
+        <p:txBody>
+          <a:bodyPr wrap="square" lIns="0" tIns="0" rIns="0" bIns="0" rtlCol="0" anchor="t"/>
+          <a:lstStyle/>
+          <a:p>
+            <a:pPr indent="0" marL="0">
+              <a:buNone/>
+            </a:pPr>
+            <a:r>
+              <a:rPr lang="en-US" sz="1200" b="1" dirty="0">
+                <a:solidFill>
+                  <a:srgbClr val="FFFFFF"/>
+                </a:solidFill>
+                <a:latin typeface="Calibri" pitchFamily="34" charset="0"/>
+                <a:ea typeface="Calibri" pitchFamily="34" charset="-122"/>
+                <a:cs typeface="Calibri" pitchFamily="34" charset="-120"/>
+              </a:rPr>
+              <a:t>Product Image Management  ·  $10/hr</a:t>
+            </a:r>
+            <a:endParaRPr lang="en-US" sz="1200" dirty="0"/>
+          </a:p>
+        </p:txBody>
+      </p:sp>
+      <p:sp>
+        <p:nvSpPr>
+          <p:cNvPr id="28" name="Text 25"/>
+          <p:cNvSpPr txBox="1"/>
+          <p:nvPr/>
+        </p:nvSpPr>
+        <p:spPr>
+          <a:xfrm>
+            <a:off x="7353148" y="4937760"/>
+            <a:ext cx="4061308" cy="365760"/>
+          </a:xfrm>
+          <a:prstGeom prst="rect">
+            <a:avLst/>
+          </a:prstGeom>
+          <a:noFill/>
+          <a:ln/>
+        </p:spPr>
+        <p:txBody>
+          <a:bodyPr wrap="square" lIns="0" tIns="0" rIns="0" bIns="0" rtlCol="0" anchor="t"/>
+          <a:lstStyle/>
+          <a:p>
+            <a:pPr indent="0" marL="0">
+              <a:buNone/>
+            </a:pPr>
+            <a:r>
+              <a:rPr lang="en-US" sz="950" dirty="0">
+                <a:solidFill>
+                  <a:srgbClr val="FFE3D0"/>
+                </a:solidFill>
+                <a:latin typeface="Calibri" pitchFamily="34" charset="0"/>
+                <a:ea typeface="Calibri" pitchFamily="34" charset="-122"/>
+                <a:cs typeface="Calibri" pitchFamily="34" charset="-120"/>
+              </a:rPr>
+              <a:t>Our team finds, edits and uploads product images to your online menus.</a:t>
+            </a:r>
+            <a:endParaRPr lang="en-US" sz="950" dirty="0"/>
+          </a:p>
+        </p:txBody>
+      </p:sp>
+      <p:sp>
+        <p:nvSpPr>
+          <p:cNvPr id="29" name="Text 26"/>
+          <p:cNvSpPr txBox="1"/>
+          <p:nvPr/>
+        </p:nvSpPr>
+        <p:spPr>
+          <a:xfrm>
+            <a:off x="548640" y="5431536"/>
             <a:ext cx="6858000" cy="365760"/>
           </a:xfrm>
           <a:prstGeom prst="rect">
@@ -16553,13 +16802,13 @@
       </p:sp>
       <p:sp>
         <p:nvSpPr>
-          <p:cNvPr id="23" name="Text 20"/>
-          <p:cNvSpPr txBox="1"/>
-          <p:nvPr/>
-        </p:nvSpPr>
-        <p:spPr>
-          <a:xfrm>
-            <a:off x="548640" y="5660136"/>
+          <p:cNvPr id="30" name="Text 27"/>
+          <p:cNvSpPr txBox="1"/>
+          <p:nvPr/>
+        </p:nvSpPr>
+        <p:spPr>
+          <a:xfrm>
+            <a:off x="548640" y="5815584"/>
             <a:ext cx="6858000" cy="365760"/>
           </a:xfrm>
           <a:prstGeom prst="rect">

</xml_diff>

<commit_message>
Refine Weedmaps scope copy: efficient placement, strain tagging, promo codes
Co-Authored-By: Claude Fable 5.1 <noreply@anthropic.com>
Claude-Session: https://claude.ai/code/session_01RhvxWoxVegp3rGjZ4khBZo
</commit_message>
<xml_diff>
--- a/decks/Sparks-x-example-green-valley.pptx
+++ b/decks/Sparks-x-example-green-valley.pptx
@@ -12697,7 +12697,7 @@
                 <a:ea typeface="Calibri" pitchFamily="34" charset="-122"/>
                 <a:cs typeface="Calibri" pitchFamily="34" charset="-120"/>
               </a:rPr>
-              <a:t>Daily budget pacing and bid management for top placement in every service zone</a:t>
+              <a:t>Daily budget pacing and bid management for the most efficient placement in every service zone</a:t>
             </a:r>
             <a:endParaRPr lang="en-US" sz="1150" dirty="0"/>
           </a:p>
@@ -13035,7 +13035,7 @@
                 <a:ea typeface="Calibri" pitchFamily="34" charset="-122"/>
                 <a:cs typeface="Calibri" pitchFamily="34" charset="-120"/>
               </a:rPr>
-              <a:t>Menu management synced with your POS; every product verified</a:t>
+              <a:t>Menu management synced with your POS; every product verified and strain tagged, featured products kept current</a:t>
             </a:r>
             <a:endParaRPr lang="en-US" sz="1150" dirty="0"/>
           </a:p>
@@ -13204,7 +13204,7 @@
                 <a:ea typeface="Calibri" pitchFamily="34" charset="-122"/>
                 <a:cs typeface="Calibri" pitchFamily="34" charset="-120"/>
               </a:rPr>
-              <a:t>Daily and monthly deal activations, BOGOs, and featured products</a:t>
+              <a:t>Daily and monthly deal activations, BOGOs, promo codes, sales pricing and daily product mapping</a:t>
             </a:r>
             <a:endParaRPr lang="en-US" sz="1150" dirty="0"/>
           </a:p>

</xml_diff>

<commit_message>
Reprice to Single Platform Management $495 + Listing Bundle $495 = $990
The first investment card is now "Single Platform Management" for any
one platform (the focus platform, not necessarily Weedmaps); the
Listing Bundle adds every other platform for +$495/mo; Total Package is
$990/mo. Applied to every prospect, the template, the knowledge base
and CLAUDE.md. Next-steps summary can use a short `summary` label.

Co-Authored-By: Claude Fable 5.1 <noreply@anthropic.com>
Claude-Session: https://claude.ai/code/session_01RhvxWoxVegp3rGjZ4khBZo
</commit_message>
<xml_diff>
--- a/decks/Sparks-x-example-green-valley.pptx
+++ b/decks/Sparks-x-example-green-valley.pptx
@@ -1659,7 +1659,7 @@
           <a:p>
             <a:r>
               <a:rPr lang="en-US" dirty="0"/>
-              <a:t>Pricing for Weedmaps Management. Results in 30 days or your money back. Ad spend is billed by the platform; the fee covers management. Each add-on is $495/mo. Optional add-ons, priced separately and not in the package total: Review Generation ($100/mo per location — + messaging fees. We text your customers asking for reviews and gate negative feedback before it goes public.); Product Image Management ($10/hr — Our team finds, edits and uploads product images to your online menus.).</a:t>
+              <a:t>Single platform management is $495/mo for any one platform (Weedmaps here); the listing bundle adds every other platform for another $495/mo. Results in 30 days or your money back. Ad spend is billed by the platform; the fee covers management. Each add-on is $495/mo. Optional add-ons, priced separately and not in the package total: Review Generation ($100/mo per location — + messaging fees. We text your customers asking for reviews and gate negative feedback before it goes public.); Product Image Management ($10/hr — Our team finds, edits and uploads product images to your online menus.).</a:t>
             </a:r>
             <a:endParaRPr lang="en-US" dirty="0"/>
           </a:p>
@@ -7589,7 +7589,7 @@
                 <a:ea typeface="Calibri" pitchFamily="34" charset="-122"/>
                 <a:cs typeface="Calibri" pitchFamily="34" charset="-120"/>
               </a:rPr>
-              <a:t>Launch</a:t>
+              <a:t>Single Platform (Weedmaps)</a:t>
             </a:r>
             <a:endParaRPr lang="en-US" sz="1200" dirty="0"/>
           </a:p>
@@ -7628,7 +7628,7 @@
                 <a:ea typeface="Calibri" pitchFamily="34" charset="-122"/>
                 <a:cs typeface="Calibri" pitchFamily="34" charset="-120"/>
               </a:rPr>
-              <a:t>Custom</a:t>
+              <a:t>$495/mo</a:t>
             </a:r>
             <a:endParaRPr lang="en-US" sz="1200" dirty="0"/>
           </a:p>
@@ -7667,7 +7667,7 @@
                 <a:ea typeface="Calibri" pitchFamily="34" charset="-122"/>
                 <a:cs typeface="Calibri" pitchFamily="34" charset="-120"/>
               </a:rPr>
-              <a:t>Growth</a:t>
+              <a:t>Listing Bundle  (optional)</a:t>
             </a:r>
             <a:endParaRPr lang="en-US" sz="1200" dirty="0"/>
           </a:p>
@@ -7706,7 +7706,7 @@
                 <a:ea typeface="Calibri" pitchFamily="34" charset="-122"/>
                 <a:cs typeface="Calibri" pitchFamily="34" charset="-120"/>
               </a:rPr>
-              <a:t>Custom</a:t>
+              <a:t>+$495/mo</a:t>
             </a:r>
             <a:endParaRPr lang="en-US" sz="1200" dirty="0"/>
           </a:p>
@@ -7714,7 +7714,30 @@
       </p:sp>
       <p:sp>
         <p:nvSpPr>
-          <p:cNvPr id="29" name="Text 25"/>
+          <p:cNvPr id="29" name="Shape 25"/>
+          <p:cNvSpPr/>
+          <p:nvPr/>
+        </p:nvSpPr>
+        <p:spPr>
+          <a:xfrm>
+            <a:off x="7909560" y="3462528"/>
+            <a:ext cx="3413455" cy="0"/>
+          </a:xfrm>
+          <a:prstGeom prst="line">
+            <a:avLst/>
+          </a:prstGeom>
+          <a:noFill/>
+          <a:ln w="9525">
+            <a:solidFill>
+              <a:srgbClr val="F0B48C"/>
+            </a:solidFill>
+            <a:prstDash val="solid"/>
+          </a:ln>
+        </p:spPr>
+      </p:sp>
+      <p:sp>
+        <p:nvSpPr>
+          <p:cNvPr id="30" name="Text 26"/>
           <p:cNvSpPr txBox="1"/>
           <p:nvPr/>
         </p:nvSpPr>
@@ -7737,7 +7760,7 @@
               <a:buNone/>
             </a:pPr>
             <a:r>
-              <a:rPr lang="en-US" sz="1200" dirty="0">
+              <a:rPr lang="en-US" sz="1200" b="1" dirty="0">
                 <a:solidFill>
                   <a:srgbClr val="FFFFFF"/>
                 </a:solidFill>
@@ -7745,7 +7768,7 @@
                 <a:ea typeface="Calibri" pitchFamily="34" charset="-122"/>
                 <a:cs typeface="Calibri" pitchFamily="34" charset="-120"/>
               </a:rPr>
-              <a:t>Dominate</a:t>
+              <a:t>Total Package</a:t>
             </a:r>
             <a:endParaRPr lang="en-US" sz="1200" dirty="0"/>
           </a:p>
@@ -7753,7 +7776,7 @@
       </p:sp>
       <p:sp>
         <p:nvSpPr>
-          <p:cNvPr id="30" name="Text 26"/>
+          <p:cNvPr id="31" name="Text 27"/>
           <p:cNvSpPr txBox="1"/>
           <p:nvPr/>
         </p:nvSpPr>
@@ -7776,7 +7799,7 @@
               <a:buNone/>
             </a:pPr>
             <a:r>
-              <a:rPr lang="en-US" sz="1200" b="1" dirty="0">
+              <a:rPr lang="en-US" sz="1400" b="1" dirty="0">
                 <a:solidFill>
                   <a:srgbClr val="FFFFFF"/>
                 </a:solidFill>
@@ -7784,15 +7807,15 @@
                 <a:ea typeface="Calibri" pitchFamily="34" charset="-122"/>
                 <a:cs typeface="Calibri" pitchFamily="34" charset="-120"/>
               </a:rPr>
-              <a:t>Custom</a:t>
-            </a:r>
-            <a:endParaRPr lang="en-US" sz="1200" dirty="0"/>
-          </a:p>
-        </p:txBody>
-      </p:sp>
-      <p:sp>
-        <p:nvSpPr>
-          <p:cNvPr id="31" name="Text 27"/>
+              <a:t>$990/mo</a:t>
+            </a:r>
+            <a:endParaRPr lang="en-US" sz="1400" dirty="0"/>
+          </a:p>
+        </p:txBody>
+      </p:sp>
+      <p:sp>
+        <p:nvSpPr>
+          <p:cNvPr id="32" name="Text 28"/>
           <p:cNvSpPr txBox="1"/>
           <p:nvPr/>
         </p:nvSpPr>
@@ -7831,7 +7854,7 @@
       </p:sp>
       <p:sp>
         <p:nvSpPr>
-          <p:cNvPr id="32" name="Text 28"/>
+          <p:cNvPr id="33" name="Text 29"/>
           <p:cNvSpPr txBox="1"/>
           <p:nvPr/>
         </p:nvSpPr>
@@ -7870,7 +7893,7 @@
       </p:sp>
       <p:sp>
         <p:nvSpPr>
-          <p:cNvPr id="33" name="Text 29"/>
+          <p:cNvPr id="34" name="Text 30"/>
           <p:cNvSpPr txBox="1"/>
           <p:nvPr/>
         </p:nvSpPr>
@@ -7909,7 +7932,7 @@
       </p:sp>
       <p:sp>
         <p:nvSpPr>
-          <p:cNvPr id="34" name="Text 30"/>
+          <p:cNvPr id="35" name="Text 31"/>
           <p:cNvSpPr txBox="1"/>
           <p:nvPr/>
         </p:nvSpPr>
@@ -7948,7 +7971,7 @@
       </p:sp>
       <p:sp>
         <p:nvSpPr>
-          <p:cNvPr id="35" name="Text 31"/>
+          <p:cNvPr id="36" name="Text 32"/>
           <p:cNvSpPr txBox="1"/>
           <p:nvPr/>
         </p:nvSpPr>
@@ -7987,7 +8010,7 @@
       </p:sp>
       <p:sp>
         <p:nvSpPr>
-          <p:cNvPr id="36" name="Text 32"/>
+          <p:cNvPr id="37" name="Text 33"/>
           <p:cNvSpPr txBox="1"/>
           <p:nvPr/>
         </p:nvSpPr>
@@ -8026,7 +8049,7 @@
       </p:sp>
       <p:sp>
         <p:nvSpPr>
-          <p:cNvPr id="37" name="Text 33"/>
+          <p:cNvPr id="38" name="Text 34"/>
           <p:cNvSpPr txBox="1"/>
           <p:nvPr/>
         </p:nvSpPr>
@@ -8065,7 +8088,7 @@
       </p:sp>
       <p:sp>
         <p:nvSpPr>
-          <p:cNvPr id="38" name="Text 34"/>
+          <p:cNvPr id="39" name="Text 35"/>
           <p:cNvSpPr txBox="1"/>
           <p:nvPr/>
         </p:nvSpPr>
@@ -16035,7 +16058,7 @@
                 <a:ea typeface="Arial" pitchFamily="34" charset="-122"/>
                 <a:cs typeface="Arial" pitchFamily="34" charset="-120"/>
               </a:rPr>
-              <a:t>Weedmaps Management investment</a:t>
+              <a:t>Investment</a:t>
             </a:r>
             <a:endParaRPr lang="en-US" sz="3400" dirty="0"/>
           </a:p>
@@ -16074,7 +16097,7 @@
                 <a:ea typeface="Calibri" pitchFamily="34" charset="-122"/>
                 <a:cs typeface="Calibri" pitchFamily="34" charset="-120"/>
               </a:rPr>
-              <a:t>Month-to-month after 90-day launch</a:t>
+              <a:t>Single platform management, with every other platform as one optional bundle. Month-to-month after 90-day launch.</a:t>
             </a:r>
             <a:endParaRPr lang="en-US" sz="1500" dirty="0"/>
           </a:p>
@@ -16140,7 +16163,7 @@
                 <a:ea typeface="Calibri" pitchFamily="34" charset="-122"/>
                 <a:cs typeface="Calibri" pitchFamily="34" charset="-120"/>
               </a:rPr>
-              <a:t>Launch</a:t>
+              <a:t>Single Platform Management</a:t>
             </a:r>
             <a:endParaRPr lang="en-US" sz="1600" dirty="0"/>
           </a:p>
@@ -16179,7 +16202,7 @@
                 <a:ea typeface="Arial" pitchFamily="34" charset="-122"/>
                 <a:cs typeface="Arial" pitchFamily="34" charset="-120"/>
               </a:rPr>
-              <a:t>Custom</a:t>
+              <a:t>$495/mo</a:t>
             </a:r>
             <a:endParaRPr lang="en-US" sz="3200" dirty="0"/>
           </a:p>
@@ -16194,7 +16217,7 @@
         <p:spPr>
           <a:xfrm>
             <a:off x="868680" y="3218688"/>
-            <a:ext cx="2875178" cy="1152144"/>
+            <a:ext cx="2875178" cy="457200"/>
           </a:xfrm>
           <a:prstGeom prst="rect">
             <a:avLst/>
@@ -16210,6 +16233,45 @@
               <a:buNone/>
             </a:pPr>
             <a:r>
+              <a:rPr lang="en-US" sz="1050" i="1" dirty="0">
+                <a:solidFill>
+                  <a:srgbClr val="DD5F13"/>
+                </a:solidFill>
+                <a:latin typeface="Calibri" pitchFamily="34" charset="0"/>
+                <a:ea typeface="Calibri" pitchFamily="34" charset="-122"/>
+                <a:cs typeface="Calibri" pitchFamily="34" charset="-120"/>
+              </a:rPr>
+              <a:t>or 10% of that platform's ad spend once it exceeds $4,950/mo</a:t>
+            </a:r>
+            <a:endParaRPr lang="en-US" sz="1050" dirty="0"/>
+          </a:p>
+        </p:txBody>
+      </p:sp>
+      <p:sp>
+        <p:nvSpPr>
+          <p:cNvPr id="14" name="Text 11"/>
+          <p:cNvSpPr txBox="1"/>
+          <p:nvPr/>
+        </p:nvSpPr>
+        <p:spPr>
+          <a:xfrm>
+            <a:off x="868680" y="3675888"/>
+            <a:ext cx="2875178" cy="694944"/>
+          </a:xfrm>
+          <a:prstGeom prst="rect">
+            <a:avLst/>
+          </a:prstGeom>
+          <a:noFill/>
+          <a:ln/>
+        </p:spPr>
+        <p:txBody>
+          <a:bodyPr wrap="square" lIns="0" tIns="0" rIns="0" bIns="0" rtlCol="0" anchor="t"/>
+          <a:lstStyle/>
+          <a:p>
+            <a:pPr indent="0" marL="0">
+              <a:buNone/>
+            </a:pPr>
+            <a:r>
               <a:rPr lang="en-US" sz="1100" dirty="0">
                 <a:solidFill>
                   <a:srgbClr val="222222"/>
@@ -16218,7 +16280,7 @@
                 <a:ea typeface="Calibri" pitchFamily="34" charset="-122"/>
                 <a:cs typeface="Calibri" pitchFamily="34" charset="-120"/>
               </a:rPr>
-              <a:t>Weedmaps + Google</a:t>
+              <a:t>Any one platform — Weedmaps in this proposal: bids, listings, menus, deals, graphics, reviews, weekly reporting</a:t>
             </a:r>
             <a:endParaRPr lang="en-US" sz="1100" dirty="0"/>
           </a:p>
@@ -16226,7 +16288,7 @@
       </p:sp>
       <p:sp>
         <p:nvSpPr>
-          <p:cNvPr id="14" name="Shape 11"/>
+          <p:cNvPr id="15" name="Shape 12"/>
           <p:cNvSpPr/>
           <p:nvPr/>
         </p:nvSpPr>
@@ -16253,7 +16315,7 @@
       </p:sp>
       <p:sp>
         <p:nvSpPr>
-          <p:cNvPr id="15" name="Text 12"/>
+          <p:cNvPr id="16" name="Text 13"/>
           <p:cNvSpPr txBox="1"/>
           <p:nvPr/>
         </p:nvSpPr>
@@ -16284,7 +16346,7 @@
                 <a:ea typeface="Calibri" pitchFamily="34" charset="-122"/>
                 <a:cs typeface="Calibri" pitchFamily="34" charset="-120"/>
               </a:rPr>
-              <a:t>Growth</a:t>
+              <a:t>Listing Bundle</a:t>
             </a:r>
             <a:endParaRPr lang="en-US" sz="1600" dirty="0"/>
           </a:p>
@@ -16292,7 +16354,7 @@
       </p:sp>
       <p:sp>
         <p:nvSpPr>
-          <p:cNvPr id="16" name="Text 13"/>
+          <p:cNvPr id="17" name="Text 14"/>
           <p:cNvSpPr txBox="1"/>
           <p:nvPr/>
         </p:nvSpPr>
@@ -16323,7 +16385,7 @@
                 <a:ea typeface="Arial" pitchFamily="34" charset="-122"/>
                 <a:cs typeface="Arial" pitchFamily="34" charset="-120"/>
               </a:rPr>
-              <a:t>Custom</a:t>
+              <a:t>+$495/mo</a:t>
             </a:r>
             <a:endParaRPr lang="en-US" sz="3200" dirty="0"/>
           </a:p>
@@ -16331,14 +16393,14 @@
       </p:sp>
       <p:sp>
         <p:nvSpPr>
-          <p:cNvPr id="17" name="Text 14"/>
+          <p:cNvPr id="18" name="Text 15"/>
           <p:cNvSpPr txBox="1"/>
           <p:nvPr/>
         </p:nvSpPr>
         <p:spPr>
           <a:xfrm>
             <a:off x="4658258" y="3218688"/>
-            <a:ext cx="2875178" cy="1152144"/>
+            <a:ext cx="2875178" cy="457200"/>
           </a:xfrm>
           <a:prstGeom prst="rect">
             <a:avLst/>
@@ -16354,6 +16416,45 @@
               <a:buNone/>
             </a:pPr>
             <a:r>
+              <a:rPr lang="en-US" sz="1050" i="1" dirty="0">
+                <a:solidFill>
+                  <a:srgbClr val="DD5F13"/>
+                </a:solidFill>
+                <a:latin typeface="Calibri" pitchFamily="34" charset="0"/>
+                <a:ea typeface="Calibri" pitchFamily="34" charset="-122"/>
+                <a:cs typeface="Calibri" pitchFamily="34" charset="-120"/>
+              </a:rPr>
+              <a:t>or 10% of ad spend if any platform's spend exceeds $4,950/mo</a:t>
+            </a:r>
+            <a:endParaRPr lang="en-US" sz="1050" dirty="0"/>
+          </a:p>
+        </p:txBody>
+      </p:sp>
+      <p:sp>
+        <p:nvSpPr>
+          <p:cNvPr id="19" name="Text 16"/>
+          <p:cNvSpPr txBox="1"/>
+          <p:nvPr/>
+        </p:nvSpPr>
+        <p:spPr>
+          <a:xfrm>
+            <a:off x="4658258" y="3675888"/>
+            <a:ext cx="2875178" cy="694944"/>
+          </a:xfrm>
+          <a:prstGeom prst="rect">
+            <a:avLst/>
+          </a:prstGeom>
+          <a:noFill/>
+          <a:ln/>
+        </p:spPr>
+        <p:txBody>
+          <a:bodyPr wrap="square" lIns="0" tIns="0" rIns="0" bIns="0" rtlCol="0" anchor="t"/>
+          <a:lstStyle/>
+          <a:p>
+            <a:pPr indent="0" marL="0">
+              <a:buNone/>
+            </a:pPr>
+            <a:r>
               <a:rPr lang="en-US" sz="1100" dirty="0">
                 <a:solidFill>
                   <a:srgbClr val="222222"/>
@@ -16362,7 +16463,7 @@
                 <a:ea typeface="Calibri" pitchFamily="34" charset="-122"/>
                 <a:cs typeface="Calibri" pitchFamily="34" charset="-120"/>
               </a:rPr>
-              <a:t>Weedmaps + Leafly + Yelp + Google</a:t>
+              <a:t>Every other platform: Leafly + Yelp + Google + Apple Maps and 20 directories — same seven pillars everywhere</a:t>
             </a:r>
             <a:endParaRPr lang="en-US" sz="1100" dirty="0"/>
           </a:p>
@@ -16370,7 +16471,7 @@
       </p:sp>
       <p:sp>
         <p:nvSpPr>
-          <p:cNvPr id="18" name="Shape 15"/>
+          <p:cNvPr id="20" name="Shape 17"/>
           <p:cNvSpPr/>
           <p:nvPr/>
         </p:nvSpPr>
@@ -16385,7 +16486,7 @@
             </a:avLst>
           </a:prstGeom>
           <a:solidFill>
-            <a:srgbClr val="FFFFFF"/>
+            <a:srgbClr val="FDE7D8"/>
           </a:solidFill>
           <a:ln w="6350">
             <a:solidFill>
@@ -16397,14 +16498,104 @@
       </p:sp>
       <p:sp>
         <p:nvSpPr>
-          <p:cNvPr id="19" name="Text 16"/>
+          <p:cNvPr id="21" name="Shape 18"/>
+          <p:cNvSpPr/>
+          <p:nvPr/>
+        </p:nvSpPr>
+        <p:spPr>
+          <a:xfrm>
+            <a:off x="8127797" y="2103120"/>
+            <a:ext cx="3515258" cy="2377440"/>
+          </a:xfrm>
+          <a:prstGeom prst="roundRect">
+            <a:avLst>
+              <a:gd name="adj" fmla="val 4615"/>
+            </a:avLst>
+          </a:prstGeom>
+          <a:ln w="25400">
+            <a:solidFill>
+              <a:srgbClr val="FFFFFF"/>
+            </a:solidFill>
+            <a:prstDash val="solid"/>
+          </a:ln>
+        </p:spPr>
+      </p:sp>
+      <p:sp>
+        <p:nvSpPr>
+          <p:cNvPr id="22" name="Shape 19"/>
+          <p:cNvSpPr/>
+          <p:nvPr/>
+        </p:nvSpPr>
+        <p:spPr>
+          <a:xfrm>
+            <a:off x="10134295" y="2359152"/>
+            <a:ext cx="1234440" cy="310896"/>
+          </a:xfrm>
+          <a:prstGeom prst="roundRect">
+            <a:avLst>
+              <a:gd name="adj" fmla="val 50000"/>
+            </a:avLst>
+          </a:prstGeom>
+          <a:solidFill>
+            <a:srgbClr val="DD5F13"/>
+          </a:solidFill>
+          <a:ln w="12700">
+            <a:solidFill>
+              <a:srgbClr val="DD5F13"/>
+            </a:solidFill>
+            <a:prstDash val="solid"/>
+          </a:ln>
+        </p:spPr>
+      </p:sp>
+      <p:sp>
+        <p:nvSpPr>
+          <p:cNvPr id="23" name="Text 20"/>
+          <p:cNvSpPr txBox="1"/>
+          <p:nvPr/>
+        </p:nvSpPr>
+        <p:spPr>
+          <a:xfrm>
+            <a:off x="10134295" y="2359152"/>
+            <a:ext cx="1234440" cy="310896"/>
+          </a:xfrm>
+          <a:prstGeom prst="rect">
+            <a:avLst/>
+          </a:prstGeom>
+          <a:noFill/>
+          <a:ln/>
+        </p:spPr>
+        <p:txBody>
+          <a:bodyPr wrap="square" lIns="0" tIns="0" rIns="0" bIns="0" rtlCol="0" anchor="ctr"/>
+          <a:lstStyle/>
+          <a:p>
+            <a:pPr algn="ctr" indent="0" marL="0">
+              <a:buNone/>
+            </a:pPr>
+            <a:r>
+              <a:rPr lang="en-US" sz="950" b="1" spc="100" kern="0" dirty="0">
+                <a:solidFill>
+                  <a:srgbClr val="FFFFFF"/>
+                </a:solidFill>
+                <a:latin typeface="Calibri" pitchFamily="34" charset="0"/>
+                <a:ea typeface="Calibri" pitchFamily="34" charset="-122"/>
+                <a:cs typeface="Calibri" pitchFamily="34" charset="-120"/>
+              </a:rPr>
+              <a:t>RECOMMENDED</a:t>
+            </a:r>
+            <a:endParaRPr lang="en-US" sz="950" dirty="0"/>
+          </a:p>
+        </p:txBody>
+      </p:sp>
+      <p:sp>
+        <p:nvSpPr>
+          <p:cNvPr id="24" name="Text 21"/>
           <p:cNvSpPr txBox="1"/>
           <p:nvPr/>
         </p:nvSpPr>
         <p:spPr>
           <a:xfrm>
             <a:off x="8447837" y="2286000"/>
-            <a:ext cx="2875178" cy="365760"/>
+            <a:ext cx="1595018" cy="365760"/>
           </a:xfrm>
           <a:prstGeom prst="rect">
             <a:avLst/>
@@ -16428,7 +16619,7 @@
                 <a:ea typeface="Calibri" pitchFamily="34" charset="-122"/>
                 <a:cs typeface="Calibri" pitchFamily="34" charset="-120"/>
               </a:rPr>
-              <a:t>Dominate</a:t>
+              <a:t>Total Package</a:t>
             </a:r>
             <a:endParaRPr lang="en-US" sz="1600" dirty="0"/>
           </a:p>
@@ -16436,7 +16627,7 @@
       </p:sp>
       <p:sp>
         <p:nvSpPr>
-          <p:cNvPr id="20" name="Text 17"/>
+          <p:cNvPr id="25" name="Text 22"/>
           <p:cNvSpPr txBox="1"/>
           <p:nvPr/>
         </p:nvSpPr>
@@ -16467,7 +16658,7 @@
                 <a:ea typeface="Arial" pitchFamily="34" charset="-122"/>
                 <a:cs typeface="Arial" pitchFamily="34" charset="-120"/>
               </a:rPr>
-              <a:t>Custom</a:t>
+              <a:t>$990/mo</a:t>
             </a:r>
             <a:endParaRPr lang="en-US" sz="3200" dirty="0"/>
           </a:p>
@@ -16475,14 +16666,14 @@
       </p:sp>
       <p:sp>
         <p:nvSpPr>
-          <p:cNvPr id="21" name="Text 18"/>
+          <p:cNvPr id="26" name="Text 23"/>
           <p:cNvSpPr txBox="1"/>
           <p:nvPr/>
         </p:nvSpPr>
         <p:spPr>
           <a:xfrm>
             <a:off x="8447837" y="3218688"/>
-            <a:ext cx="2875178" cy="1152144"/>
+            <a:ext cx="2875178" cy="457200"/>
           </a:xfrm>
           <a:prstGeom prst="rect">
             <a:avLst/>
@@ -16498,6 +16689,45 @@
               <a:buNone/>
             </a:pPr>
             <a:r>
+              <a:rPr lang="en-US" sz="1050" i="1" dirty="0">
+                <a:solidFill>
+                  <a:srgbClr val="DD5F13"/>
+                </a:solidFill>
+                <a:latin typeface="Calibri" pitchFamily="34" charset="0"/>
+                <a:ea typeface="Calibri" pitchFamily="34" charset="-122"/>
+                <a:cs typeface="Calibri" pitchFamily="34" charset="-120"/>
+              </a:rPr>
+              <a:t>or 10% of ad spend where the spend thresholds are exceeded</a:t>
+            </a:r>
+            <a:endParaRPr lang="en-US" sz="1050" dirty="0"/>
+          </a:p>
+        </p:txBody>
+      </p:sp>
+      <p:sp>
+        <p:nvSpPr>
+          <p:cNvPr id="27" name="Text 24"/>
+          <p:cNvSpPr txBox="1"/>
+          <p:nvPr/>
+        </p:nvSpPr>
+        <p:spPr>
+          <a:xfrm>
+            <a:off x="8447837" y="3675888"/>
+            <a:ext cx="2875178" cy="694944"/>
+          </a:xfrm>
+          <a:prstGeom prst="rect">
+            <a:avLst/>
+          </a:prstGeom>
+          <a:noFill/>
+          <a:ln/>
+        </p:spPr>
+        <p:txBody>
+          <a:bodyPr wrap="square" lIns="0" tIns="0" rIns="0" bIns="0" rtlCol="0" anchor="t"/>
+          <a:lstStyle/>
+          <a:p>
+            <a:pPr indent="0" marL="0">
+              <a:buNone/>
+            </a:pPr>
+            <a:r>
               <a:rPr lang="en-US" sz="1100" dirty="0">
                 <a:solidFill>
                   <a:srgbClr val="222222"/>
@@ -16506,7 +16736,7 @@
                 <a:ea typeface="Calibri" pitchFamily="34" charset="-122"/>
                 <a:cs typeface="Calibri" pitchFamily="34" charset="-120"/>
               </a:rPr>
-              <a:t>All platforms + Local SEO + Programmatic</a:t>
+              <a:t>Every marketplace, map and directory your customers use — one team, one report.</a:t>
             </a:r>
             <a:endParaRPr lang="en-US" sz="1100" dirty="0"/>
           </a:p>
@@ -16514,7 +16744,7 @@
       </p:sp>
       <p:sp>
         <p:nvSpPr>
-          <p:cNvPr id="22" name="Text 19"/>
+          <p:cNvPr id="28" name="Text 25"/>
           <p:cNvSpPr txBox="1"/>
           <p:nvPr/>
         </p:nvSpPr>
@@ -16553,7 +16783,7 @@
       </p:sp>
       <p:sp>
         <p:nvSpPr>
-          <p:cNvPr id="23" name="Shape 20"/>
+          <p:cNvPr id="29" name="Shape 26"/>
           <p:cNvSpPr/>
           <p:nvPr/>
         </p:nvSpPr>
@@ -16580,7 +16810,7 @@
       </p:sp>
       <p:sp>
         <p:nvSpPr>
-          <p:cNvPr id="24" name="Text 21"/>
+          <p:cNvPr id="30" name="Text 27"/>
           <p:cNvSpPr txBox="1"/>
           <p:nvPr/>
         </p:nvSpPr>
@@ -16619,7 +16849,7 @@
       </p:sp>
       <p:sp>
         <p:nvSpPr>
-          <p:cNvPr id="25" name="Text 22"/>
+          <p:cNvPr id="31" name="Text 28"/>
           <p:cNvSpPr txBox="1"/>
           <p:nvPr/>
         </p:nvSpPr>
@@ -16658,7 +16888,7 @@
       </p:sp>
       <p:sp>
         <p:nvSpPr>
-          <p:cNvPr id="26" name="Shape 23"/>
+          <p:cNvPr id="32" name="Shape 29"/>
           <p:cNvSpPr/>
           <p:nvPr/>
         </p:nvSpPr>
@@ -16685,7 +16915,7 @@
       </p:sp>
       <p:sp>
         <p:nvSpPr>
-          <p:cNvPr id="27" name="Text 24"/>
+          <p:cNvPr id="33" name="Text 30"/>
           <p:cNvSpPr txBox="1"/>
           <p:nvPr/>
         </p:nvSpPr>
@@ -16724,7 +16954,7 @@
       </p:sp>
       <p:sp>
         <p:nvSpPr>
-          <p:cNvPr id="28" name="Text 25"/>
+          <p:cNvPr id="34" name="Text 31"/>
           <p:cNvSpPr txBox="1"/>
           <p:nvPr/>
         </p:nvSpPr>
@@ -16763,7 +16993,7 @@
       </p:sp>
       <p:sp>
         <p:nvSpPr>
-          <p:cNvPr id="29" name="Text 26"/>
+          <p:cNvPr id="35" name="Text 32"/>
           <p:cNvSpPr txBox="1"/>
           <p:nvPr/>
         </p:nvSpPr>
@@ -16802,7 +17032,7 @@
       </p:sp>
       <p:sp>
         <p:nvSpPr>
-          <p:cNvPr id="30" name="Text 27"/>
+          <p:cNvPr id="36" name="Text 33"/>
           <p:cNvSpPr txBox="1"/>
           <p:nvPr/>
         </p:nvSpPr>

</xml_diff>

<commit_message>
Next steps: kickoff, 30-day launch, measure & optimize, repeat & grow
Standard four-step process on the Next Steps slide (layout now fits four
steps). Kickoff aligns on goals, info, deals, menu, connects every
platform and sets up the analytics dashboard; month two measures the
return and re-tunes positions, deals, products and graphics; then the
cycle repeats monthly. Prospect plans updated to the same shape.

Co-Authored-By: Claude Fable 5.1 <noreply@anthropic.com>
Claude-Session: https://claude.ai/code/session_01RhvxWoxVegp3rGjZ4khBZo
</commit_message>
<xml_diff>
--- a/decks/Sparks-x-example-green-valley.pptx
+++ b/decks/Sparks-x-example-green-valley.pptx
@@ -955,7 +955,7 @@
           <a:p>
             <a:r>
               <a:rPr lang="en-US" dirty="0"/>
-              <a:t>Close: restate the guarantee, propose a start date, and ask for Weedmaps admin access to begin the audit. Add-ons are $495/mo each. Can be switched on at any time.</a:t>
+              <a:t>Walk the process: kickoff (align on goals, info, deals, menu; connect every platform; set up the analytics dashboard), a 30-day launch, then every month we measure what the changes did to the return and re-tune positions, deals, products and graphics — rinse and repeat to keep growing it. Close: restate the guarantee, propose a kickoff date, and ask for Weedmaps admin access. Add-ons are $495/mo each. Can be switched on at any time.</a:t>
             </a:r>
             <a:endParaRPr lang="en-US" dirty="0"/>
           </a:p>
@@ -6995,7 +6995,7 @@
                 <a:ea typeface="Calibri" pitchFamily="34" charset="-122"/>
                 <a:cs typeface="Calibri" pitchFamily="34" charset="-120"/>
               </a:rPr>
-              <a:t>A 90-day Weedmaps launch plan for Green Valley Dispensary.</a:t>
+              <a:t>Kickoff, a 30-day Weedmaps launch, then a monthly cycle of measure and optimize for Green Valley Dispensary.</a:t>
             </a:r>
             <a:endParaRPr lang="en-US" sz="1500" dirty="0"/>
           </a:p>
@@ -7009,8 +7009,8 @@
         </p:nvSpPr>
         <p:spPr>
           <a:xfrm>
-            <a:off x="548640" y="2240280"/>
-            <a:ext cx="502920" cy="502920"/>
+            <a:off x="548640" y="2039112"/>
+            <a:ext cx="457200" cy="457200"/>
           </a:xfrm>
           <a:prstGeom prst="ellipse">
             <a:avLst/>
@@ -7034,8 +7034,8 @@
         </p:nvSpPr>
         <p:spPr>
           <a:xfrm>
-            <a:off x="548640" y="2240280"/>
-            <a:ext cx="502920" cy="502920"/>
+            <a:off x="548640" y="2039112"/>
+            <a:ext cx="457200" cy="457200"/>
           </a:xfrm>
           <a:prstGeom prst="rect">
             <a:avLst/>
@@ -7051,7 +7051,7 @@
               <a:buNone/>
             </a:pPr>
             <a:r>
-              <a:rPr lang="en-US" sz="1600" b="1" dirty="0">
+              <a:rPr lang="en-US" sz="1500" b="1" dirty="0">
                 <a:solidFill>
                   <a:srgbClr val="DD5F13"/>
                 </a:solidFill>
@@ -7061,7 +7061,7 @@
               </a:rPr>
               <a:t>1</a:t>
             </a:r>
-            <a:endParaRPr lang="en-US" sz="1600" dirty="0"/>
+            <a:endParaRPr lang="en-US" sz="1500" dirty="0"/>
           </a:p>
         </p:txBody>
       </p:sp>
@@ -7073,8 +7073,8 @@
         </p:nvSpPr>
         <p:spPr>
           <a:xfrm>
-            <a:off x="1280160" y="2148840"/>
-            <a:ext cx="5943600" cy="365760"/>
+            <a:off x="1234440" y="1965960"/>
+            <a:ext cx="5989320" cy="310896"/>
           </a:xfrm>
           <a:prstGeom prst="rect">
             <a:avLst/>
@@ -7090,7 +7090,7 @@
               <a:buNone/>
             </a:pPr>
             <a:r>
-              <a:rPr lang="en-US" sz="1500" b="1" dirty="0">
+              <a:rPr lang="en-US" sz="1400" b="1" dirty="0">
                 <a:solidFill>
                   <a:srgbClr val="FFFFFF"/>
                 </a:solidFill>
@@ -7098,9 +7098,9 @@
                 <a:ea typeface="Calibri" pitchFamily="34" charset="-122"/>
                 <a:cs typeface="Calibri" pitchFamily="34" charset="-120"/>
               </a:rPr>
-              <a:t>Days 1–30</a:t>
-            </a:r>
-            <a:endParaRPr lang="en-US" sz="1500" dirty="0"/>
+              <a:t>Kickoff</a:t>
+            </a:r>
+            <a:endParaRPr lang="en-US" sz="1400" dirty="0"/>
           </a:p>
         </p:txBody>
       </p:sp>
@@ -7112,8 +7112,8 @@
         </p:nvSpPr>
         <p:spPr>
           <a:xfrm>
-            <a:off x="1280160" y="2514600"/>
-            <a:ext cx="5943600" cy="548640"/>
+            <a:off x="1234440" y="2267712"/>
+            <a:ext cx="5989320" cy="438912"/>
           </a:xfrm>
           <a:prstGeom prst="rect">
             <a:avLst/>
@@ -7129,7 +7129,7 @@
               <a:buNone/>
             </a:pPr>
             <a:r>
-              <a:rPr lang="en-US" sz="1200" dirty="0">
+              <a:rPr lang="en-US" sz="1100" dirty="0">
                 <a:solidFill>
                   <a:srgbClr val="FFE3D0"/>
                 </a:solidFill>
@@ -7137,9 +7137,9 @@
                 <a:ea typeface="Calibri" pitchFamily="34" charset="-122"/>
                 <a:cs typeface="Calibri" pitchFamily="34" charset="-120"/>
               </a:rPr>
-              <a:t>Full audit, strategy, listing + menu clean-up, campaigns live</a:t>
-            </a:r>
-            <a:endParaRPr lang="en-US" sz="1200" dirty="0"/>
+              <a:t>Meet with your team to align on goals, account info, deals, menu and brand assets; connect every platform; set up your analytics dashboard</a:t>
+            </a:r>
+            <a:endParaRPr lang="en-US" sz="1100" dirty="0"/>
           </a:p>
         </p:txBody>
       </p:sp>
@@ -7151,8 +7151,8 @@
         </p:nvSpPr>
         <p:spPr>
           <a:xfrm>
-            <a:off x="548640" y="3200400"/>
-            <a:ext cx="502920" cy="502920"/>
+            <a:off x="548640" y="2788920"/>
+            <a:ext cx="457200" cy="457200"/>
           </a:xfrm>
           <a:prstGeom prst="ellipse">
             <a:avLst/>
@@ -7176,8 +7176,8 @@
         </p:nvSpPr>
         <p:spPr>
           <a:xfrm>
-            <a:off x="548640" y="3200400"/>
-            <a:ext cx="502920" cy="502920"/>
+            <a:off x="548640" y="2788920"/>
+            <a:ext cx="457200" cy="457200"/>
           </a:xfrm>
           <a:prstGeom prst="rect">
             <a:avLst/>
@@ -7193,7 +7193,7 @@
               <a:buNone/>
             </a:pPr>
             <a:r>
-              <a:rPr lang="en-US" sz="1600" b="1" dirty="0">
+              <a:rPr lang="en-US" sz="1500" b="1" dirty="0">
                 <a:solidFill>
                   <a:srgbClr val="DD5F13"/>
                 </a:solidFill>
@@ -7203,7 +7203,7 @@
               </a:rPr>
               <a:t>2</a:t>
             </a:r>
-            <a:endParaRPr lang="en-US" sz="1600" dirty="0"/>
+            <a:endParaRPr lang="en-US" sz="1500" dirty="0"/>
           </a:p>
         </p:txBody>
       </p:sp>
@@ -7215,8 +7215,8 @@
         </p:nvSpPr>
         <p:spPr>
           <a:xfrm>
-            <a:off x="1280160" y="3108960"/>
-            <a:ext cx="5943600" cy="365760"/>
+            <a:off x="1234440" y="2715768"/>
+            <a:ext cx="5989320" cy="310896"/>
           </a:xfrm>
           <a:prstGeom prst="rect">
             <a:avLst/>
@@ -7232,7 +7232,7 @@
               <a:buNone/>
             </a:pPr>
             <a:r>
-              <a:rPr lang="en-US" sz="1500" b="1" dirty="0">
+              <a:rPr lang="en-US" sz="1400" b="1" dirty="0">
                 <a:solidFill>
                   <a:srgbClr val="FFFFFF"/>
                 </a:solidFill>
@@ -7240,9 +7240,9 @@
                 <a:ea typeface="Calibri" pitchFamily="34" charset="-122"/>
                 <a:cs typeface="Calibri" pitchFamily="34" charset="-120"/>
               </a:rPr>
-              <a:t>Days 31–60</a:t>
-            </a:r>
-            <a:endParaRPr lang="en-US" sz="1500" dirty="0"/>
+              <a:t>Days 1–30  ·  Launch</a:t>
+            </a:r>
+            <a:endParaRPr lang="en-US" sz="1400" dirty="0"/>
           </a:p>
         </p:txBody>
       </p:sp>
@@ -7254,8 +7254,8 @@
         </p:nvSpPr>
         <p:spPr>
           <a:xfrm>
-            <a:off x="1280160" y="3474720"/>
-            <a:ext cx="5943600" cy="548640"/>
+            <a:off x="1234440" y="3017520"/>
+            <a:ext cx="5989320" cy="438912"/>
           </a:xfrm>
           <a:prstGeom prst="rect">
             <a:avLst/>
@@ -7271,7 +7271,7 @@
               <a:buNone/>
             </a:pPr>
             <a:r>
-              <a:rPr lang="en-US" sz="1200" dirty="0">
+              <a:rPr lang="en-US" sz="1100" dirty="0">
                 <a:solidFill>
                   <a:srgbClr val="FFE3D0"/>
                 </a:solidFill>
@@ -7279,9 +7279,9 @@
                 <a:ea typeface="Calibri" pitchFamily="34" charset="-122"/>
                 <a:cs typeface="Calibri" pitchFamily="34" charset="-120"/>
               </a:rPr>
-              <a:t>Bid &amp; deal optimization, review program, dashboard attribution</a:t>
-            </a:r>
-            <a:endParaRPr lang="en-US" sz="1200" dirty="0"/>
+              <a:t>Full audit, strategy, listing and menu clean-up, products verified and strain tagged, deals and campaigns live</a:t>
+            </a:r>
+            <a:endParaRPr lang="en-US" sz="1100" dirty="0"/>
           </a:p>
         </p:txBody>
       </p:sp>
@@ -7293,8 +7293,8 @@
         </p:nvSpPr>
         <p:spPr>
           <a:xfrm>
-            <a:off x="548640" y="4160520"/>
-            <a:ext cx="502920" cy="502920"/>
+            <a:off x="548640" y="3538728"/>
+            <a:ext cx="457200" cy="457200"/>
           </a:xfrm>
           <a:prstGeom prst="ellipse">
             <a:avLst/>
@@ -7318,8 +7318,8 @@
         </p:nvSpPr>
         <p:spPr>
           <a:xfrm>
-            <a:off x="548640" y="4160520"/>
-            <a:ext cx="502920" cy="502920"/>
+            <a:off x="548640" y="3538728"/>
+            <a:ext cx="457200" cy="457200"/>
           </a:xfrm>
           <a:prstGeom prst="rect">
             <a:avLst/>
@@ -7335,7 +7335,7 @@
               <a:buNone/>
             </a:pPr>
             <a:r>
-              <a:rPr lang="en-US" sz="1600" b="1" dirty="0">
+              <a:rPr lang="en-US" sz="1500" b="1" dirty="0">
                 <a:solidFill>
                   <a:srgbClr val="DD5F13"/>
                 </a:solidFill>
@@ -7345,7 +7345,7 @@
               </a:rPr>
               <a:t>3</a:t>
             </a:r>
-            <a:endParaRPr lang="en-US" sz="1600" dirty="0"/>
+            <a:endParaRPr lang="en-US" sz="1500" dirty="0"/>
           </a:p>
         </p:txBody>
       </p:sp>
@@ -7357,8 +7357,8 @@
         </p:nvSpPr>
         <p:spPr>
           <a:xfrm>
-            <a:off x="1280160" y="4069080"/>
-            <a:ext cx="5943600" cy="365760"/>
+            <a:off x="1234440" y="3465576"/>
+            <a:ext cx="5989320" cy="310896"/>
           </a:xfrm>
           <a:prstGeom prst="rect">
             <a:avLst/>
@@ -7374,30 +7374,172 @@
               <a:buNone/>
             </a:pPr>
             <a:r>
+              <a:rPr lang="en-US" sz="1400" b="1" dirty="0">
+                <a:solidFill>
+                  <a:srgbClr val="FFFFFF"/>
+                </a:solidFill>
+                <a:latin typeface="Calibri" pitchFamily="34" charset="0"/>
+                <a:ea typeface="Calibri" pitchFamily="34" charset="-122"/>
+                <a:cs typeface="Calibri" pitchFamily="34" charset="-120"/>
+              </a:rPr>
+              <a:t>Days 31–60  ·  Measure &amp; optimize</a:t>
+            </a:r>
+            <a:endParaRPr lang="en-US" sz="1400" dirty="0"/>
+          </a:p>
+        </p:txBody>
+      </p:sp>
+      <p:sp>
+        <p:nvSpPr>
+          <p:cNvPr id="20" name="Text 17"/>
+          <p:cNvSpPr txBox="1"/>
+          <p:nvPr/>
+        </p:nvSpPr>
+        <p:spPr>
+          <a:xfrm>
+            <a:off x="1234440" y="3767328"/>
+            <a:ext cx="5989320" cy="438912"/>
+          </a:xfrm>
+          <a:prstGeom prst="rect">
+            <a:avLst/>
+          </a:prstGeom>
+          <a:noFill/>
+          <a:ln/>
+        </p:spPr>
+        <p:txBody>
+          <a:bodyPr wrap="square" lIns="0" tIns="0" rIns="0" bIns="0" rtlCol="0" anchor="t"/>
+          <a:lstStyle/>
+          <a:p>
+            <a:pPr indent="0" marL="0">
+              <a:buNone/>
+            </a:pPr>
+            <a:r>
+              <a:rPr lang="en-US" sz="1100" dirty="0">
+                <a:solidFill>
+                  <a:srgbClr val="FFE3D0"/>
+                </a:solidFill>
+                <a:latin typeface="Calibri" pitchFamily="34" charset="0"/>
+                <a:ea typeface="Calibri" pitchFamily="34" charset="-122"/>
+                <a:cs typeface="Calibri" pitchFamily="34" charset="-120"/>
+              </a:rPr>
+              <a:t>Measure what the launch did to orders and return, then re-tune positions, deals, products and graphics to improve it</a:t>
+            </a:r>
+            <a:endParaRPr lang="en-US" sz="1100" dirty="0"/>
+          </a:p>
+        </p:txBody>
+      </p:sp>
+      <p:sp>
+        <p:nvSpPr>
+          <p:cNvPr id="21" name="Shape 18"/>
+          <p:cNvSpPr/>
+          <p:nvPr/>
+        </p:nvSpPr>
+        <p:spPr>
+          <a:xfrm>
+            <a:off x="548640" y="4288536"/>
+            <a:ext cx="457200" cy="457200"/>
+          </a:xfrm>
+          <a:prstGeom prst="ellipse">
+            <a:avLst/>
+          </a:prstGeom>
+          <a:solidFill>
+            <a:srgbClr val="FFFFFF"/>
+          </a:solidFill>
+          <a:ln w="12700">
+            <a:solidFill>
+              <a:srgbClr val="FFFFFF"/>
+            </a:solidFill>
+            <a:prstDash val="solid"/>
+          </a:ln>
+        </p:spPr>
+      </p:sp>
+      <p:sp>
+        <p:nvSpPr>
+          <p:cNvPr id="22" name="Text 19"/>
+          <p:cNvSpPr txBox="1"/>
+          <p:nvPr/>
+        </p:nvSpPr>
+        <p:spPr>
+          <a:xfrm>
+            <a:off x="548640" y="4288536"/>
+            <a:ext cx="457200" cy="457200"/>
+          </a:xfrm>
+          <a:prstGeom prst="rect">
+            <a:avLst/>
+          </a:prstGeom>
+          <a:noFill/>
+          <a:ln/>
+        </p:spPr>
+        <p:txBody>
+          <a:bodyPr wrap="square" lIns="0" tIns="0" rIns="0" bIns="0" rtlCol="0" anchor="ctr"/>
+          <a:lstStyle/>
+          <a:p>
+            <a:pPr algn="ctr" indent="0" marL="0">
+              <a:buNone/>
+            </a:pPr>
+            <a:r>
               <a:rPr lang="en-US" sz="1500" b="1" dirty="0">
                 <a:solidFill>
+                  <a:srgbClr val="DD5F13"/>
+                </a:solidFill>
+                <a:latin typeface="Arial" pitchFamily="34" charset="0"/>
+                <a:ea typeface="Arial" pitchFamily="34" charset="-122"/>
+                <a:cs typeface="Arial" pitchFamily="34" charset="-120"/>
+              </a:rPr>
+              <a:t>4</a:t>
+            </a:r>
+            <a:endParaRPr lang="en-US" sz="1500" dirty="0"/>
+          </a:p>
+        </p:txBody>
+      </p:sp>
+      <p:sp>
+        <p:nvSpPr>
+          <p:cNvPr id="23" name="Text 20"/>
+          <p:cNvSpPr txBox="1"/>
+          <p:nvPr/>
+        </p:nvSpPr>
+        <p:spPr>
+          <a:xfrm>
+            <a:off x="1234440" y="4215384"/>
+            <a:ext cx="5989320" cy="310896"/>
+          </a:xfrm>
+          <a:prstGeom prst="rect">
+            <a:avLst/>
+          </a:prstGeom>
+          <a:noFill/>
+          <a:ln/>
+        </p:spPr>
+        <p:txBody>
+          <a:bodyPr wrap="square" lIns="0" tIns="0" rIns="0" bIns="0" rtlCol="0" anchor="t"/>
+          <a:lstStyle/>
+          <a:p>
+            <a:pPr indent="0" marL="0">
+              <a:buNone/>
+            </a:pPr>
+            <a:r>
+              <a:rPr lang="en-US" sz="1400" b="1" dirty="0">
+                <a:solidFill>
                   <a:srgbClr val="FFFFFF"/>
                 </a:solidFill>
                 <a:latin typeface="Calibri" pitchFamily="34" charset="0"/>
                 <a:ea typeface="Calibri" pitchFamily="34" charset="-122"/>
                 <a:cs typeface="Calibri" pitchFamily="34" charset="-120"/>
               </a:rPr>
-              <a:t>Days 61–90</a:t>
-            </a:r>
-            <a:endParaRPr lang="en-US" sz="1500" dirty="0"/>
-          </a:p>
-        </p:txBody>
-      </p:sp>
-      <p:sp>
-        <p:nvSpPr>
-          <p:cNvPr id="20" name="Text 17"/>
-          <p:cNvSpPr txBox="1"/>
-          <p:nvPr/>
-        </p:nvSpPr>
-        <p:spPr>
-          <a:xfrm>
-            <a:off x="1280160" y="4434840"/>
-            <a:ext cx="5943600" cy="548640"/>
+              <a:t>Days 61–90 and beyond  ·  Repeat &amp; grow</a:t>
+            </a:r>
+            <a:endParaRPr lang="en-US" sz="1400" dirty="0"/>
+          </a:p>
+        </p:txBody>
+      </p:sp>
+      <p:sp>
+        <p:nvSpPr>
+          <p:cNvPr id="24" name="Text 21"/>
+          <p:cNvSpPr txBox="1"/>
+          <p:nvPr/>
+        </p:nvSpPr>
+        <p:spPr>
+          <a:xfrm>
+            <a:off x="1234440" y="4517136"/>
+            <a:ext cx="5989320" cy="438912"/>
           </a:xfrm>
           <a:prstGeom prst="rect">
             <a:avLst/>
@@ -7413,7 +7555,7 @@
               <a:buNone/>
             </a:pPr>
             <a:r>
-              <a:rPr lang="en-US" sz="1200" dirty="0">
+              <a:rPr lang="en-US" sz="1100" dirty="0">
                 <a:solidFill>
                   <a:srgbClr val="FFE3D0"/>
                 </a:solidFill>
@@ -7421,21 +7563,21 @@
                 <a:ea typeface="Calibri" pitchFamily="34" charset="-122"/>
                 <a:cs typeface="Calibri" pitchFamily="34" charset="-120"/>
               </a:rPr>
-              <a:t>Scale winners, Maps 3-pack push, quarterly plan</a:t>
-            </a:r>
-            <a:endParaRPr lang="en-US" sz="1200" dirty="0"/>
-          </a:p>
-        </p:txBody>
-      </p:sp>
-      <p:sp>
-        <p:nvSpPr>
-          <p:cNvPr id="21" name="Text 18"/>
-          <p:cNvSpPr txBox="1"/>
-          <p:nvPr/>
-        </p:nvSpPr>
-        <p:spPr>
-          <a:xfrm>
-            <a:off x="548640" y="5120640"/>
+              <a:t>Rinse and repeat every month: measure, adjust, improve — continually growing and maximizing your return; add-on platforms switched on when you're ready</a:t>
+            </a:r>
+            <a:endParaRPr lang="en-US" sz="1100" dirty="0"/>
+          </a:p>
+        </p:txBody>
+      </p:sp>
+      <p:sp>
+        <p:nvSpPr>
+          <p:cNvPr id="25" name="Text 22"/>
+          <p:cNvSpPr txBox="1"/>
+          <p:nvPr/>
+        </p:nvSpPr>
+        <p:spPr>
+          <a:xfrm>
+            <a:off x="548640" y="5212080"/>
             <a:ext cx="6675120" cy="365760"/>
           </a:xfrm>
           <a:prstGeom prst="rect">
@@ -7468,7 +7610,7 @@
       </p:sp>
       <p:pic>
         <p:nvPicPr>
-          <p:cNvPr id="22" name="Image 1" descr="preencoded.png">    </p:cNvPr>
+          <p:cNvPr id="26" name="Image 1" descr="preencoded.png">    </p:cNvPr>
           <p:cNvPicPr>
             <a:picLocks noChangeAspect="1"/>
           </p:cNvPicPr>
@@ -7482,7 +7624,7 @@
         </p:blipFill>
         <p:spPr>
           <a:xfrm>
-            <a:off x="548640" y="5623560"/>
+            <a:off x="548640" y="5687568"/>
             <a:ext cx="914400" cy="611278"/>
           </a:xfrm>
           <a:prstGeom prst="rect">
@@ -7492,7 +7634,7 @@
       </p:pic>
       <p:sp>
         <p:nvSpPr>
-          <p:cNvPr id="23" name="Shape 19"/>
+          <p:cNvPr id="27" name="Shape 23"/>
           <p:cNvSpPr/>
           <p:nvPr/>
         </p:nvSpPr>
@@ -7519,7 +7661,7 @@
       </p:sp>
       <p:sp>
         <p:nvSpPr>
-          <p:cNvPr id="24" name="Text 20"/>
+          <p:cNvPr id="28" name="Text 24"/>
           <p:cNvSpPr txBox="1"/>
           <p:nvPr/>
         </p:nvSpPr>
@@ -7558,7 +7700,7 @@
       </p:sp>
       <p:sp>
         <p:nvSpPr>
-          <p:cNvPr id="25" name="Text 21"/>
+          <p:cNvPr id="29" name="Text 25"/>
           <p:cNvSpPr txBox="1"/>
           <p:nvPr/>
         </p:nvSpPr>
@@ -7597,7 +7739,7 @@
       </p:sp>
       <p:sp>
         <p:nvSpPr>
-          <p:cNvPr id="26" name="Text 22"/>
+          <p:cNvPr id="30" name="Text 26"/>
           <p:cNvSpPr txBox="1"/>
           <p:nvPr/>
         </p:nvSpPr>
@@ -7636,7 +7778,7 @@
       </p:sp>
       <p:sp>
         <p:nvSpPr>
-          <p:cNvPr id="27" name="Text 23"/>
+          <p:cNvPr id="31" name="Text 27"/>
           <p:cNvSpPr txBox="1"/>
           <p:nvPr/>
         </p:nvSpPr>
@@ -7675,7 +7817,7 @@
       </p:sp>
       <p:sp>
         <p:nvSpPr>
-          <p:cNvPr id="28" name="Text 24"/>
+          <p:cNvPr id="32" name="Text 28"/>
           <p:cNvSpPr txBox="1"/>
           <p:nvPr/>
         </p:nvSpPr>
@@ -7714,7 +7856,7 @@
       </p:sp>
       <p:sp>
         <p:nvSpPr>
-          <p:cNvPr id="29" name="Shape 25"/>
+          <p:cNvPr id="33" name="Shape 29"/>
           <p:cNvSpPr/>
           <p:nvPr/>
         </p:nvSpPr>
@@ -7737,7 +7879,7 @@
       </p:sp>
       <p:sp>
         <p:nvSpPr>
-          <p:cNvPr id="30" name="Text 26"/>
+          <p:cNvPr id="34" name="Text 30"/>
           <p:cNvSpPr txBox="1"/>
           <p:nvPr/>
         </p:nvSpPr>
@@ -7776,7 +7918,7 @@
       </p:sp>
       <p:sp>
         <p:nvSpPr>
-          <p:cNvPr id="31" name="Text 27"/>
+          <p:cNvPr id="35" name="Text 31"/>
           <p:cNvSpPr txBox="1"/>
           <p:nvPr/>
         </p:nvSpPr>
@@ -7815,7 +7957,7 @@
       </p:sp>
       <p:sp>
         <p:nvSpPr>
-          <p:cNvPr id="32" name="Text 28"/>
+          <p:cNvPr id="36" name="Text 32"/>
           <p:cNvSpPr txBox="1"/>
           <p:nvPr/>
         </p:nvSpPr>
@@ -7854,7 +7996,7 @@
       </p:sp>
       <p:sp>
         <p:nvSpPr>
-          <p:cNvPr id="33" name="Text 29"/>
+          <p:cNvPr id="37" name="Text 33"/>
           <p:cNvSpPr txBox="1"/>
           <p:nvPr/>
         </p:nvSpPr>
@@ -7893,7 +8035,7 @@
       </p:sp>
       <p:sp>
         <p:nvSpPr>
-          <p:cNvPr id="34" name="Text 30"/>
+          <p:cNvPr id="38" name="Text 34"/>
           <p:cNvSpPr txBox="1"/>
           <p:nvPr/>
         </p:nvSpPr>
@@ -7932,7 +8074,7 @@
       </p:sp>
       <p:sp>
         <p:nvSpPr>
-          <p:cNvPr id="35" name="Text 31"/>
+          <p:cNvPr id="39" name="Text 35"/>
           <p:cNvSpPr txBox="1"/>
           <p:nvPr/>
         </p:nvSpPr>
@@ -7971,7 +8113,7 @@
       </p:sp>
       <p:sp>
         <p:nvSpPr>
-          <p:cNvPr id="36" name="Text 32"/>
+          <p:cNvPr id="40" name="Text 36"/>
           <p:cNvSpPr txBox="1"/>
           <p:nvPr/>
         </p:nvSpPr>
@@ -8010,7 +8152,7 @@
       </p:sp>
       <p:sp>
         <p:nvSpPr>
-          <p:cNvPr id="37" name="Text 33"/>
+          <p:cNvPr id="41" name="Text 37"/>
           <p:cNvSpPr txBox="1"/>
           <p:nvPr/>
         </p:nvSpPr>
@@ -8049,7 +8191,7 @@
       </p:sp>
       <p:sp>
         <p:nvSpPr>
-          <p:cNvPr id="38" name="Text 34"/>
+          <p:cNvPr id="42" name="Text 38"/>
           <p:cNvSpPr txBox="1"/>
           <p:nvPr/>
         </p:nvSpPr>
@@ -8088,7 +8230,7 @@
       </p:sp>
       <p:sp>
         <p:nvSpPr>
-          <p:cNvPr id="39" name="Text 35"/>
+          <p:cNvPr id="43" name="Text 39"/>
           <p:cNvSpPr txBox="1"/>
           <p:nvPr/>
         </p:nvSpPr>

</xml_diff>

<commit_message>
Cover says Single Platform or Multi-Platform Management proposal
Auto-detected from which platforms are included; prospect.package can
force "single" or "multi". The one-liner already names the platforms.

Co-Authored-By: Claude Fable 5.1 <noreply@anthropic.com>
Claude-Session: https://claude.ai/code/session_01RhvxWoxVegp3rGjZ4khBZo
</commit_message>
<xml_diff>
--- a/decks/Sparks-x-example-green-valley.pptx
+++ b/decks/Sparks-x-example-green-valley.pptx
@@ -515,7 +515,7 @@
           <a:p>
             <a:r>
               <a:rPr lang="en-US" dirty="0"/>
-              <a:t>Open with the one-liner. Green Valley Dispensary is a dispensary in Sacramento, CA. This deck is Weedmaps-first: the full pitch is Weedmaps management; the other platforms are add-ons at $495/mo each.</a:t>
+              <a:t>Open with the one-liner. Green Valley Dispensary is a dispensary in Sacramento, CA. This is a multi-platform proposal (Weedmaps, Leafly, Yelp, and Google), Weedmaps-first: the full pitch is Weedmaps management; the other platforms are add-ons at $495/mo each.</a:t>
             </a:r>
             <a:endParaRPr lang="en-US" dirty="0"/>
           </a:p>
@@ -2302,7 +2302,7 @@
                 <a:ea typeface="Calibri" pitchFamily="34" charset="-122"/>
                 <a:cs typeface="Calibri" pitchFamily="34" charset="-120"/>
               </a:rPr>
-              <a:t>Weedmaps Management proposal</a:t>
+              <a:t>Multi-Platform Management proposal</a:t>
             </a:r>
             <a:endParaRPr lang="en-US" sz="1800" dirty="0"/>
           </a:p>

</xml_diff>

<commit_message>
Next steps: generic three-step process (kickoff, days 1–30, days 31+)
Steps 3 and 4 merged into "Days 31+ · Measure, optimize, repeat". The
plan is now the same rinse-and-repeat process on every deck with no
listing-specific tasks; prospect files no longer carry their own plan.

Co-Authored-By: Claude Fable 5.1 <noreply@anthropic.com>
Claude-Session: https://claude.ai/code/session_01RhvxWoxVegp3rGjZ4khBZo
</commit_message>
<xml_diff>
--- a/decks/Sparks-x-example-green-valley.pptx
+++ b/decks/Sparks-x-example-green-valley.pptx
@@ -955,7 +955,7 @@
           <a:p>
             <a:r>
               <a:rPr lang="en-US" dirty="0"/>
-              <a:t>Walk the process: kickoff (align on goals, info, deals, menu; connect every platform; set up the analytics dashboard), a 30-day launch, then every month we measure what the changes did to the return and re-tune positions, deals, products and graphics — rinse and repeat to keep growing it. Close: restate the guarantee, propose a kickoff date, and ask for Weedmaps admin access. Add-ons are $495/mo each. Can be switched on at any time.</a:t>
+              <a:t>Walk the process: kickoff (align on goals, info, deals, menu; connect every platform; set up the analytics dashboard), a 30-day launch, then from day 31 every month we measure what the changes did to the return and re-tune positions, deals, products and graphics — rinse and repeat to keep growing it. Close: restate the guarantee, propose a kickoff date, and ask for Weedmaps admin access. Add-ons are $495/mo each. Can be switched on at any time.</a:t>
             </a:r>
             <a:endParaRPr lang="en-US" dirty="0"/>
           </a:p>
@@ -6971,7 +6971,7 @@
         <p:spPr>
           <a:xfrm>
             <a:off x="548640" y="1225550"/>
-            <a:ext cx="11094415" cy="347472"/>
+            <a:ext cx="11094415" cy="603504"/>
           </a:xfrm>
           <a:prstGeom prst="rect">
             <a:avLst/>
@@ -6995,7 +6995,7 @@
                 <a:ea typeface="Calibri" pitchFamily="34" charset="-122"/>
                 <a:cs typeface="Calibri" pitchFamily="34" charset="-120"/>
               </a:rPr>
-              <a:t>Kickoff, a 30-day Weedmaps launch, then a monthly cycle of measure and optimize for Green Valley Dispensary.</a:t>
+              <a:t>Kickoff, a 30-day Weedmaps launch, then a monthly cycle of measure and optimize to keep growing Green Valley Dispensary's return.</a:t>
             </a:r>
             <a:endParaRPr lang="en-US" sz="1500" dirty="0"/>
           </a:p>
@@ -7009,7 +7009,7 @@
         </p:nvSpPr>
         <p:spPr>
           <a:xfrm>
-            <a:off x="548640" y="2039112"/>
+            <a:off x="548640" y="2221992"/>
             <a:ext cx="457200" cy="457200"/>
           </a:xfrm>
           <a:prstGeom prst="ellipse">
@@ -7034,7 +7034,7 @@
         </p:nvSpPr>
         <p:spPr>
           <a:xfrm>
-            <a:off x="548640" y="2039112"/>
+            <a:off x="548640" y="2221992"/>
             <a:ext cx="457200" cy="457200"/>
           </a:xfrm>
           <a:prstGeom prst="rect">
@@ -7073,7 +7073,7 @@
         </p:nvSpPr>
         <p:spPr>
           <a:xfrm>
-            <a:off x="1234440" y="1965960"/>
+            <a:off x="1234440" y="2148840"/>
             <a:ext cx="5989320" cy="310896"/>
           </a:xfrm>
           <a:prstGeom prst="rect">
@@ -7090,7 +7090,7 @@
               <a:buNone/>
             </a:pPr>
             <a:r>
-              <a:rPr lang="en-US" sz="1400" b="1" dirty="0">
+              <a:rPr lang="en-US" sz="1500" b="1" dirty="0">
                 <a:solidFill>
                   <a:srgbClr val="FFFFFF"/>
                 </a:solidFill>
@@ -7100,7 +7100,7 @@
               </a:rPr>
               <a:t>Kickoff</a:t>
             </a:r>
-            <a:endParaRPr lang="en-US" sz="1400" dirty="0"/>
+            <a:endParaRPr lang="en-US" sz="1500" dirty="0"/>
           </a:p>
         </p:txBody>
       </p:sp>
@@ -7112,8 +7112,8 @@
         </p:nvSpPr>
         <p:spPr>
           <a:xfrm>
-            <a:off x="1234440" y="2267712"/>
-            <a:ext cx="5989320" cy="438912"/>
+            <a:off x="1234440" y="2450592"/>
+            <a:ext cx="5989320" cy="548640"/>
           </a:xfrm>
           <a:prstGeom prst="rect">
             <a:avLst/>
@@ -7129,7 +7129,7 @@
               <a:buNone/>
             </a:pPr>
             <a:r>
-              <a:rPr lang="en-US" sz="1100" dirty="0">
+              <a:rPr lang="en-US" sz="1200" dirty="0">
                 <a:solidFill>
                   <a:srgbClr val="FFE3D0"/>
                 </a:solidFill>
@@ -7139,7 +7139,7 @@
               </a:rPr>
               <a:t>Meet with your team to align on goals, account info, deals, menu and brand assets; connect every platform; set up your analytics dashboard</a:t>
             </a:r>
-            <a:endParaRPr lang="en-US" sz="1100" dirty="0"/>
+            <a:endParaRPr lang="en-US" sz="1200" dirty="0"/>
           </a:p>
         </p:txBody>
       </p:sp>
@@ -7151,7 +7151,7 @@
         </p:nvSpPr>
         <p:spPr>
           <a:xfrm>
-            <a:off x="548640" y="2788920"/>
+            <a:off x="548640" y="3182112"/>
             <a:ext cx="457200" cy="457200"/>
           </a:xfrm>
           <a:prstGeom prst="ellipse">
@@ -7176,7 +7176,7 @@
         </p:nvSpPr>
         <p:spPr>
           <a:xfrm>
-            <a:off x="548640" y="2788920"/>
+            <a:off x="548640" y="3182112"/>
             <a:ext cx="457200" cy="457200"/>
           </a:xfrm>
           <a:prstGeom prst="rect">
@@ -7215,7 +7215,7 @@
         </p:nvSpPr>
         <p:spPr>
           <a:xfrm>
-            <a:off x="1234440" y="2715768"/>
+            <a:off x="1234440" y="3108960"/>
             <a:ext cx="5989320" cy="310896"/>
           </a:xfrm>
           <a:prstGeom prst="rect">
@@ -7232,7 +7232,7 @@
               <a:buNone/>
             </a:pPr>
             <a:r>
-              <a:rPr lang="en-US" sz="1400" b="1" dirty="0">
+              <a:rPr lang="en-US" sz="1500" b="1" dirty="0">
                 <a:solidFill>
                   <a:srgbClr val="FFFFFF"/>
                 </a:solidFill>
@@ -7242,7 +7242,7 @@
               </a:rPr>
               <a:t>Days 1–30  ·  Launch</a:t>
             </a:r>
-            <a:endParaRPr lang="en-US" sz="1400" dirty="0"/>
+            <a:endParaRPr lang="en-US" sz="1500" dirty="0"/>
           </a:p>
         </p:txBody>
       </p:sp>
@@ -7254,8 +7254,8 @@
         </p:nvSpPr>
         <p:spPr>
           <a:xfrm>
-            <a:off x="1234440" y="3017520"/>
-            <a:ext cx="5989320" cy="438912"/>
+            <a:off x="1234440" y="3410712"/>
+            <a:ext cx="5989320" cy="548640"/>
           </a:xfrm>
           <a:prstGeom prst="rect">
             <a:avLst/>
@@ -7271,7 +7271,7 @@
               <a:buNone/>
             </a:pPr>
             <a:r>
-              <a:rPr lang="en-US" sz="1100" dirty="0">
+              <a:rPr lang="en-US" sz="1200" dirty="0">
                 <a:solidFill>
                   <a:srgbClr val="FFE3D0"/>
                 </a:solidFill>
@@ -7279,9 +7279,9 @@
                 <a:ea typeface="Calibri" pitchFamily="34" charset="-122"/>
                 <a:cs typeface="Calibri" pitchFamily="34" charset="-120"/>
               </a:rPr>
-              <a:t>Full audit, strategy, listing and menu clean-up, products verified and strain tagged, deals and campaigns live</a:t>
-            </a:r>
-            <a:endParaRPr lang="en-US" sz="1100" dirty="0"/>
+              <a:t>Full audit and strategy, listing and menu clean-up, products verified and strain tagged, deals, graphics and campaigns live</a:t>
+            </a:r>
+            <a:endParaRPr lang="en-US" sz="1200" dirty="0"/>
           </a:p>
         </p:txBody>
       </p:sp>
@@ -7293,7 +7293,7 @@
         </p:nvSpPr>
         <p:spPr>
           <a:xfrm>
-            <a:off x="548640" y="3538728"/>
+            <a:off x="548640" y="4142232"/>
             <a:ext cx="457200" cy="457200"/>
           </a:xfrm>
           <a:prstGeom prst="ellipse">
@@ -7318,7 +7318,7 @@
         </p:nvSpPr>
         <p:spPr>
           <a:xfrm>
-            <a:off x="548640" y="3538728"/>
+            <a:off x="548640" y="4142232"/>
             <a:ext cx="457200" cy="457200"/>
           </a:xfrm>
           <a:prstGeom prst="rect">
@@ -7357,7 +7357,7 @@
         </p:nvSpPr>
         <p:spPr>
           <a:xfrm>
-            <a:off x="1234440" y="3465576"/>
+            <a:off x="1234440" y="4069080"/>
             <a:ext cx="5989320" cy="310896"/>
           </a:xfrm>
           <a:prstGeom prst="rect">
@@ -7374,7 +7374,7 @@
               <a:buNone/>
             </a:pPr>
             <a:r>
-              <a:rPr lang="en-US" sz="1400" b="1" dirty="0">
+              <a:rPr lang="en-US" sz="1500" b="1" dirty="0">
                 <a:solidFill>
                   <a:srgbClr val="FFFFFF"/>
                 </a:solidFill>
@@ -7382,9 +7382,9 @@
                 <a:ea typeface="Calibri" pitchFamily="34" charset="-122"/>
                 <a:cs typeface="Calibri" pitchFamily="34" charset="-120"/>
               </a:rPr>
-              <a:t>Days 31–60  ·  Measure &amp; optimize</a:t>
-            </a:r>
-            <a:endParaRPr lang="en-US" sz="1400" dirty="0"/>
+              <a:t>Days 31+  ·  Measure, optimize, repeat</a:t>
+            </a:r>
+            <a:endParaRPr lang="en-US" sz="1500" dirty="0"/>
           </a:p>
         </p:txBody>
       </p:sp>
@@ -7396,8 +7396,8 @@
         </p:nvSpPr>
         <p:spPr>
           <a:xfrm>
-            <a:off x="1234440" y="3767328"/>
-            <a:ext cx="5989320" cy="438912"/>
+            <a:off x="1234440" y="4370832"/>
+            <a:ext cx="5989320" cy="548640"/>
           </a:xfrm>
           <a:prstGeom prst="rect">
             <a:avLst/>
@@ -7413,7 +7413,7 @@
               <a:buNone/>
             </a:pPr>
             <a:r>
-              <a:rPr lang="en-US" sz="1100" dirty="0">
+              <a:rPr lang="en-US" sz="1200" dirty="0">
                 <a:solidFill>
                   <a:srgbClr val="FFE3D0"/>
                 </a:solidFill>
@@ -7421,163 +7421,21 @@
                 <a:ea typeface="Calibri" pitchFamily="34" charset="-122"/>
                 <a:cs typeface="Calibri" pitchFamily="34" charset="-120"/>
               </a:rPr>
-              <a:t>Measure what the launch did to orders and return, then re-tune positions, deals, products and graphics to improve it</a:t>
-            </a:r>
-            <a:endParaRPr lang="en-US" sz="1100" dirty="0"/>
-          </a:p>
-        </p:txBody>
-      </p:sp>
-      <p:sp>
-        <p:nvSpPr>
-          <p:cNvPr id="21" name="Shape 18"/>
-          <p:cNvSpPr/>
-          <p:nvPr/>
-        </p:nvSpPr>
-        <p:spPr>
-          <a:xfrm>
-            <a:off x="548640" y="4288536"/>
-            <a:ext cx="457200" cy="457200"/>
-          </a:xfrm>
-          <a:prstGeom prst="ellipse">
-            <a:avLst/>
-          </a:prstGeom>
-          <a:solidFill>
-            <a:srgbClr val="FFFFFF"/>
-          </a:solidFill>
-          <a:ln w="12700">
-            <a:solidFill>
-              <a:srgbClr val="FFFFFF"/>
-            </a:solidFill>
-            <a:prstDash val="solid"/>
-          </a:ln>
-        </p:spPr>
-      </p:sp>
-      <p:sp>
-        <p:nvSpPr>
-          <p:cNvPr id="22" name="Text 19"/>
-          <p:cNvSpPr txBox="1"/>
-          <p:nvPr/>
-        </p:nvSpPr>
-        <p:spPr>
-          <a:xfrm>
-            <a:off x="548640" y="4288536"/>
-            <a:ext cx="457200" cy="457200"/>
-          </a:xfrm>
-          <a:prstGeom prst="rect">
-            <a:avLst/>
-          </a:prstGeom>
-          <a:noFill/>
-          <a:ln/>
-        </p:spPr>
-        <p:txBody>
-          <a:bodyPr wrap="square" lIns="0" tIns="0" rIns="0" bIns="0" rtlCol="0" anchor="ctr"/>
-          <a:lstStyle/>
-          <a:p>
-            <a:pPr algn="ctr" indent="0" marL="0">
-              <a:buNone/>
-            </a:pPr>
-            <a:r>
-              <a:rPr lang="en-US" sz="1500" b="1" dirty="0">
-                <a:solidFill>
-                  <a:srgbClr val="DD5F13"/>
-                </a:solidFill>
-                <a:latin typeface="Arial" pitchFamily="34" charset="0"/>
-                <a:ea typeface="Arial" pitchFamily="34" charset="-122"/>
-                <a:cs typeface="Arial" pitchFamily="34" charset="-120"/>
-              </a:rPr>
-              <a:t>4</a:t>
-            </a:r>
-            <a:endParaRPr lang="en-US" sz="1500" dirty="0"/>
-          </a:p>
-        </p:txBody>
-      </p:sp>
-      <p:sp>
-        <p:nvSpPr>
-          <p:cNvPr id="23" name="Text 20"/>
-          <p:cNvSpPr txBox="1"/>
-          <p:nvPr/>
-        </p:nvSpPr>
-        <p:spPr>
-          <a:xfrm>
-            <a:off x="1234440" y="4215384"/>
-            <a:ext cx="5989320" cy="310896"/>
-          </a:xfrm>
-          <a:prstGeom prst="rect">
-            <a:avLst/>
-          </a:prstGeom>
-          <a:noFill/>
-          <a:ln/>
-        </p:spPr>
-        <p:txBody>
-          <a:bodyPr wrap="square" lIns="0" tIns="0" rIns="0" bIns="0" rtlCol="0" anchor="t"/>
-          <a:lstStyle/>
-          <a:p>
-            <a:pPr indent="0" marL="0">
-              <a:buNone/>
-            </a:pPr>
-            <a:r>
-              <a:rPr lang="en-US" sz="1400" b="1" dirty="0">
-                <a:solidFill>
-                  <a:srgbClr val="FFFFFF"/>
-                </a:solidFill>
-                <a:latin typeface="Calibri" pitchFamily="34" charset="0"/>
-                <a:ea typeface="Calibri" pitchFamily="34" charset="-122"/>
-                <a:cs typeface="Calibri" pitchFamily="34" charset="-120"/>
-              </a:rPr>
-              <a:t>Days 61–90 and beyond  ·  Repeat &amp; grow</a:t>
-            </a:r>
-            <a:endParaRPr lang="en-US" sz="1400" dirty="0"/>
-          </a:p>
-        </p:txBody>
-      </p:sp>
-      <p:sp>
-        <p:nvSpPr>
-          <p:cNvPr id="24" name="Text 21"/>
-          <p:cNvSpPr txBox="1"/>
-          <p:nvPr/>
-        </p:nvSpPr>
-        <p:spPr>
-          <a:xfrm>
-            <a:off x="1234440" y="4517136"/>
-            <a:ext cx="5989320" cy="438912"/>
-          </a:xfrm>
-          <a:prstGeom prst="rect">
-            <a:avLst/>
-          </a:prstGeom>
-          <a:noFill/>
-          <a:ln/>
-        </p:spPr>
-        <p:txBody>
-          <a:bodyPr wrap="square" lIns="0" tIns="0" rIns="0" bIns="0" rtlCol="0" anchor="t"/>
-          <a:lstStyle/>
-          <a:p>
-            <a:pPr indent="0" marL="0">
-              <a:buNone/>
-            </a:pPr>
-            <a:r>
-              <a:rPr lang="en-US" sz="1100" dirty="0">
-                <a:solidFill>
-                  <a:srgbClr val="FFE3D0"/>
-                </a:solidFill>
-                <a:latin typeface="Calibri" pitchFamily="34" charset="0"/>
-                <a:ea typeface="Calibri" pitchFamily="34" charset="-122"/>
-                <a:cs typeface="Calibri" pitchFamily="34" charset="-120"/>
-              </a:rPr>
-              <a:t>Rinse and repeat every month: measure, adjust, improve — continually growing and maximizing your return; add-on platforms switched on when you're ready</a:t>
-            </a:r>
-            <a:endParaRPr lang="en-US" sz="1100" dirty="0"/>
-          </a:p>
-        </p:txBody>
-      </p:sp>
-      <p:sp>
-        <p:nvSpPr>
-          <p:cNvPr id="25" name="Text 22"/>
-          <p:cNvSpPr txBox="1"/>
-          <p:nvPr/>
-        </p:nvSpPr>
-        <p:spPr>
-          <a:xfrm>
-            <a:off x="548640" y="5212080"/>
+              <a:t>Every month we measure what the changes did to orders and return, then re-tune positions, deals, products and graphics — rinse and repeat to keep growing and maximizing your return</a:t>
+            </a:r>
+            <a:endParaRPr lang="en-US" sz="1200" dirty="0"/>
+          </a:p>
+        </p:txBody>
+      </p:sp>
+      <p:sp>
+        <p:nvSpPr>
+          <p:cNvPr id="21" name="Text 18"/>
+          <p:cNvSpPr txBox="1"/>
+          <p:nvPr/>
+        </p:nvSpPr>
+        <p:spPr>
+          <a:xfrm>
+            <a:off x="548640" y="5120640"/>
             <a:ext cx="6675120" cy="365760"/>
           </a:xfrm>
           <a:prstGeom prst="rect">
@@ -7610,7 +7468,7 @@
       </p:sp>
       <p:pic>
         <p:nvPicPr>
-          <p:cNvPr id="26" name="Image 1" descr="preencoded.png">    </p:cNvPr>
+          <p:cNvPr id="22" name="Image 1" descr="preencoded.png">    </p:cNvPr>
           <p:cNvPicPr>
             <a:picLocks noChangeAspect="1"/>
           </p:cNvPicPr>
@@ -7634,7 +7492,7 @@
       </p:pic>
       <p:sp>
         <p:nvSpPr>
-          <p:cNvPr id="27" name="Shape 23"/>
+          <p:cNvPr id="23" name="Shape 19"/>
           <p:cNvSpPr/>
           <p:nvPr/>
         </p:nvSpPr>
@@ -7661,7 +7519,7 @@
       </p:sp>
       <p:sp>
         <p:nvSpPr>
-          <p:cNvPr id="28" name="Text 24"/>
+          <p:cNvPr id="24" name="Text 20"/>
           <p:cNvSpPr txBox="1"/>
           <p:nvPr/>
         </p:nvSpPr>
@@ -7700,7 +7558,7 @@
       </p:sp>
       <p:sp>
         <p:nvSpPr>
-          <p:cNvPr id="29" name="Text 25"/>
+          <p:cNvPr id="25" name="Text 21"/>
           <p:cNvSpPr txBox="1"/>
           <p:nvPr/>
         </p:nvSpPr>
@@ -7739,7 +7597,7 @@
       </p:sp>
       <p:sp>
         <p:nvSpPr>
-          <p:cNvPr id="30" name="Text 26"/>
+          <p:cNvPr id="26" name="Text 22"/>
           <p:cNvSpPr txBox="1"/>
           <p:nvPr/>
         </p:nvSpPr>
@@ -7778,7 +7636,7 @@
       </p:sp>
       <p:sp>
         <p:nvSpPr>
-          <p:cNvPr id="31" name="Text 27"/>
+          <p:cNvPr id="27" name="Text 23"/>
           <p:cNvSpPr txBox="1"/>
           <p:nvPr/>
         </p:nvSpPr>
@@ -7817,7 +7675,7 @@
       </p:sp>
       <p:sp>
         <p:nvSpPr>
-          <p:cNvPr id="32" name="Text 28"/>
+          <p:cNvPr id="28" name="Text 24"/>
           <p:cNvSpPr txBox="1"/>
           <p:nvPr/>
         </p:nvSpPr>
@@ -7856,7 +7714,7 @@
       </p:sp>
       <p:sp>
         <p:nvSpPr>
-          <p:cNvPr id="33" name="Shape 29"/>
+          <p:cNvPr id="29" name="Shape 25"/>
           <p:cNvSpPr/>
           <p:nvPr/>
         </p:nvSpPr>
@@ -7879,7 +7737,7 @@
       </p:sp>
       <p:sp>
         <p:nvSpPr>
-          <p:cNvPr id="34" name="Text 30"/>
+          <p:cNvPr id="30" name="Text 26"/>
           <p:cNvSpPr txBox="1"/>
           <p:nvPr/>
         </p:nvSpPr>
@@ -7918,7 +7776,7 @@
       </p:sp>
       <p:sp>
         <p:nvSpPr>
-          <p:cNvPr id="35" name="Text 31"/>
+          <p:cNvPr id="31" name="Text 27"/>
           <p:cNvSpPr txBox="1"/>
           <p:nvPr/>
         </p:nvSpPr>
@@ -7957,7 +7815,7 @@
       </p:sp>
       <p:sp>
         <p:nvSpPr>
-          <p:cNvPr id="36" name="Text 32"/>
+          <p:cNvPr id="32" name="Text 28"/>
           <p:cNvSpPr txBox="1"/>
           <p:nvPr/>
         </p:nvSpPr>
@@ -7996,7 +7854,7 @@
       </p:sp>
       <p:sp>
         <p:nvSpPr>
-          <p:cNvPr id="37" name="Text 33"/>
+          <p:cNvPr id="33" name="Text 29"/>
           <p:cNvSpPr txBox="1"/>
           <p:nvPr/>
         </p:nvSpPr>
@@ -8035,7 +7893,7 @@
       </p:sp>
       <p:sp>
         <p:nvSpPr>
-          <p:cNvPr id="38" name="Text 34"/>
+          <p:cNvPr id="34" name="Text 30"/>
           <p:cNvSpPr txBox="1"/>
           <p:nvPr/>
         </p:nvSpPr>
@@ -8074,7 +7932,7 @@
       </p:sp>
       <p:sp>
         <p:nvSpPr>
-          <p:cNvPr id="39" name="Text 35"/>
+          <p:cNvPr id="35" name="Text 31"/>
           <p:cNvSpPr txBox="1"/>
           <p:nvPr/>
         </p:nvSpPr>
@@ -8113,7 +7971,7 @@
       </p:sp>
       <p:sp>
         <p:nvSpPr>
-          <p:cNvPr id="40" name="Text 36"/>
+          <p:cNvPr id="36" name="Text 32"/>
           <p:cNvSpPr txBox="1"/>
           <p:nvPr/>
         </p:nvSpPr>
@@ -8152,7 +8010,7 @@
       </p:sp>
       <p:sp>
         <p:nvSpPr>
-          <p:cNvPr id="41" name="Text 37"/>
+          <p:cNvPr id="37" name="Text 33"/>
           <p:cNvSpPr txBox="1"/>
           <p:nvPr/>
         </p:nvSpPr>
@@ -8191,7 +8049,7 @@
       </p:sp>
       <p:sp>
         <p:nvSpPr>
-          <p:cNvPr id="42" name="Text 38"/>
+          <p:cNvPr id="38" name="Text 34"/>
           <p:cNvSpPr txBox="1"/>
           <p:nvPr/>
         </p:nvSpPr>
@@ -8230,7 +8088,7 @@
       </p:sp>
       <p:sp>
         <p:nvSpPr>
-          <p:cNvPr id="43" name="Text 39"/>
+          <p:cNvPr id="39" name="Text 35"/>
           <p:cNvSpPr txBox="1"/>
           <p:nvPr/>
         </p:nvSpPr>

</xml_diff>

<commit_message>
Generalize section eyebrows, cover one-liner and slide titles
Eyebrows read "Single Platform Management · <section>" (or Multi-
Platform). The cover one-liner, solution title, scope title, case-study
title and next-steps subtitle no longer name the focus platform.

Co-Authored-By: Claude Fable 5.1 <noreply@anthropic.com>
Claude-Session: https://claude.ai/code/session_01RhvxWoxVegp3rGjZ4khBZo
</commit_message>
<xml_diff>
--- a/decks/Sparks-x-example-green-valley.pptx
+++ b/decks/Sparks-x-example-green-valley.pptx
@@ -2341,7 +2341,7 @@
                 <a:ea typeface="Calibri" pitchFamily="34" charset="-122"/>
                 <a:cs typeface="Calibri" pitchFamily="34" charset="-120"/>
               </a:rPr>
-              <a:t>We manage your Weedmaps, Leafly, Yelp, and Google listings and ads so your dispensary gets found, clicked, and ordered from.</a:t>
+              <a:t>We manage your listings and ads across every platform your customers use, so your dispensary gets found, clicked, and ordered from.</a:t>
             </a:r>
             <a:endParaRPr lang="en-US" sz="1600" dirty="0"/>
           </a:p>
@@ -6995,7 +6995,7 @@
                 <a:ea typeface="Calibri" pitchFamily="34" charset="-122"/>
                 <a:cs typeface="Calibri" pitchFamily="34" charset="-120"/>
               </a:rPr>
-              <a:t>Kickoff, a 30-day Weedmaps launch, then a monthly cycle of measure and optimize to keep growing Green Valley Dispensary's return.</a:t>
+              <a:t>Kickoff, a 30-day launch, then a monthly cycle of measure and optimize to keep growing Green Valley Dispensary's return.</a:t>
             </a:r>
             <a:endParaRPr lang="en-US" sz="1500" dirty="0"/>
           </a:p>
@@ -9205,7 +9205,7 @@
                 <a:ea typeface="Arial" pitchFamily="34" charset="-122"/>
                 <a:cs typeface="Arial" pitchFamily="34" charset="-120"/>
               </a:rPr>
-              <a:t>We run your Weedmaps listings and ads — and we're accountable for the orders.</a:t>
+              <a:t>We run your listings and ads — and we're accountable for the orders.</a:t>
             </a:r>
             <a:endParaRPr lang="en-US" sz="2400" dirty="0"/>
           </a:p>
@@ -11674,7 +11674,7 @@
                 <a:ea typeface="Calibri" pitchFamily="34" charset="-122"/>
                 <a:cs typeface="Calibri" pitchFamily="34" charset="-120"/>
               </a:rPr>
-              <a:t>WEEDMAPS MANAGEMENT  ·  AUDIT</a:t>
+              <a:t>MULTI-PLATFORM MANAGEMENT  ·  AUDIT</a:t>
             </a:r>
             <a:endParaRPr lang="en-US" sz="1100" dirty="0"/>
           </a:p>
@@ -12473,7 +12473,7 @@
                 <a:ea typeface="Calibri" pitchFamily="34" charset="-122"/>
                 <a:cs typeface="Calibri" pitchFamily="34" charset="-120"/>
               </a:rPr>
-              <a:t>WEEDMAPS MANAGEMENT  ·  SCOPE</a:t>
+              <a:t>MULTI-PLATFORM MANAGEMENT  ·  SCOPE</a:t>
             </a:r>
             <a:endParaRPr lang="en-US" sz="1100" dirty="0"/>
           </a:p>
@@ -12488,7 +12488,7 @@
         <p:spPr>
           <a:xfrm>
             <a:off x="548640" y="832104"/>
-            <a:ext cx="11094415" cy="853440"/>
+            <a:ext cx="11094415" cy="535940"/>
           </a:xfrm>
           <a:prstGeom prst="rect">
             <a:avLst/>
@@ -12504,7 +12504,7 @@
               <a:buNone/>
             </a:pPr>
             <a:r>
-              <a:rPr lang="en-US" sz="2400" b="1" dirty="0">
+              <a:rPr lang="en-US" sz="2800" b="1" dirty="0">
                 <a:solidFill>
                   <a:srgbClr val="DD5F13"/>
                 </a:solidFill>
@@ -12512,9 +12512,9 @@
                 <a:ea typeface="Arial" pitchFamily="34" charset="-122"/>
                 <a:cs typeface="Arial" pitchFamily="34" charset="-120"/>
               </a:rPr>
-              <a:t>What Sparks will manage on Weedmaps for Green Valley Dispensary</a:t>
-            </a:r>
-            <a:endParaRPr lang="en-US" sz="2400" dirty="0"/>
+              <a:t>What Sparks will manage for Green Valley Dispensary</a:t>
+            </a:r>
+            <a:endParaRPr lang="en-US" sz="2800" dirty="0"/>
           </a:p>
         </p:txBody>
       </p:sp>
@@ -12526,8 +12526,8 @@
         </p:nvSpPr>
         <p:spPr>
           <a:xfrm>
-            <a:off x="548640" y="1776984"/>
-            <a:ext cx="11094415" cy="603504"/>
+            <a:off x="548640" y="1459484"/>
+            <a:ext cx="11094415" cy="347472"/>
           </a:xfrm>
           <a:prstGeom prst="rect">
             <a:avLst/>
@@ -12551,7 +12551,7 @@
                 <a:ea typeface="Calibri" pitchFamily="34" charset="-122"/>
                 <a:cs typeface="Calibri" pitchFamily="34" charset="-120"/>
               </a:rPr>
-              <a:t>Everything below applies to every Green Valley Dispensary listing on Weedmaps, and to each platform you add to the engagement.</a:t>
+              <a:t>Everything below applies to every Green Valley Dispensary listing on Weedmaps, Leafly, Yelp, and Google.</a:t>
             </a:r>
             <a:endParaRPr lang="en-US" sz="1500" dirty="0"/>
           </a:p>
@@ -12565,12 +12565,12 @@
         </p:nvSpPr>
         <p:spPr>
           <a:xfrm>
-            <a:off x="548640" y="2654808"/>
-            <a:ext cx="5410048" cy="765048"/>
+            <a:off x="548640" y="2081276"/>
+            <a:ext cx="5410048" cy="777240"/>
           </a:xfrm>
           <a:prstGeom prst="roundRect">
             <a:avLst>
-              <a:gd name="adj" fmla="val 14343"/>
+              <a:gd name="adj" fmla="val 14118"/>
             </a:avLst>
           </a:prstGeom>
           <a:solidFill>
@@ -12592,7 +12592,7 @@
         </p:nvSpPr>
         <p:spPr>
           <a:xfrm>
-            <a:off x="777240" y="2845308"/>
+            <a:off x="777240" y="2277872"/>
             <a:ext cx="384048" cy="384048"/>
           </a:xfrm>
           <a:prstGeom prst="ellipse">
@@ -12617,7 +12617,7 @@
         </p:nvSpPr>
         <p:spPr>
           <a:xfrm>
-            <a:off x="777240" y="2845308"/>
+            <a:off x="777240" y="2277872"/>
             <a:ext cx="384048" cy="384048"/>
           </a:xfrm>
           <a:prstGeom prst="rect">
@@ -12656,7 +12656,7 @@
         </p:nvSpPr>
         <p:spPr>
           <a:xfrm>
-            <a:off x="1325880" y="2746248"/>
+            <a:off x="1325880" y="2172716"/>
             <a:ext cx="4404208" cy="274320"/>
           </a:xfrm>
           <a:prstGeom prst="rect">
@@ -12695,8 +12695,8 @@
         </p:nvSpPr>
         <p:spPr>
           <a:xfrm>
-            <a:off x="1325880" y="3020568"/>
-            <a:ext cx="4404208" cy="353568"/>
+            <a:off x="1325880" y="2447036"/>
+            <a:ext cx="4404208" cy="365760"/>
           </a:xfrm>
           <a:prstGeom prst="rect">
             <a:avLst/>
@@ -12734,12 +12734,12 @@
         </p:nvSpPr>
         <p:spPr>
           <a:xfrm>
-            <a:off x="6233008" y="2654808"/>
-            <a:ext cx="5410048" cy="765048"/>
+            <a:off x="6233008" y="2081276"/>
+            <a:ext cx="5410048" cy="777240"/>
           </a:xfrm>
           <a:prstGeom prst="roundRect">
             <a:avLst>
-              <a:gd name="adj" fmla="val 14343"/>
+              <a:gd name="adj" fmla="val 14118"/>
             </a:avLst>
           </a:prstGeom>
           <a:solidFill>
@@ -12761,7 +12761,7 @@
         </p:nvSpPr>
         <p:spPr>
           <a:xfrm>
-            <a:off x="6461608" y="2845308"/>
+            <a:off x="6461608" y="2277872"/>
             <a:ext cx="384048" cy="384048"/>
           </a:xfrm>
           <a:prstGeom prst="ellipse">
@@ -12786,7 +12786,7 @@
         </p:nvSpPr>
         <p:spPr>
           <a:xfrm>
-            <a:off x="6461608" y="2845308"/>
+            <a:off x="6461608" y="2277872"/>
             <a:ext cx="384048" cy="384048"/>
           </a:xfrm>
           <a:prstGeom prst="rect">
@@ -12825,7 +12825,7 @@
         </p:nvSpPr>
         <p:spPr>
           <a:xfrm>
-            <a:off x="7010248" y="2746248"/>
+            <a:off x="7010248" y="2172716"/>
             <a:ext cx="4404208" cy="274320"/>
           </a:xfrm>
           <a:prstGeom prst="rect">
@@ -12864,8 +12864,8 @@
         </p:nvSpPr>
         <p:spPr>
           <a:xfrm>
-            <a:off x="7010248" y="3020568"/>
-            <a:ext cx="4404208" cy="353568"/>
+            <a:off x="7010248" y="2447036"/>
+            <a:ext cx="4404208" cy="365760"/>
           </a:xfrm>
           <a:prstGeom prst="rect">
             <a:avLst/>
@@ -12903,12 +12903,12 @@
         </p:nvSpPr>
         <p:spPr>
           <a:xfrm>
-            <a:off x="548640" y="3557016"/>
-            <a:ext cx="5410048" cy="765048"/>
+            <a:off x="548640" y="2995676"/>
+            <a:ext cx="5410048" cy="777240"/>
           </a:xfrm>
           <a:prstGeom prst="roundRect">
             <a:avLst>
-              <a:gd name="adj" fmla="val 14343"/>
+              <a:gd name="adj" fmla="val 14118"/>
             </a:avLst>
           </a:prstGeom>
           <a:solidFill>
@@ -12930,7 +12930,7 @@
         </p:nvSpPr>
         <p:spPr>
           <a:xfrm>
-            <a:off x="777240" y="3747516"/>
+            <a:off x="777240" y="3192272"/>
             <a:ext cx="384048" cy="384048"/>
           </a:xfrm>
           <a:prstGeom prst="ellipse">
@@ -12955,7 +12955,7 @@
         </p:nvSpPr>
         <p:spPr>
           <a:xfrm>
-            <a:off x="777240" y="3747516"/>
+            <a:off x="777240" y="3192272"/>
             <a:ext cx="384048" cy="384048"/>
           </a:xfrm>
           <a:prstGeom prst="rect">
@@ -12994,7 +12994,7 @@
         </p:nvSpPr>
         <p:spPr>
           <a:xfrm>
-            <a:off x="1325880" y="3648456"/>
+            <a:off x="1325880" y="3087116"/>
             <a:ext cx="4404208" cy="274320"/>
           </a:xfrm>
           <a:prstGeom prst="rect">
@@ -13033,8 +13033,8 @@
         </p:nvSpPr>
         <p:spPr>
           <a:xfrm>
-            <a:off x="1325880" y="3922776"/>
-            <a:ext cx="4404208" cy="353568"/>
+            <a:off x="1325880" y="3361436"/>
+            <a:ext cx="4404208" cy="365760"/>
           </a:xfrm>
           <a:prstGeom prst="rect">
             <a:avLst/>
@@ -13072,12 +13072,12 @@
         </p:nvSpPr>
         <p:spPr>
           <a:xfrm>
-            <a:off x="6233008" y="3557016"/>
-            <a:ext cx="5410048" cy="765048"/>
+            <a:off x="6233008" y="2995676"/>
+            <a:ext cx="5410048" cy="777240"/>
           </a:xfrm>
           <a:prstGeom prst="roundRect">
             <a:avLst>
-              <a:gd name="adj" fmla="val 14343"/>
+              <a:gd name="adj" fmla="val 14118"/>
             </a:avLst>
           </a:prstGeom>
           <a:solidFill>
@@ -13099,7 +13099,7 @@
         </p:nvSpPr>
         <p:spPr>
           <a:xfrm>
-            <a:off x="6461608" y="3747516"/>
+            <a:off x="6461608" y="3192272"/>
             <a:ext cx="384048" cy="384048"/>
           </a:xfrm>
           <a:prstGeom prst="ellipse">
@@ -13124,7 +13124,7 @@
         </p:nvSpPr>
         <p:spPr>
           <a:xfrm>
-            <a:off x="6461608" y="3747516"/>
+            <a:off x="6461608" y="3192272"/>
             <a:ext cx="384048" cy="384048"/>
           </a:xfrm>
           <a:prstGeom prst="rect">
@@ -13163,7 +13163,7 @@
         </p:nvSpPr>
         <p:spPr>
           <a:xfrm>
-            <a:off x="7010248" y="3648456"/>
+            <a:off x="7010248" y="3087116"/>
             <a:ext cx="4404208" cy="274320"/>
           </a:xfrm>
           <a:prstGeom prst="rect">
@@ -13202,8 +13202,8 @@
         </p:nvSpPr>
         <p:spPr>
           <a:xfrm>
-            <a:off x="7010248" y="3922776"/>
-            <a:ext cx="4404208" cy="353568"/>
+            <a:off x="7010248" y="3361436"/>
+            <a:ext cx="4404208" cy="365760"/>
           </a:xfrm>
           <a:prstGeom prst="rect">
             <a:avLst/>
@@ -13241,12 +13241,12 @@
         </p:nvSpPr>
         <p:spPr>
           <a:xfrm>
-            <a:off x="548640" y="4459224"/>
-            <a:ext cx="5410048" cy="765048"/>
+            <a:off x="548640" y="3910076"/>
+            <a:ext cx="5410048" cy="777240"/>
           </a:xfrm>
           <a:prstGeom prst="roundRect">
             <a:avLst>
-              <a:gd name="adj" fmla="val 14343"/>
+              <a:gd name="adj" fmla="val 14118"/>
             </a:avLst>
           </a:prstGeom>
           <a:solidFill>
@@ -13268,7 +13268,7 @@
         </p:nvSpPr>
         <p:spPr>
           <a:xfrm>
-            <a:off x="777240" y="4649724"/>
+            <a:off x="777240" y="4106672"/>
             <a:ext cx="384048" cy="384048"/>
           </a:xfrm>
           <a:prstGeom prst="ellipse">
@@ -13293,7 +13293,7 @@
         </p:nvSpPr>
         <p:spPr>
           <a:xfrm>
-            <a:off x="777240" y="4649724"/>
+            <a:off x="777240" y="4106672"/>
             <a:ext cx="384048" cy="384048"/>
           </a:xfrm>
           <a:prstGeom prst="rect">
@@ -13332,7 +13332,7 @@
         </p:nvSpPr>
         <p:spPr>
           <a:xfrm>
-            <a:off x="1325880" y="4550664"/>
+            <a:off x="1325880" y="4001516"/>
             <a:ext cx="4404208" cy="274320"/>
           </a:xfrm>
           <a:prstGeom prst="rect">
@@ -13371,8 +13371,8 @@
         </p:nvSpPr>
         <p:spPr>
           <a:xfrm>
-            <a:off x="1325880" y="4824984"/>
-            <a:ext cx="4404208" cy="353568"/>
+            <a:off x="1325880" y="4275836"/>
+            <a:ext cx="4404208" cy="365760"/>
           </a:xfrm>
           <a:prstGeom prst="rect">
             <a:avLst/>
@@ -13410,12 +13410,12 @@
         </p:nvSpPr>
         <p:spPr>
           <a:xfrm>
-            <a:off x="6233008" y="4459224"/>
-            <a:ext cx="5410048" cy="765048"/>
+            <a:off x="6233008" y="3910076"/>
+            <a:ext cx="5410048" cy="777240"/>
           </a:xfrm>
           <a:prstGeom prst="roundRect">
             <a:avLst>
-              <a:gd name="adj" fmla="val 14343"/>
+              <a:gd name="adj" fmla="val 14118"/>
             </a:avLst>
           </a:prstGeom>
           <a:solidFill>
@@ -13437,7 +13437,7 @@
         </p:nvSpPr>
         <p:spPr>
           <a:xfrm>
-            <a:off x="6461608" y="4649724"/>
+            <a:off x="6461608" y="4106672"/>
             <a:ext cx="384048" cy="384048"/>
           </a:xfrm>
           <a:prstGeom prst="ellipse">
@@ -13462,7 +13462,7 @@
         </p:nvSpPr>
         <p:spPr>
           <a:xfrm>
-            <a:off x="6461608" y="4649724"/>
+            <a:off x="6461608" y="4106672"/>
             <a:ext cx="384048" cy="384048"/>
           </a:xfrm>
           <a:prstGeom prst="rect">
@@ -13501,7 +13501,7 @@
         </p:nvSpPr>
         <p:spPr>
           <a:xfrm>
-            <a:off x="7010248" y="4550664"/>
+            <a:off x="7010248" y="4001516"/>
             <a:ext cx="4404208" cy="274320"/>
           </a:xfrm>
           <a:prstGeom prst="rect">
@@ -13540,8 +13540,8 @@
         </p:nvSpPr>
         <p:spPr>
           <a:xfrm>
-            <a:off x="7010248" y="4824984"/>
-            <a:ext cx="4404208" cy="353568"/>
+            <a:off x="7010248" y="4275836"/>
+            <a:ext cx="4404208" cy="365760"/>
           </a:xfrm>
           <a:prstGeom prst="rect">
             <a:avLst/>
@@ -13579,12 +13579,12 @@
         </p:nvSpPr>
         <p:spPr>
           <a:xfrm>
-            <a:off x="548640" y="5361432"/>
-            <a:ext cx="5410048" cy="765048"/>
+            <a:off x="548640" y="4824476"/>
+            <a:ext cx="5410048" cy="777240"/>
           </a:xfrm>
           <a:prstGeom prst="roundRect">
             <a:avLst>
-              <a:gd name="adj" fmla="val 14343"/>
+              <a:gd name="adj" fmla="val 14118"/>
             </a:avLst>
           </a:prstGeom>
           <a:solidFill>
@@ -13606,7 +13606,7 @@
         </p:nvSpPr>
         <p:spPr>
           <a:xfrm>
-            <a:off x="777240" y="5551932"/>
+            <a:off x="777240" y="5021072"/>
             <a:ext cx="384048" cy="384048"/>
           </a:xfrm>
           <a:prstGeom prst="ellipse">
@@ -13631,7 +13631,7 @@
         </p:nvSpPr>
         <p:spPr>
           <a:xfrm>
-            <a:off x="777240" y="5551932"/>
+            <a:off x="777240" y="5021072"/>
             <a:ext cx="384048" cy="384048"/>
           </a:xfrm>
           <a:prstGeom prst="rect">
@@ -13670,7 +13670,7 @@
         </p:nvSpPr>
         <p:spPr>
           <a:xfrm>
-            <a:off x="1325880" y="5452872"/>
+            <a:off x="1325880" y="4915916"/>
             <a:ext cx="4404208" cy="274320"/>
           </a:xfrm>
           <a:prstGeom prst="rect">
@@ -13709,8 +13709,8 @@
         </p:nvSpPr>
         <p:spPr>
           <a:xfrm>
-            <a:off x="1325880" y="5727192"/>
-            <a:ext cx="4404208" cy="353568"/>
+            <a:off x="1325880" y="5190236"/>
+            <a:ext cx="4404208" cy="365760"/>
           </a:xfrm>
           <a:prstGeom prst="rect">
             <a:avLst/>
@@ -13748,12 +13748,12 @@
         </p:nvSpPr>
         <p:spPr>
           <a:xfrm>
-            <a:off x="6233008" y="5361432"/>
-            <a:ext cx="5410048" cy="765048"/>
+            <a:off x="6233008" y="4824476"/>
+            <a:ext cx="5410048" cy="777240"/>
           </a:xfrm>
           <a:prstGeom prst="roundRect">
             <a:avLst>
-              <a:gd name="adj" fmla="val 14343"/>
+              <a:gd name="adj" fmla="val 14118"/>
             </a:avLst>
           </a:prstGeom>
           <a:solidFill>
@@ -13775,7 +13775,7 @@
         </p:nvSpPr>
         <p:spPr>
           <a:xfrm>
-            <a:off x="6461608" y="5551932"/>
+            <a:off x="6461608" y="5021072"/>
             <a:ext cx="384048" cy="384048"/>
           </a:xfrm>
           <a:prstGeom prst="ellipse">
@@ -13800,7 +13800,7 @@
         </p:nvSpPr>
         <p:spPr>
           <a:xfrm>
-            <a:off x="6461608" y="5551932"/>
+            <a:off x="6461608" y="5021072"/>
             <a:ext cx="384048" cy="384048"/>
           </a:xfrm>
           <a:prstGeom prst="rect">
@@ -13839,7 +13839,7 @@
         </p:nvSpPr>
         <p:spPr>
           <a:xfrm>
-            <a:off x="7010248" y="5452872"/>
+            <a:off x="7010248" y="4915916"/>
             <a:ext cx="4404208" cy="274320"/>
           </a:xfrm>
           <a:prstGeom prst="rect">
@@ -13878,8 +13878,8 @@
         </p:nvSpPr>
         <p:spPr>
           <a:xfrm>
-            <a:off x="7010248" y="5727192"/>
-            <a:ext cx="4404208" cy="353568"/>
+            <a:off x="7010248" y="5190236"/>
+            <a:ext cx="4404208" cy="365760"/>
           </a:xfrm>
           <a:prstGeom prst="rect">
             <a:avLst/>
@@ -14122,7 +14122,7 @@
                 <a:ea typeface="Calibri" pitchFamily="34" charset="-122"/>
                 <a:cs typeface="Calibri" pitchFamily="34" charset="-120"/>
               </a:rPr>
-              <a:t>WEEDMAPS MANAGEMENT  ·  RESULTS</a:t>
+              <a:t>MULTI-PLATFORM MANAGEMENT  ·  RESULTS</a:t>
             </a:r>
             <a:endParaRPr lang="en-US" sz="1100" dirty="0"/>
           </a:p>
@@ -14832,7 +14832,7 @@
                 <a:ea typeface="Calibri" pitchFamily="34" charset="-122"/>
                 <a:cs typeface="Calibri" pitchFamily="34" charset="-120"/>
               </a:rPr>
-              <a:t>WEEDMAPS MANAGEMENT  ·  PROOF</a:t>
+              <a:t>MULTI-PLATFORM MANAGEMENT  ·  PROOF</a:t>
             </a:r>
             <a:endParaRPr lang="en-US" sz="1100" dirty="0"/>
           </a:p>
@@ -14871,7 +14871,7 @@
                 <a:ea typeface="Arial" pitchFamily="34" charset="-122"/>
                 <a:cs typeface="Arial" pitchFamily="34" charset="-120"/>
               </a:rPr>
-              <a:t>Weedmaps case studies</a:t>
+              <a:t>Case studies</a:t>
             </a:r>
             <a:endParaRPr lang="en-US" sz="3400" dirty="0"/>
           </a:p>
@@ -16019,7 +16019,7 @@
                 <a:ea typeface="Calibri" pitchFamily="34" charset="-122"/>
                 <a:cs typeface="Calibri" pitchFamily="34" charset="-120"/>
               </a:rPr>
-              <a:t>WEEDMAPS MANAGEMENT  ·  INVESTMENT</a:t>
+              <a:t>MULTI-PLATFORM MANAGEMENT  ·  INVESTMENT</a:t>
             </a:r>
             <a:endParaRPr lang="en-US" sz="1100" dirty="0"/>
           </a:p>

</xml_diff>

<commit_message>
Rename the investment slide to Proposal
Co-Authored-By: Claude Fable 5.1 <noreply@anthropic.com>
Claude-Session: https://claude.ai/code/session_01RhvxWoxVegp3rGjZ4khBZo
</commit_message>
<xml_diff>
--- a/decks/Sparks-x-example-green-valley.pptx
+++ b/decks/Sparks-x-example-green-valley.pptx
@@ -16019,7 +16019,7 @@
                 <a:ea typeface="Calibri" pitchFamily="34" charset="-122"/>
                 <a:cs typeface="Calibri" pitchFamily="34" charset="-120"/>
               </a:rPr>
-              <a:t>MULTI-PLATFORM MANAGEMENT  ·  INVESTMENT</a:t>
+              <a:t>MULTI-PLATFORM MANAGEMENT  ·  PROPOSAL</a:t>
             </a:r>
             <a:endParaRPr lang="en-US" sz="1100" dirty="0"/>
           </a:p>
@@ -16058,7 +16058,7 @@
                 <a:ea typeface="Arial" pitchFamily="34" charset="-122"/>
                 <a:cs typeface="Arial" pitchFamily="34" charset="-120"/>
               </a:rPr>
-              <a:t>Investment</a:t>
+              <a:t>Proposal</a:t>
             </a:r>
             <a:endParaRPr lang="en-US" sz="3400" dirty="0"/>
           </a:p>

</xml_diff>

<commit_message>
Kickoff step: sign agreement, share logins, then meet the team
Co-Authored-By: Claude Fable 5.1 <noreply@anthropic.com>
Claude-Session: https://claude.ai/code/session_01RhvxWoxVegp3rGjZ4khBZo
</commit_message>
<xml_diff>
--- a/decks/Sparks-x-example-green-valley.pptx
+++ b/decks/Sparks-x-example-green-valley.pptx
@@ -955,7 +955,7 @@
           <a:p>
             <a:r>
               <a:rPr lang="en-US" dirty="0"/>
-              <a:t>Walk the process: kickoff (align on goals, info, deals, menu; connect every platform; set up the analytics dashboard), a 30-day launch, then from day 31 every month we measure what the changes did to the return and re-tune positions, deals, products and graphics — rinse and repeat to keep growing it. Close: restate the guarantee, propose a kickoff date, and ask for Weedmaps admin access. Add-ons are $495/mo each. Can be switched on at any time.</a:t>
+              <a:t>Walk the process: kickoff (sign the agency agreement, collect logins, then meet the team to align on goals, deals, menu; connect every platform; set up the analytics dashboard), a 30-day launch, then from day 31 every month we measure what the changes did to the return and re-tune positions, deals, products and graphics — rinse and repeat to keep growing it. Close: restate the guarantee, propose a kickoff date, and ask for Weedmaps admin access. Add-ons are $495/mo each. Can be switched on at any time.</a:t>
             </a:r>
             <a:endParaRPr lang="en-US" dirty="0"/>
           </a:p>
@@ -7137,7 +7137,7 @@
                 <a:ea typeface="Calibri" pitchFamily="34" charset="-122"/>
                 <a:cs typeface="Calibri" pitchFamily="34" charset="-120"/>
               </a:rPr>
-              <a:t>Meet with your team to align on goals, account info, deals, menu and brand assets; connect every platform; set up your analytics dashboard</a:t>
+              <a:t>Sign the agency agreement and share your logins, then meet with your team to align on goals, deals, menu and assets; we connect every platform and set up your dashboard</a:t>
             </a:r>
             <a:endParaRPr lang="en-US" sz="1200" dirty="0"/>
           </a:p>

</xml_diff>